<commit_message>
Improve slide visuals and narrative flow for investor pitch deck
Update pitch deck assets and script to refine image zones, ensure no overlaps, and enhance narrative tone.

Replit-Commit-Author: Agent
Replit-Commit-Session-Id: 85f09f3c-352d-446d-b98e-3f307c26fc5a
Replit-Commit-Checkpoint-Type: full_checkpoint
Replit-Commit-Event-Id: a5811f86-af9c-49aa-8948-0a8b14c7f7fb
Replit-Commit-Screenshot-Url: https://storage.googleapis.com/screenshot-production-us-central1/3bd53afc-ff4f-401b-9e3d-b367791ef629/85f09f3c-352d-446d-b98e-3f307c26fc5a/v9XelxY
Replit-Helium-Checkpoint-Created: true
</commit_message>
<xml_diff>
--- a/attached_assets/VaughnMartin-Investor-Pitch-Deck-v10.pptx
+++ b/attached_assets/VaughnMartin-Investor-Pitch-Deck-v10.pptx
@@ -3159,15 +3159,15 @@
         </p:nvPicPr>
         <p:blipFill>
           <a:blip r:embed="rId2"/>
-          <a:srcRect l="25816" r="25816"/>
+          <a:srcRect l="23092" r="23092"/>
           <a:stretch>
             <a:fillRect/>
           </a:stretch>
         </p:blipFill>
         <p:spPr>
           <a:xfrm>
-            <a:off x="6766560" y="73152"/>
-            <a:ext cx="5330952" cy="6199632"/>
+            <a:off x="6492240" y="512064"/>
+            <a:ext cx="5458968" cy="5705856"/>
           </a:xfrm>
           <a:prstGeom prst="rect">
             <a:avLst/>
@@ -3182,17 +3182,17 @@
         </p:nvSpPr>
         <p:spPr>
           <a:xfrm>
-            <a:off x="6400800" y="73152"/>
-            <a:ext cx="1645920" cy="6199632"/>
-          </a:xfrm>
-          <a:prstGeom prst="rect">
-            <a:avLst/>
-          </a:prstGeom>
-          <a:solidFill>
-            <a:srgbClr val="0A0F2E"/>
-          </a:solidFill>
-          <a:ln>
-            <a:noFill/>
+            <a:off x="6492240" y="512064"/>
+            <a:ext cx="5458968" cy="5705856"/>
+          </a:xfrm>
+          <a:prstGeom prst="rect">
+            <a:avLst/>
+          </a:prstGeom>
+          <a:noFill/>
+          <a:ln w="15240">
+            <a:solidFill>
+              <a:srgbClr val="C9A84C"/>
+            </a:solidFill>
           </a:ln>
         </p:spPr>
         <p:style>
@@ -3225,17 +3225,17 @@
         </p:nvSpPr>
         <p:spPr>
           <a:xfrm>
-            <a:off x="6766560" y="73152"/>
-            <a:ext cx="5330952" cy="6199632"/>
-          </a:xfrm>
-          <a:prstGeom prst="rect">
-            <a:avLst/>
-          </a:prstGeom>
-          <a:noFill/>
-          <a:ln w="10160">
-            <a:solidFill>
-              <a:srgbClr val="283458"/>
-            </a:solidFill>
+            <a:off x="6492240" y="5980176"/>
+            <a:ext cx="5458968" cy="237744"/>
+          </a:xfrm>
+          <a:prstGeom prst="rect">
+            <a:avLst/>
+          </a:prstGeom>
+          <a:solidFill>
+            <a:srgbClr val="060A1E"/>
+          </a:solidFill>
+          <a:ln>
+            <a:noFill/>
           </a:ln>
         </p:spPr>
         <p:style>
@@ -3260,9 +3260,87 @@
           </a:p>
         </p:txBody>
       </p:sp>
+      <p:sp>
+        <p:nvSpPr>
+          <p:cNvPr id="6" name="TextBox 5"/>
+          <p:cNvSpPr txBox="1"/>
+          <p:nvPr/>
+        </p:nvSpPr>
+        <p:spPr>
+          <a:xfrm>
+            <a:off x="6583680" y="6043676"/>
+            <a:ext cx="5276088" cy="237744"/>
+          </a:xfrm>
+          <a:prstGeom prst="rect">
+            <a:avLst/>
+          </a:prstGeom>
+          <a:noFill/>
+        </p:spPr>
+        <p:txBody>
+          <a:bodyPr wrap="square">
+            <a:spAutoFit/>
+          </a:bodyPr>
+          <a:lstStyle/>
+          <a:p>
+            <a:pPr algn="l"/>
+            <a:r>
+              <a:rPr sz="800" b="1" i="0">
+                <a:solidFill>
+                  <a:srgbClr val="C9A84C"/>
+                </a:solidFill>
+                <a:latin typeface="Barlow Condensed"/>
+              </a:rPr>
+              <a:t>COMMAND TOWER · LIVE SIGNAL MONITORING · PRODUCTION</a:t>
+            </a:r>
+          </a:p>
+        </p:txBody>
+      </p:sp>
+      <p:sp>
+        <p:nvSpPr>
+          <p:cNvPr id="7" name="Rectangle 6"/>
+          <p:cNvSpPr/>
+          <p:nvPr/>
+        </p:nvSpPr>
+        <p:spPr>
+          <a:xfrm>
+            <a:off x="6364224" y="512064"/>
+            <a:ext cx="12700" cy="5705856"/>
+          </a:xfrm>
+          <a:prstGeom prst="rect">
+            <a:avLst/>
+          </a:prstGeom>
+          <a:solidFill>
+            <a:srgbClr val="C9A84C"/>
+          </a:solidFill>
+          <a:ln>
+            <a:noFill/>
+          </a:ln>
+        </p:spPr>
+        <p:style>
+          <a:lnRef idx="1">
+            <a:schemeClr val="accent1"/>
+          </a:lnRef>
+          <a:fillRef idx="3">
+            <a:schemeClr val="accent1"/>
+          </a:fillRef>
+          <a:effectRef idx="2">
+            <a:schemeClr val="accent1"/>
+          </a:effectRef>
+          <a:fontRef idx="minor">
+            <a:schemeClr val="lt1"/>
+          </a:fontRef>
+        </p:style>
+        <p:txBody>
+          <a:bodyPr rtlCol="0" anchor="ctr"/>
+          <a:lstStyle/>
+          <a:p>
+            <a:pPr algn="ctr"/>
+          </a:p>
+        </p:txBody>
+      </p:sp>
       <p:pic>
         <p:nvPicPr>
-          <p:cNvPr id="6" name="Picture 5" descr="vm-logo-hd.png"/>
+          <p:cNvPr id="8" name="Picture 7" descr="vm-logo-hd.png"/>
           <p:cNvPicPr>
             <a:picLocks noChangeAspect="1"/>
           </p:cNvPicPr>
@@ -3276,8 +3354,8 @@
         </p:blipFill>
         <p:spPr>
           <a:xfrm>
-            <a:off x="420624" y="420624"/>
-            <a:ext cx="2286000" cy="613833"/>
+            <a:off x="384048" y="457200"/>
+            <a:ext cx="2377440" cy="638410"/>
           </a:xfrm>
           <a:prstGeom prst="rect">
             <a:avLst/>
@@ -3286,14 +3364,14 @@
       </p:pic>
       <p:sp>
         <p:nvSpPr>
-          <p:cNvPr id="7" name="TextBox 6"/>
-          <p:cNvSpPr txBox="1"/>
-          <p:nvPr/>
-        </p:nvSpPr>
-        <p:spPr>
-          <a:xfrm>
-            <a:off x="420624" y="987552"/>
-            <a:ext cx="5943600" cy="203200"/>
+          <p:cNvPr id="9" name="TextBox 8"/>
+          <p:cNvSpPr txBox="1"/>
+          <p:nvPr/>
+        </p:nvSpPr>
+        <p:spPr>
+          <a:xfrm>
+            <a:off x="384048" y="1115568"/>
+            <a:ext cx="5760720" cy="203200"/>
           </a:xfrm>
           <a:prstGeom prst="rect">
             <a:avLst/>
@@ -3321,14 +3399,14 @@
       </p:sp>
       <p:sp>
         <p:nvSpPr>
-          <p:cNvPr id="8" name="TextBox 7"/>
-          <p:cNvSpPr txBox="1"/>
-          <p:nvPr/>
-        </p:nvSpPr>
-        <p:spPr>
-          <a:xfrm>
-            <a:off x="420624" y="1316736"/>
-            <a:ext cx="6126480" cy="2377440"/>
+          <p:cNvPr id="10" name="TextBox 9"/>
+          <p:cNvSpPr txBox="1"/>
+          <p:nvPr/>
+        </p:nvSpPr>
+        <p:spPr>
+          <a:xfrm>
+            <a:off x="384048" y="1408176"/>
+            <a:ext cx="5760720" cy="2084831"/>
           </a:xfrm>
           <a:prstGeom prst="rect">
             <a:avLst/>
@@ -3343,27 +3421,28 @@
           <a:p>
             <a:pPr algn="l"/>
             <a:r>
-              <a:rPr sz="3400" b="1">
+              <a:rPr sz="3800" b="1">
                 <a:solidFill>
                   <a:srgbClr val="FFFFFF"/>
                 </a:solidFill>
                 <a:latin typeface="Barlow Condensed"/>
               </a:rPr>
-              <a:t>When a strategic trigger fires—are you executing in 12 minutes or organizing from scratch?</a:t>
-            </a:r>
-          </a:p>
-        </p:txBody>
-      </p:sp>
-      <p:sp>
-        <p:nvSpPr>
-          <p:cNvPr id="9" name="TextBox 8"/>
-          <p:cNvSpPr txBox="1"/>
-          <p:nvPr/>
-        </p:nvSpPr>
-        <p:spPr>
-          <a:xfrm>
-            <a:off x="420624" y="3767328"/>
-            <a:ext cx="5943600" cy="457200"/>
+              <a:t>The response is ready
+before the trigger fires.</a:t>
+            </a:r>
+          </a:p>
+        </p:txBody>
+      </p:sp>
+      <p:sp>
+        <p:nvSpPr>
+          <p:cNvPr id="11" name="TextBox 10"/>
+          <p:cNvSpPr txBox="1"/>
+          <p:nvPr/>
+        </p:nvSpPr>
+        <p:spPr>
+          <a:xfrm>
+            <a:off x="384048" y="3584448"/>
+            <a:ext cx="5760720" cy="804672"/>
           </a:xfrm>
           <a:prstGeom prst="rect">
             <a:avLst/>
@@ -3378,27 +3457,28 @@
           <a:p>
             <a:pPr algn="l"/>
             <a:r>
-              <a:rPr sz="1600" b="0" i="1">
+              <a:rPr sz="1400" b="0" i="0">
                 <a:solidFill>
                   <a:srgbClr val="99A5BB"/>
                 </a:solidFill>
                 <a:latin typeface="Barlow Condensed"/>
               </a:rPr>
-              <a:t>Signal advantage before execution advantage.</a:t>
-            </a:r>
-          </a:p>
-        </p:txBody>
-      </p:sp>
-      <p:sp>
-        <p:nvSpPr>
-          <p:cNvPr id="10" name="Rectangle 9"/>
+              <a:t>Every enterprise plans to respond. VaughnMartin ensures
+the response is already staged when the moment arrives.</a:t>
+            </a:r>
+          </a:p>
+        </p:txBody>
+      </p:sp>
+      <p:sp>
+        <p:nvSpPr>
+          <p:cNvPr id="12" name="Rectangle 11"/>
           <p:cNvSpPr/>
           <p:nvPr/>
         </p:nvSpPr>
         <p:spPr>
           <a:xfrm>
-            <a:off x="420624" y="4407408"/>
-            <a:ext cx="5120640" cy="438912"/>
+            <a:off x="384048" y="4553712"/>
+            <a:ext cx="5760720" cy="420624"/>
           </a:xfrm>
           <a:prstGeom prst="rect">
             <a:avLst/>
@@ -3436,14 +3516,14 @@
       </p:sp>
       <p:sp>
         <p:nvSpPr>
-          <p:cNvPr id="11" name="TextBox 10"/>
-          <p:cNvSpPr txBox="1"/>
-          <p:nvPr/>
-        </p:nvSpPr>
-        <p:spPr>
-          <a:xfrm>
-            <a:off x="512064" y="4509008"/>
-            <a:ext cx="4937760" cy="365760"/>
+          <p:cNvPr id="13" name="TextBox 12"/>
+          <p:cNvSpPr txBox="1"/>
+          <p:nvPr/>
+        </p:nvSpPr>
+        <p:spPr>
+          <a:xfrm>
+            <a:off x="493776" y="4642612"/>
+            <a:ext cx="5577840" cy="365760"/>
           </a:xfrm>
           <a:prstGeom prst="rect">
             <a:avLst/>
@@ -3458,27 +3538,27 @@
           <a:p>
             <a:pPr algn="l"/>
             <a:r>
-              <a:rPr sz="1300" b="1" i="0">
+              <a:rPr sz="1200" b="1" i="0">
                 <a:solidFill>
                   <a:srgbClr val="C9A84C"/>
                 </a:solidFill>
                 <a:latin typeface="Barlow Condensed"/>
               </a:rPr>
-              <a:t>Activist Investor · 91%</a:t>
-            </a:r>
-          </a:p>
-        </p:txBody>
-      </p:sp>
-      <p:sp>
-        <p:nvSpPr>
-          <p:cNvPr id="12" name="Rectangle 11"/>
+              <a:t>Activist Investor  ·  91% confidence</a:t>
+            </a:r>
+          </a:p>
+        </p:txBody>
+      </p:sp>
+      <p:sp>
+        <p:nvSpPr>
+          <p:cNvPr id="14" name="Rectangle 13"/>
           <p:cNvSpPr/>
           <p:nvPr/>
         </p:nvSpPr>
         <p:spPr>
           <a:xfrm>
-            <a:off x="420624" y="4974336"/>
-            <a:ext cx="5120640" cy="438912"/>
+            <a:off x="384048" y="5102352"/>
+            <a:ext cx="5760720" cy="420624"/>
           </a:xfrm>
           <a:prstGeom prst="rect">
             <a:avLst/>
@@ -3516,14 +3596,14 @@
       </p:sp>
       <p:sp>
         <p:nvSpPr>
-          <p:cNvPr id="13" name="TextBox 12"/>
-          <p:cNvSpPr txBox="1"/>
-          <p:nvPr/>
-        </p:nvSpPr>
-        <p:spPr>
-          <a:xfrm>
-            <a:off x="512064" y="5075936"/>
-            <a:ext cx="4937760" cy="365760"/>
+          <p:cNvPr id="15" name="TextBox 14"/>
+          <p:cNvSpPr txBox="1"/>
+          <p:nvPr/>
+        </p:nvSpPr>
+        <p:spPr>
+          <a:xfrm>
+            <a:off x="493776" y="5191252"/>
+            <a:ext cx="5577840" cy="365760"/>
           </a:xfrm>
           <a:prstGeom prst="rect">
             <a:avLst/>
@@ -3538,27 +3618,27 @@
           <a:p>
             <a:pPr algn="l"/>
             <a:r>
-              <a:rPr sz="1300" b="1" i="0">
+              <a:rPr sz="1200" b="1" i="0">
                 <a:solidFill>
                   <a:srgbClr val="C9A84C"/>
                 </a:solidFill>
                 <a:latin typeface="Barlow Condensed"/>
               </a:rPr>
-              <a:t>Ransomware · 95%</a:t>
-            </a:r>
-          </a:p>
-        </p:txBody>
-      </p:sp>
-      <p:sp>
-        <p:nvSpPr>
-          <p:cNvPr id="14" name="Rectangle 13"/>
+              <a:t>Ransomware  ·  95% confidence</a:t>
+            </a:r>
+          </a:p>
+        </p:txBody>
+      </p:sp>
+      <p:sp>
+        <p:nvSpPr>
+          <p:cNvPr id="16" name="Rectangle 15"/>
           <p:cNvSpPr/>
           <p:nvPr/>
         </p:nvSpPr>
         <p:spPr>
           <a:xfrm>
-            <a:off x="420624" y="5541264"/>
-            <a:ext cx="5120640" cy="438912"/>
+            <a:off x="384048" y="5650992"/>
+            <a:ext cx="5760720" cy="420624"/>
           </a:xfrm>
           <a:prstGeom prst="rect">
             <a:avLst/>
@@ -3596,14 +3676,14 @@
       </p:sp>
       <p:sp>
         <p:nvSpPr>
-          <p:cNvPr id="15" name="TextBox 14"/>
-          <p:cNvSpPr txBox="1"/>
-          <p:nvPr/>
-        </p:nvSpPr>
-        <p:spPr>
-          <a:xfrm>
-            <a:off x="512064" y="5642864"/>
-            <a:ext cx="4937760" cy="365760"/>
+          <p:cNvPr id="17" name="TextBox 16"/>
+          <p:cNvSpPr txBox="1"/>
+          <p:nvPr/>
+        </p:nvSpPr>
+        <p:spPr>
+          <a:xfrm>
+            <a:off x="493776" y="5739892"/>
+            <a:ext cx="5577840" cy="365760"/>
           </a:xfrm>
           <a:prstGeom prst="rect">
             <a:avLst/>
@@ -3618,33 +3698,33 @@
           <a:p>
             <a:pPr algn="l"/>
             <a:r>
-              <a:rPr sz="1300" b="1" i="0">
+              <a:rPr sz="1200" b="1" i="0">
                 <a:solidFill>
                   <a:srgbClr val="C9A84C"/>
                 </a:solidFill>
                 <a:latin typeface="Barlow Condensed"/>
               </a:rPr>
-              <a:t>Regulatory · 87%</a:t>
-            </a:r>
-          </a:p>
-        </p:txBody>
-      </p:sp>
-      <p:sp>
-        <p:nvSpPr>
-          <p:cNvPr id="16" name="Rectangle 15"/>
+              <a:t>Regulatory Inquiry  ·  87% confidence</a:t>
+            </a:r>
+          </a:p>
+        </p:txBody>
+      </p:sp>
+      <p:sp>
+        <p:nvSpPr>
+          <p:cNvPr id="18" name="Rectangle 17"/>
           <p:cNvSpPr/>
           <p:nvPr/>
         </p:nvSpPr>
         <p:spPr>
           <a:xfrm>
-            <a:off x="0" y="6291072"/>
-            <a:ext cx="12191695" cy="502920"/>
+            <a:off x="0" y="6254496"/>
+            <a:ext cx="12191695" cy="475488"/>
           </a:xfrm>
           <a:prstGeom prst="rect">
             <a:avLst/>
           </a:prstGeom>
           <a:solidFill>
-            <a:srgbClr val="080A1C"/>
+            <a:srgbClr val="060818"/>
           </a:solidFill>
           <a:ln>
             <a:noFill/>
@@ -3674,13 +3754,13 @@
       </p:sp>
       <p:sp>
         <p:nvSpPr>
-          <p:cNvPr id="17" name="TextBox 16"/>
-          <p:cNvSpPr txBox="1"/>
-          <p:nvPr/>
-        </p:nvSpPr>
-        <p:spPr>
-          <a:xfrm>
-            <a:off x="457200" y="6345936"/>
+          <p:cNvPr id="19" name="TextBox 18"/>
+          <p:cNvSpPr txBox="1"/>
+          <p:nvPr/>
+        </p:nvSpPr>
+        <p:spPr>
+          <a:xfrm>
+            <a:off x="457200" y="6318504"/>
             <a:ext cx="11274552" cy="402336"/>
           </a:xfrm>
           <a:prstGeom prst="rect">
@@ -3696,20 +3776,20 @@
           <a:p>
             <a:pPr algn="ctr"/>
             <a:r>
-              <a:rPr sz="1300" b="1" i="0">
+              <a:rPr sz="1200" b="1" i="0">
                 <a:solidFill>
                   <a:srgbClr val="C9A84C"/>
                 </a:solidFill>
                 <a:latin typeface="Barlow Condensed"/>
               </a:rPr>
-              <a:t>AI monitors continuously.     Executives authorize decisively.</a:t>
-            </a:r>
-          </a:p>
-        </p:txBody>
-      </p:sp>
-      <p:sp>
-        <p:nvSpPr>
-          <p:cNvPr id="18" name="TextBox 17"/>
+              <a:t>AI monitors continuously.   Executives authorize decisively.   Teams execute.</a:t>
+            </a:r>
+          </a:p>
+        </p:txBody>
+      </p:sp>
+      <p:sp>
+        <p:nvSpPr>
+          <p:cNvPr id="20" name="TextBox 19"/>
           <p:cNvSpPr txBox="1"/>
           <p:nvPr/>
         </p:nvSpPr>
@@ -3827,8 +3907,8 @@
         </p:blipFill>
         <p:spPr>
           <a:xfrm>
-            <a:off x="420624" y="420624"/>
-            <a:ext cx="1828800" cy="491066"/>
+            <a:off x="329184" y="457200"/>
+            <a:ext cx="1664208" cy="446887"/>
           </a:xfrm>
           <a:prstGeom prst="rect">
             <a:avLst/>
@@ -3843,7 +3923,7 @@
         </p:nvSpPr>
         <p:spPr>
           <a:xfrm>
-            <a:off x="2542032" y="420624"/>
+            <a:off x="2176272" y="512064"/>
             <a:ext cx="10972800" cy="203200"/>
           </a:xfrm>
           <a:prstGeom prst="rect">
@@ -3878,8 +3958,8 @@
         </p:nvSpPr>
         <p:spPr>
           <a:xfrm>
-            <a:off x="2542032" y="676656"/>
-            <a:ext cx="8924544" cy="877824"/>
+            <a:off x="329184" y="950976"/>
+            <a:ext cx="8686800" cy="731520"/>
           </a:xfrm>
           <a:prstGeom prst="rect">
             <a:avLst/>
@@ -3913,7 +3993,7 @@
         </p:nvSpPr>
         <p:spPr>
           <a:xfrm>
-            <a:off x="329184" y="1664208"/>
+            <a:off x="329184" y="1737360"/>
             <a:ext cx="11530584" cy="19050"/>
           </a:xfrm>
           <a:prstGeom prst="rect">
@@ -3956,8 +4036,8 @@
         </p:nvSpPr>
         <p:spPr>
           <a:xfrm>
-            <a:off x="329184" y="1810512"/>
-            <a:ext cx="1719072" cy="1170432"/>
+            <a:off x="329184" y="1883664"/>
+            <a:ext cx="1810512" cy="1170432"/>
           </a:xfrm>
           <a:prstGeom prst="rect">
             <a:avLst/>
@@ -3999,8 +4079,8 @@
         </p:nvSpPr>
         <p:spPr>
           <a:xfrm>
-            <a:off x="329184" y="1865376"/>
-            <a:ext cx="1719072" cy="603504"/>
+            <a:off x="329184" y="1938528"/>
+            <a:ext cx="1810512" cy="621792"/>
           </a:xfrm>
           <a:prstGeom prst="rect">
             <a:avLst/>
@@ -4034,8 +4114,8 @@
         </p:nvSpPr>
         <p:spPr>
           <a:xfrm>
-            <a:off x="329184" y="2468880"/>
-            <a:ext cx="1719072" cy="493776"/>
+            <a:off x="329184" y="2542032"/>
+            <a:ext cx="1810512" cy="475488"/>
           </a:xfrm>
           <a:prstGeom prst="rect">
             <a:avLst/>
@@ -4070,8 +4150,8 @@
         </p:nvSpPr>
         <p:spPr>
           <a:xfrm>
-            <a:off x="2194560" y="1810512"/>
-            <a:ext cx="1719072" cy="1170432"/>
+            <a:off x="2249424" y="1883664"/>
+            <a:ext cx="1810512" cy="1170432"/>
           </a:xfrm>
           <a:prstGeom prst="rect">
             <a:avLst/>
@@ -4113,8 +4193,8 @@
         </p:nvSpPr>
         <p:spPr>
           <a:xfrm>
-            <a:off x="2194560" y="1865376"/>
-            <a:ext cx="1719072" cy="603504"/>
+            <a:off x="2249424" y="1938528"/>
+            <a:ext cx="1810512" cy="621792"/>
           </a:xfrm>
           <a:prstGeom prst="rect">
             <a:avLst/>
@@ -4148,8 +4228,8 @@
         </p:nvSpPr>
         <p:spPr>
           <a:xfrm>
-            <a:off x="2194560" y="2468880"/>
-            <a:ext cx="1719072" cy="493776"/>
+            <a:off x="2249424" y="2542032"/>
+            <a:ext cx="1810512" cy="475488"/>
           </a:xfrm>
           <a:prstGeom prst="rect">
             <a:avLst/>
@@ -4184,8 +4264,8 @@
         </p:nvSpPr>
         <p:spPr>
           <a:xfrm>
-            <a:off x="4059936" y="1810512"/>
-            <a:ext cx="1719072" cy="1170432"/>
+            <a:off x="4169664" y="1883664"/>
+            <a:ext cx="1810512" cy="1170432"/>
           </a:xfrm>
           <a:prstGeom prst="rect">
             <a:avLst/>
@@ -4227,8 +4307,8 @@
         </p:nvSpPr>
         <p:spPr>
           <a:xfrm>
-            <a:off x="4059936" y="1865376"/>
-            <a:ext cx="1719072" cy="603504"/>
+            <a:off x="4169664" y="1938528"/>
+            <a:ext cx="1810512" cy="621792"/>
           </a:xfrm>
           <a:prstGeom prst="rect">
             <a:avLst/>
@@ -4262,8 +4342,8 @@
         </p:nvSpPr>
         <p:spPr>
           <a:xfrm>
-            <a:off x="4059936" y="2468880"/>
-            <a:ext cx="1719072" cy="493776"/>
+            <a:off x="4169664" y="2542032"/>
+            <a:ext cx="1810512" cy="475488"/>
           </a:xfrm>
           <a:prstGeom prst="rect">
             <a:avLst/>
@@ -4298,8 +4378,8 @@
         </p:nvSpPr>
         <p:spPr>
           <a:xfrm>
-            <a:off x="329184" y="3145536"/>
-            <a:ext cx="5669280" cy="493776"/>
+            <a:off x="329184" y="3218688"/>
+            <a:ext cx="5449824" cy="475488"/>
           </a:xfrm>
           <a:prstGeom prst="rect">
             <a:avLst/>
@@ -4333,8 +4413,8 @@
         </p:nvSpPr>
         <p:spPr>
           <a:xfrm>
-            <a:off x="329184" y="3760215"/>
-            <a:ext cx="5577840" cy="6350"/>
+            <a:off x="329184" y="3749039"/>
+            <a:ext cx="5449824" cy="6350"/>
           </a:xfrm>
           <a:prstGeom prst="rect">
             <a:avLst/>
@@ -4376,8 +4456,8 @@
         </p:nvSpPr>
         <p:spPr>
           <a:xfrm>
-            <a:off x="329184" y="3785615"/>
-            <a:ext cx="1645920" cy="304800"/>
+            <a:off x="329184" y="3803903"/>
+            <a:ext cx="1645920" cy="279400"/>
           </a:xfrm>
           <a:prstGeom prst="rect">
             <a:avLst/>
@@ -4411,8 +4491,8 @@
         </p:nvSpPr>
         <p:spPr>
           <a:xfrm>
-            <a:off x="329184" y="4023359"/>
-            <a:ext cx="5577840" cy="347472"/>
+            <a:off x="329184" y="3986783"/>
+            <a:ext cx="5449824" cy="256032"/>
           </a:xfrm>
           <a:prstGeom prst="rect">
             <a:avLst/>
@@ -4446,8 +4526,8 @@
         </p:nvSpPr>
         <p:spPr>
           <a:xfrm>
-            <a:off x="329184" y="4418583"/>
-            <a:ext cx="5577840" cy="6350"/>
+            <a:off x="329184" y="4270246"/>
+            <a:ext cx="5449824" cy="6350"/>
           </a:xfrm>
           <a:prstGeom prst="rect">
             <a:avLst/>
@@ -4489,8 +4569,8 @@
         </p:nvSpPr>
         <p:spPr>
           <a:xfrm>
-            <a:off x="329184" y="4443983"/>
-            <a:ext cx="1645920" cy="304800"/>
+            <a:off x="329184" y="4325110"/>
+            <a:ext cx="1645920" cy="279400"/>
           </a:xfrm>
           <a:prstGeom prst="rect">
             <a:avLst/>
@@ -4524,8 +4604,8 @@
         </p:nvSpPr>
         <p:spPr>
           <a:xfrm>
-            <a:off x="329184" y="4681727"/>
-            <a:ext cx="5577840" cy="347472"/>
+            <a:off x="329184" y="4507990"/>
+            <a:ext cx="5449824" cy="256032"/>
           </a:xfrm>
           <a:prstGeom prst="rect">
             <a:avLst/>
@@ -4559,8 +4639,8 @@
         </p:nvSpPr>
         <p:spPr>
           <a:xfrm>
-            <a:off x="329184" y="5076951"/>
-            <a:ext cx="5577840" cy="6350"/>
+            <a:off x="329184" y="4791453"/>
+            <a:ext cx="5449824" cy="6350"/>
           </a:xfrm>
           <a:prstGeom prst="rect">
             <a:avLst/>
@@ -4602,8 +4682,8 @@
         </p:nvSpPr>
         <p:spPr>
           <a:xfrm>
-            <a:off x="329184" y="5102351"/>
-            <a:ext cx="1645920" cy="304800"/>
+            <a:off x="329184" y="4846317"/>
+            <a:ext cx="1645920" cy="279400"/>
           </a:xfrm>
           <a:prstGeom prst="rect">
             <a:avLst/>
@@ -4637,8 +4717,8 @@
         </p:nvSpPr>
         <p:spPr>
           <a:xfrm>
-            <a:off x="329184" y="5340095"/>
-            <a:ext cx="5577840" cy="347472"/>
+            <a:off x="329184" y="5029197"/>
+            <a:ext cx="5449824" cy="256032"/>
           </a:xfrm>
           <a:prstGeom prst="rect">
             <a:avLst/>
@@ -4672,8 +4752,8 @@
         </p:nvSpPr>
         <p:spPr>
           <a:xfrm>
-            <a:off x="329184" y="5779008"/>
-            <a:ext cx="5577840" cy="457200"/>
+            <a:off x="329184" y="5449824"/>
+            <a:ext cx="5449824" cy="457200"/>
           </a:xfrm>
           <a:prstGeom prst="rect">
             <a:avLst/>
@@ -4717,8 +4797,8 @@
         </p:nvSpPr>
         <p:spPr>
           <a:xfrm>
-            <a:off x="420624" y="5893308"/>
-            <a:ext cx="5394960" cy="402336"/>
+            <a:off x="420624" y="5522976"/>
+            <a:ext cx="5266944" cy="402336"/>
           </a:xfrm>
           <a:prstGeom prst="rect">
             <a:avLst/>
@@ -4752,8 +4832,8 @@
         </p:nvSpPr>
         <p:spPr>
           <a:xfrm>
-            <a:off x="6035040" y="1664208"/>
-            <a:ext cx="6350" cy="4572000"/>
+            <a:off x="5961888" y="1737360"/>
+            <a:ext cx="6350" cy="4425696"/>
           </a:xfrm>
           <a:prstGeom prst="rect">
             <a:avLst/>
@@ -4797,14 +4877,14 @@
         </p:nvPicPr>
         <p:blipFill>
           <a:blip r:embed="rId3"/>
-          <a:srcRect t="7933" b="7933"/>
+          <a:srcRect t="-9429" b="-9429"/>
           <a:stretch>
             <a:fillRect/>
           </a:stretch>
         </p:blipFill>
         <p:spPr>
           <a:xfrm>
-            <a:off x="6217920" y="1810512"/>
+            <a:off x="6144768" y="1737360"/>
             <a:ext cx="5641848" cy="2670048"/>
           </a:xfrm>
           <a:prstGeom prst="rect">
@@ -4820,7 +4900,7 @@
         </p:nvSpPr>
         <p:spPr>
           <a:xfrm>
-            <a:off x="6217920" y="1810512"/>
+            <a:off x="6144768" y="1737360"/>
             <a:ext cx="5641848" cy="2670048"/>
           </a:xfrm>
           <a:prstGeom prst="rect">
@@ -4863,14 +4943,14 @@
         </p:nvSpPr>
         <p:spPr>
           <a:xfrm>
-            <a:off x="6217920" y="4242816"/>
+            <a:off x="6144768" y="4169664"/>
             <a:ext cx="5641848" cy="237744"/>
           </a:xfrm>
           <a:prstGeom prst="rect">
             <a:avLst/>
           </a:prstGeom>
           <a:solidFill>
-            <a:srgbClr val="080C22"/>
+            <a:srgbClr val="060A1E"/>
           </a:solidFill>
           <a:ln>
             <a:noFill/>
@@ -4906,7 +4986,7 @@
         </p:nvSpPr>
         <p:spPr>
           <a:xfrm>
-            <a:off x="6309360" y="4306316"/>
+            <a:off x="6236208" y="4233164"/>
             <a:ext cx="5458968" cy="237744"/>
           </a:xfrm>
           <a:prstGeom prst="rect">
@@ -4941,8 +5021,8 @@
         </p:nvSpPr>
         <p:spPr>
           <a:xfrm>
-            <a:off x="6217920" y="4601464"/>
-            <a:ext cx="5577840" cy="6350"/>
+            <a:off x="6144768" y="4572000"/>
+            <a:ext cx="5641848" cy="6350"/>
           </a:xfrm>
           <a:prstGeom prst="rect">
             <a:avLst/>
@@ -4984,8 +5064,8 @@
         </p:nvSpPr>
         <p:spPr>
           <a:xfrm>
-            <a:off x="6217920" y="4626864"/>
-            <a:ext cx="1463040" cy="304800"/>
+            <a:off x="6144768" y="4608576"/>
+            <a:ext cx="1463040" cy="279400"/>
           </a:xfrm>
           <a:prstGeom prst="rect">
             <a:avLst/>
@@ -5019,8 +5099,8 @@
         </p:nvSpPr>
         <p:spPr>
           <a:xfrm>
-            <a:off x="7772400" y="4626864"/>
-            <a:ext cx="4023360" cy="365760"/>
+            <a:off x="7699248" y="4608576"/>
+            <a:ext cx="4059936" cy="329184"/>
           </a:xfrm>
           <a:prstGeom prst="rect">
             <a:avLst/>
@@ -5054,8 +5134,8 @@
         </p:nvSpPr>
         <p:spPr>
           <a:xfrm>
-            <a:off x="6217920" y="5003800"/>
-            <a:ext cx="5577840" cy="6350"/>
+            <a:off x="6144768" y="4956048"/>
+            <a:ext cx="5641848" cy="6350"/>
           </a:xfrm>
           <a:prstGeom prst="rect">
             <a:avLst/>
@@ -5097,8 +5177,8 @@
         </p:nvSpPr>
         <p:spPr>
           <a:xfrm>
-            <a:off x="6217920" y="5029200"/>
-            <a:ext cx="1463040" cy="304800"/>
+            <a:off x="6144768" y="4992624"/>
+            <a:ext cx="1463040" cy="279400"/>
           </a:xfrm>
           <a:prstGeom prst="rect">
             <a:avLst/>
@@ -5132,8 +5212,8 @@
         </p:nvSpPr>
         <p:spPr>
           <a:xfrm>
-            <a:off x="7772400" y="5029200"/>
-            <a:ext cx="4023360" cy="365760"/>
+            <a:off x="7699248" y="4992624"/>
+            <a:ext cx="4059936" cy="329184"/>
           </a:xfrm>
           <a:prstGeom prst="rect">
             <a:avLst/>
@@ -5154,7 +5234,7 @@
                 </a:solidFill>
                 <a:latin typeface="Barlow Condensed"/>
               </a:rPr>
-              <a:t>All industries · 6 sector packs available</a:t>
+              <a:t>All industries · 6 sector packs</a:t>
             </a:r>
           </a:p>
         </p:txBody>
@@ -5167,8 +5247,8 @@
         </p:nvSpPr>
         <p:spPr>
           <a:xfrm>
-            <a:off x="6217920" y="5406136"/>
-            <a:ext cx="5577840" cy="6350"/>
+            <a:off x="6144768" y="5340096"/>
+            <a:ext cx="5641848" cy="6350"/>
           </a:xfrm>
           <a:prstGeom prst="rect">
             <a:avLst/>
@@ -5210,8 +5290,8 @@
         </p:nvSpPr>
         <p:spPr>
           <a:xfrm>
-            <a:off x="6217920" y="5431536"/>
-            <a:ext cx="1463040" cy="304800"/>
+            <a:off x="6144768" y="5376672"/>
+            <a:ext cx="1463040" cy="279400"/>
           </a:xfrm>
           <a:prstGeom prst="rect">
             <a:avLst/>
@@ -5245,8 +5325,8 @@
         </p:nvSpPr>
         <p:spPr>
           <a:xfrm>
-            <a:off x="7772400" y="5431536"/>
-            <a:ext cx="4023360" cy="365760"/>
+            <a:off x="7699248" y="5376672"/>
+            <a:ext cx="4059936" cy="329184"/>
           </a:xfrm>
           <a:prstGeom prst="rect">
             <a:avLst/>
@@ -5280,8 +5360,8 @@
         </p:nvSpPr>
         <p:spPr>
           <a:xfrm>
-            <a:off x="6217920" y="5808472"/>
-            <a:ext cx="5577840" cy="6350"/>
+            <a:off x="6144768" y="5724144"/>
+            <a:ext cx="5641848" cy="6350"/>
           </a:xfrm>
           <a:prstGeom prst="rect">
             <a:avLst/>
@@ -5323,8 +5403,8 @@
         </p:nvSpPr>
         <p:spPr>
           <a:xfrm>
-            <a:off x="6217920" y="5833872"/>
-            <a:ext cx="1463040" cy="304800"/>
+            <a:off x="6144768" y="5760720"/>
+            <a:ext cx="1463040" cy="279400"/>
           </a:xfrm>
           <a:prstGeom prst="rect">
             <a:avLst/>
@@ -5358,8 +5438,8 @@
         </p:nvSpPr>
         <p:spPr>
           <a:xfrm>
-            <a:off x="7772400" y="5833872"/>
-            <a:ext cx="4023360" cy="365760"/>
+            <a:off x="7699248" y="5760720"/>
+            <a:ext cx="4059936" cy="329184"/>
           </a:xfrm>
           <a:prstGeom prst="rect">
             <a:avLst/>
@@ -5505,8 +5585,8 @@
         </p:blipFill>
         <p:spPr>
           <a:xfrm>
-            <a:off x="5184648" y="6236208"/>
-            <a:ext cx="1828800" cy="491066"/>
+            <a:off x="5276088" y="6254496"/>
+            <a:ext cx="1645920" cy="441976"/>
           </a:xfrm>
           <a:prstGeom prst="rect">
             <a:avLst/>
@@ -5521,7 +5601,7 @@
         </p:nvSpPr>
         <p:spPr>
           <a:xfrm>
-            <a:off x="457200" y="420624"/>
+            <a:off x="457200" y="438912"/>
             <a:ext cx="11274552" cy="228600"/>
           </a:xfrm>
           <a:prstGeom prst="rect">
@@ -5556,8 +5636,8 @@
         </p:nvSpPr>
         <p:spPr>
           <a:xfrm>
-            <a:off x="603504" y="896112"/>
-            <a:ext cx="10945368" cy="1389888"/>
+            <a:off x="603504" y="914400"/>
+            <a:ext cx="10945368" cy="1426464"/>
           </a:xfrm>
           <a:prstGeom prst="rect">
             <a:avLst/>
@@ -5599,8 +5679,8 @@
         </p:nvSpPr>
         <p:spPr>
           <a:xfrm>
-            <a:off x="603504" y="896112"/>
-            <a:ext cx="63500" cy="1389888"/>
+            <a:off x="603504" y="914400"/>
+            <a:ext cx="63500" cy="1426464"/>
           </a:xfrm>
           <a:prstGeom prst="rect">
             <a:avLst/>
@@ -5642,7 +5722,7 @@
         </p:nvSpPr>
         <p:spPr>
           <a:xfrm>
-            <a:off x="822960" y="1042416"/>
+            <a:off x="841248" y="1042416"/>
             <a:ext cx="1828800" cy="279400"/>
           </a:xfrm>
           <a:prstGeom prst="rect">
@@ -5677,8 +5757,8 @@
         </p:nvSpPr>
         <p:spPr>
           <a:xfrm>
-            <a:off x="822960" y="1371600"/>
-            <a:ext cx="10515600" cy="786384"/>
+            <a:off x="841248" y="1353312"/>
+            <a:ext cx="10460736" cy="877824"/>
           </a:xfrm>
           <a:prstGeom prst="rect">
             <a:avLst/>
@@ -5693,13 +5773,13 @@
           <a:p>
             <a:pPr algn="l"/>
             <a:r>
-              <a:rPr sz="1900" b="0" i="0">
+              <a:rPr sz="1600" b="0" i="0">
                 <a:solidFill>
                   <a:srgbClr val="C9A84C"/>
                 </a:solidFill>
                 <a:latin typeface="Barlow Condensed"/>
               </a:rPr>
-              <a:t>Enterprises detect more signals but still mobilize too slowly.</a:t>
+              <a:t>Enterprise work was designed for a world without AI. Committees, cycles, and coordination delays exist because humans couldn't process information fast enough to act decisively.</a:t>
             </a:r>
           </a:p>
         </p:txBody>
@@ -5712,8 +5792,8 @@
         </p:nvSpPr>
         <p:spPr>
           <a:xfrm>
-            <a:off x="603504" y="2432304"/>
-            <a:ext cx="10945368" cy="1389888"/>
+            <a:off x="603504" y="2468880"/>
+            <a:ext cx="10945368" cy="1426464"/>
           </a:xfrm>
           <a:prstGeom prst="rect">
             <a:avLst/>
@@ -5755,8 +5835,8 @@
         </p:nvSpPr>
         <p:spPr>
           <a:xfrm>
-            <a:off x="603504" y="2432304"/>
-            <a:ext cx="63500" cy="1389888"/>
+            <a:off x="603504" y="2468880"/>
+            <a:ext cx="63500" cy="1426464"/>
           </a:xfrm>
           <a:prstGeom prst="rect">
             <a:avLst/>
@@ -5798,7 +5878,7 @@
         </p:nvSpPr>
         <p:spPr>
           <a:xfrm>
-            <a:off x="822960" y="2578608"/>
+            <a:off x="841248" y="2596896"/>
             <a:ext cx="1828800" cy="279400"/>
           </a:xfrm>
           <a:prstGeom prst="rect">
@@ -5833,8 +5913,8 @@
         </p:nvSpPr>
         <p:spPr>
           <a:xfrm>
-            <a:off x="822960" y="2907792"/>
-            <a:ext cx="10515600" cy="786384"/>
+            <a:off x="841248" y="2907792"/>
+            <a:ext cx="10460736" cy="877824"/>
           </a:xfrm>
           <a:prstGeom prst="rect">
             <a:avLst/>
@@ -5849,13 +5929,13 @@
           <a:p>
             <a:pPr algn="l"/>
             <a:r>
-              <a:rPr sz="1900" b="0" i="0">
+              <a:rPr sz="1600" b="0" i="0">
                 <a:solidFill>
                   <a:srgbClr val="C9A84C"/>
                 </a:solidFill>
                 <a:latin typeface="Barlow Condensed"/>
               </a:rPr>
-              <a:t>VaughnMartin pre-stages response so executives authorize in minutes.</a:t>
+              <a:t>VaughnMartin pre-stages every response. 170 Readiness Protocols map to 221 strategic triggers — so executives authorize in minutes, not meetings.</a:t>
             </a:r>
           </a:p>
         </p:txBody>
@@ -5868,8 +5948,8 @@
         </p:nvSpPr>
         <p:spPr>
           <a:xfrm>
-            <a:off x="603504" y="3968496"/>
-            <a:ext cx="10945368" cy="1389888"/>
+            <a:off x="603504" y="4023360"/>
+            <a:ext cx="10945368" cy="1426464"/>
           </a:xfrm>
           <a:prstGeom prst="rect">
             <a:avLst/>
@@ -5911,8 +5991,8 @@
         </p:nvSpPr>
         <p:spPr>
           <a:xfrm>
-            <a:off x="603504" y="3968496"/>
-            <a:ext cx="63500" cy="1389888"/>
+            <a:off x="603504" y="4023360"/>
+            <a:ext cx="63500" cy="1426464"/>
           </a:xfrm>
           <a:prstGeom prst="rect">
             <a:avLst/>
@@ -5954,7 +6034,7 @@
         </p:nvSpPr>
         <p:spPr>
           <a:xfrm>
-            <a:off x="822960" y="4114800"/>
+            <a:off x="841248" y="4151376"/>
             <a:ext cx="1828800" cy="279400"/>
           </a:xfrm>
           <a:prstGeom prst="rect">
@@ -5989,8 +6069,8 @@
         </p:nvSpPr>
         <p:spPr>
           <a:xfrm>
-            <a:off x="822960" y="4443984"/>
-            <a:ext cx="10515600" cy="786384"/>
+            <a:off x="841248" y="4462272"/>
+            <a:ext cx="10460736" cy="877824"/>
           </a:xfrm>
           <a:prstGeom prst="rect">
             <a:avLst/>
@@ -6005,13 +6085,13 @@
           <a:p>
             <a:pPr algn="l"/>
             <a:r>
-              <a:rPr sz="1900" b="0" i="0">
+              <a:rPr sz="1600" b="0" i="0">
                 <a:solidFill>
                   <a:srgbClr val="FFFFFF"/>
                 </a:solidFill>
                 <a:latin typeface="Barlow Condensed"/>
               </a:rPr>
-              <a:t>Earlier detection + faster execution protects value before the window closes.</a:t>
+              <a:t>Any organization prepared for every situation it will face is no longer afraid of strategic triggers. It is fearless.</a:t>
             </a:r>
           </a:p>
         </p:txBody>
@@ -6216,8 +6296,8 @@
         </p:blipFill>
         <p:spPr>
           <a:xfrm>
-            <a:off x="329184" y="6387930"/>
-            <a:ext cx="1389888" cy="373210"/>
+            <a:off x="329184" y="6369635"/>
+            <a:ext cx="1389888" cy="373224"/>
           </a:xfrm>
           <a:prstGeom prst="rect">
             <a:avLst/>
@@ -6232,8 +6312,8 @@
         </p:nvSpPr>
         <p:spPr>
           <a:xfrm>
-            <a:off x="329184" y="438912"/>
-            <a:ext cx="5394960" cy="5760720"/>
+            <a:off x="329184" y="475488"/>
+            <a:ext cx="5394960" cy="5687568"/>
           </a:xfrm>
           <a:prstGeom prst="rect">
             <a:avLst/>
@@ -6275,7 +6355,7 @@
         </p:nvSpPr>
         <p:spPr>
           <a:xfrm>
-            <a:off x="603504" y="640080"/>
+            <a:off x="603504" y="658368"/>
             <a:ext cx="10972800" cy="203200"/>
           </a:xfrm>
           <a:prstGeom prst="rect">
@@ -6310,8 +6390,8 @@
         </p:nvSpPr>
         <p:spPr>
           <a:xfrm>
-            <a:off x="603504" y="987552"/>
-            <a:ext cx="3200400" cy="1993392"/>
+            <a:off x="603504" y="1005840"/>
+            <a:ext cx="3200400" cy="1920240"/>
           </a:xfrm>
           <a:prstGeom prst="rect">
             <a:avLst/>
@@ -6345,8 +6425,8 @@
         </p:nvSpPr>
         <p:spPr>
           <a:xfrm>
-            <a:off x="603504" y="2779776"/>
-            <a:ext cx="3200400" cy="594360"/>
+            <a:off x="603504" y="2798064"/>
+            <a:ext cx="3200400" cy="585216"/>
           </a:xfrm>
           <a:prstGeom prst="rect">
             <a:avLst/>
@@ -6380,7 +6460,7 @@
         </p:nvSpPr>
         <p:spPr>
           <a:xfrm>
-            <a:off x="603504" y="3474720"/>
+            <a:off x="603504" y="3493008"/>
             <a:ext cx="4407408" cy="19050"/>
           </a:xfrm>
           <a:prstGeom prst="rect">
@@ -6423,8 +6503,8 @@
         </p:nvSpPr>
         <p:spPr>
           <a:xfrm>
-            <a:off x="603504" y="3639312"/>
-            <a:ext cx="4480560" cy="502920"/>
+            <a:off x="603504" y="3657600"/>
+            <a:ext cx="4480560" cy="512064"/>
           </a:xfrm>
           <a:prstGeom prst="rect">
             <a:avLst/>
@@ -6439,13 +6519,13 @@
           <a:p>
             <a:pPr algn="l"/>
             <a:r>
-              <a:rPr sz="1500" b="0" i="1">
+              <a:rPr sz="1400" b="0" i="1">
                 <a:solidFill>
                   <a:srgbClr val="99A5BB"/>
                 </a:solidFill>
                 <a:latin typeface="Barlow Condensed"/>
               </a:rPr>
-              <a:t>Mobilization time before execution begins.</a:t>
+              <a:t>Average mobilization time before execution begins.</a:t>
             </a:r>
           </a:p>
         </p:txBody>
@@ -6458,8 +6538,8 @@
         </p:nvSpPr>
         <p:spPr>
           <a:xfrm>
-            <a:off x="6163056" y="438912"/>
-            <a:ext cx="5687568" cy="5760720"/>
+            <a:off x="6163056" y="475488"/>
+            <a:ext cx="5696712" cy="5687568"/>
           </a:xfrm>
           <a:prstGeom prst="rect">
             <a:avLst/>
@@ -6501,7 +6581,7 @@
         </p:nvSpPr>
         <p:spPr>
           <a:xfrm>
-            <a:off x="6437376" y="640080"/>
+            <a:off x="6437376" y="658368"/>
             <a:ext cx="10972800" cy="203200"/>
           </a:xfrm>
           <a:prstGeom prst="rect">
@@ -6536,8 +6616,8 @@
         </p:nvSpPr>
         <p:spPr>
           <a:xfrm>
-            <a:off x="6437376" y="987552"/>
-            <a:ext cx="5285232" cy="2176272"/>
+            <a:off x="6437376" y="1005840"/>
+            <a:ext cx="5303520" cy="2103120"/>
           </a:xfrm>
           <a:prstGeom prst="rect">
             <a:avLst/>
@@ -6573,7 +6653,7 @@
         </p:nvSpPr>
         <p:spPr>
           <a:xfrm>
-            <a:off x="6437376" y="3273552"/>
+            <a:off x="6437376" y="3236976"/>
             <a:ext cx="5120640" cy="19050"/>
           </a:xfrm>
           <a:prstGeom prst="rect">
@@ -6616,8 +6696,8 @@
         </p:nvSpPr>
         <p:spPr>
           <a:xfrm>
-            <a:off x="6437376" y="3456432"/>
-            <a:ext cx="5285232" cy="438912"/>
+            <a:off x="6437376" y="3419856"/>
+            <a:ext cx="5303520" cy="438912"/>
           </a:xfrm>
           <a:prstGeom prst="rect">
             <a:avLst/>
@@ -6659,8 +6739,8 @@
         </p:nvSpPr>
         <p:spPr>
           <a:xfrm>
-            <a:off x="6565392" y="3529584"/>
-            <a:ext cx="5029200" cy="365760"/>
+            <a:off x="6565392" y="3493008"/>
+            <a:ext cx="5047488" cy="365760"/>
           </a:xfrm>
           <a:prstGeom prst="rect">
             <a:avLst/>
@@ -6694,8 +6774,8 @@
         </p:nvSpPr>
         <p:spPr>
           <a:xfrm>
-            <a:off x="6437376" y="4023360"/>
-            <a:ext cx="5285232" cy="530352"/>
+            <a:off x="6437376" y="4005072"/>
+            <a:ext cx="5303520" cy="512064"/>
           </a:xfrm>
           <a:prstGeom prst="rect">
             <a:avLst/>
@@ -6729,8 +6809,8 @@
         </p:nvSpPr>
         <p:spPr>
           <a:xfrm>
-            <a:off x="6437376" y="4590288"/>
-            <a:ext cx="5285232" cy="530352"/>
+            <a:off x="6437376" y="4572000"/>
+            <a:ext cx="5303520" cy="512064"/>
           </a:xfrm>
           <a:prstGeom prst="rect">
             <a:avLst/>
@@ -6764,8 +6844,8 @@
         </p:nvSpPr>
         <p:spPr>
           <a:xfrm>
-            <a:off x="5980176" y="329184"/>
-            <a:ext cx="6350" cy="6035040"/>
+            <a:off x="5980176" y="365760"/>
+            <a:ext cx="6350" cy="5961888"/>
           </a:xfrm>
           <a:prstGeom prst="rect">
             <a:avLst/>
@@ -6919,8 +6999,8 @@
         </p:blipFill>
         <p:spPr>
           <a:xfrm>
-            <a:off x="329184" y="6387930"/>
-            <a:ext cx="1389888" cy="373210"/>
+            <a:off x="329184" y="6369635"/>
+            <a:ext cx="1389888" cy="373224"/>
           </a:xfrm>
           <a:prstGeom prst="rect">
             <a:avLst/>
@@ -7044,49 +7124,14 @@
       </p:sp>
       <p:sp>
         <p:nvSpPr>
-          <p:cNvPr id="7" name="TextBox 6"/>
-          <p:cNvSpPr txBox="1"/>
-          <p:nvPr/>
-        </p:nvSpPr>
-        <p:spPr>
-          <a:xfrm>
-            <a:off x="512064" y="1664208"/>
-            <a:ext cx="2560320" cy="402336"/>
-          </a:xfrm>
-          <a:prstGeom prst="rect">
-            <a:avLst/>
-          </a:prstGeom>
-          <a:noFill/>
-        </p:spPr>
-        <p:txBody>
-          <a:bodyPr wrap="square">
-            <a:spAutoFit/>
-          </a:bodyPr>
-          <a:lstStyle/>
-          <a:p>
-            <a:pPr algn="l"/>
-            <a:r>
-              <a:rPr sz="900" b="1" i="0">
-                <a:solidFill>
-                  <a:srgbClr val="2B8A6E"/>
-                </a:solidFill>
-                <a:latin typeface="Barlow Condensed"/>
-              </a:rPr>
-              <a:t>RISK &amp; RESILIENCE</a:t>
-            </a:r>
-          </a:p>
-        </p:txBody>
-      </p:sp>
-      <p:sp>
-        <p:nvSpPr>
-          <p:cNvPr id="8" name="Rectangle 7"/>
+          <p:cNvPr id="7" name="Rectangle 6"/>
           <p:cNvSpPr/>
           <p:nvPr/>
         </p:nvSpPr>
         <p:spPr>
           <a:xfrm>
-            <a:off x="3191256" y="1591056"/>
-            <a:ext cx="822960" cy="402336"/>
+            <a:off x="3118104" y="1609344"/>
+            <a:ext cx="877824" cy="402336"/>
           </a:xfrm>
           <a:prstGeom prst="rect">
             <a:avLst/>
@@ -7094,7 +7139,7 @@
           <a:solidFill>
             <a:srgbClr val="060C28"/>
           </a:solidFill>
-          <a:ln w="15240">
+          <a:ln w="17780">
             <a:solidFill>
               <a:srgbClr val="2B8A6E"/>
             </a:solidFill>
@@ -7124,35 +7169,70 @@
       </p:sp>
       <p:sp>
         <p:nvSpPr>
+          <p:cNvPr id="8" name="TextBox 7"/>
+          <p:cNvSpPr txBox="1"/>
+          <p:nvPr/>
+        </p:nvSpPr>
+        <p:spPr>
+          <a:xfrm>
+            <a:off x="3118104" y="1609344"/>
+            <a:ext cx="877824" cy="402336"/>
+          </a:xfrm>
+          <a:prstGeom prst="rect">
+            <a:avLst/>
+          </a:prstGeom>
+          <a:noFill/>
+        </p:spPr>
+        <p:txBody>
+          <a:bodyPr wrap="square">
+            <a:spAutoFit/>
+          </a:bodyPr>
+          <a:lstStyle/>
+          <a:p>
+            <a:pPr algn="ctr"/>
+            <a:r>
+              <a:rPr sz="2000" b="1" i="0">
+                <a:solidFill>
+                  <a:srgbClr val="2B8A6E"/>
+                </a:solidFill>
+                <a:latin typeface="Barlow Condensed"/>
+              </a:rPr>
+              <a:t>95%</a:t>
+            </a:r>
+          </a:p>
+        </p:txBody>
+      </p:sp>
+      <p:sp>
+        <p:nvSpPr>
           <p:cNvPr id="9" name="TextBox 8"/>
           <p:cNvSpPr txBox="1"/>
           <p:nvPr/>
         </p:nvSpPr>
         <p:spPr>
           <a:xfrm>
-            <a:off x="3191256" y="1591056"/>
-            <a:ext cx="822960" cy="402336"/>
-          </a:xfrm>
-          <a:prstGeom prst="rect">
-            <a:avLst/>
-          </a:prstGeom>
-          <a:noFill/>
-        </p:spPr>
-        <p:txBody>
-          <a:bodyPr wrap="square">
-            <a:spAutoFit/>
-          </a:bodyPr>
-          <a:lstStyle/>
-          <a:p>
-            <a:pPr algn="ctr"/>
-            <a:r>
-              <a:rPr sz="2000" b="1" i="0">
+            <a:off x="512064" y="1682496"/>
+            <a:ext cx="2496312" cy="365760"/>
+          </a:xfrm>
+          <a:prstGeom prst="rect">
+            <a:avLst/>
+          </a:prstGeom>
+          <a:noFill/>
+        </p:spPr>
+        <p:txBody>
+          <a:bodyPr wrap="square">
+            <a:spAutoFit/>
+          </a:bodyPr>
+          <a:lstStyle/>
+          <a:p>
+            <a:pPr algn="l"/>
+            <a:r>
+              <a:rPr sz="900" b="1" i="0">
                 <a:solidFill>
                   <a:srgbClr val="2B8A6E"/>
                 </a:solidFill>
                 <a:latin typeface="Barlow Condensed"/>
               </a:rPr>
-              <a:t>95%</a:t>
+              <a:t>RISK &amp; RESILIENCE</a:t>
             </a:r>
           </a:p>
         </p:txBody>
@@ -7165,7 +7245,7 @@
         </p:nvSpPr>
         <p:spPr>
           <a:xfrm>
-            <a:off x="512064" y="2212848"/>
+            <a:off x="512064" y="2231136"/>
             <a:ext cx="3429000" cy="969264"/>
           </a:xfrm>
           <a:prstGeom prst="rect">
@@ -7201,7 +7281,7 @@
         </p:nvSpPr>
         <p:spPr>
           <a:xfrm>
-            <a:off x="512064" y="3291840"/>
+            <a:off x="512064" y="3328416"/>
             <a:ext cx="3429000" cy="310896"/>
           </a:xfrm>
           <a:prstGeom prst="rect">
@@ -7236,7 +7316,7 @@
         </p:nvSpPr>
         <p:spPr>
           <a:xfrm>
-            <a:off x="512064" y="3712464"/>
+            <a:off x="512064" y="3749040"/>
             <a:ext cx="3429000" cy="50800"/>
           </a:xfrm>
           <a:prstGeom prst="rect">
@@ -7279,7 +7359,7 @@
         </p:nvSpPr>
         <p:spPr>
           <a:xfrm>
-            <a:off x="512064" y="3712464"/>
+            <a:off x="512064" y="3749040"/>
             <a:ext cx="3257550" cy="50800"/>
           </a:xfrm>
           <a:prstGeom prst="rect">
@@ -7361,49 +7441,14 @@
       </p:sp>
       <p:sp>
         <p:nvSpPr>
-          <p:cNvPr id="15" name="TextBox 14"/>
-          <p:cNvSpPr txBox="1"/>
-          <p:nvPr/>
-        </p:nvSpPr>
-        <p:spPr>
-          <a:xfrm>
-            <a:off x="4462272" y="1664208"/>
-            <a:ext cx="2560320" cy="402336"/>
-          </a:xfrm>
-          <a:prstGeom prst="rect">
-            <a:avLst/>
-          </a:prstGeom>
-          <a:noFill/>
-        </p:spPr>
-        <p:txBody>
-          <a:bodyPr wrap="square">
-            <a:spAutoFit/>
-          </a:bodyPr>
-          <a:lstStyle/>
-          <a:p>
-            <a:pPr algn="l"/>
-            <a:r>
-              <a:rPr sz="900" b="1" i="0">
-                <a:solidFill>
-                  <a:srgbClr val="2B8A6E"/>
-                </a:solidFill>
-                <a:latin typeface="Barlow Condensed"/>
-              </a:rPr>
-              <a:t>REGULATORY</a:t>
-            </a:r>
-          </a:p>
-        </p:txBody>
-      </p:sp>
-      <p:sp>
-        <p:nvSpPr>
-          <p:cNvPr id="16" name="Rectangle 15"/>
+          <p:cNvPr id="15" name="Rectangle 14"/>
           <p:cNvSpPr/>
           <p:nvPr/>
         </p:nvSpPr>
         <p:spPr>
           <a:xfrm>
-            <a:off x="7141464" y="1591056"/>
-            <a:ext cx="822960" cy="402336"/>
+            <a:off x="7068312" y="1609344"/>
+            <a:ext cx="877824" cy="402336"/>
           </a:xfrm>
           <a:prstGeom prst="rect">
             <a:avLst/>
@@ -7411,7 +7456,7 @@
           <a:solidFill>
             <a:srgbClr val="060C28"/>
           </a:solidFill>
-          <a:ln w="15240">
+          <a:ln w="17780">
             <a:solidFill>
               <a:srgbClr val="C9A84C"/>
             </a:solidFill>
@@ -7441,35 +7486,70 @@
       </p:sp>
       <p:sp>
         <p:nvSpPr>
+          <p:cNvPr id="16" name="TextBox 15"/>
+          <p:cNvSpPr txBox="1"/>
+          <p:nvPr/>
+        </p:nvSpPr>
+        <p:spPr>
+          <a:xfrm>
+            <a:off x="7068312" y="1609344"/>
+            <a:ext cx="877824" cy="402336"/>
+          </a:xfrm>
+          <a:prstGeom prst="rect">
+            <a:avLst/>
+          </a:prstGeom>
+          <a:noFill/>
+        </p:spPr>
+        <p:txBody>
+          <a:bodyPr wrap="square">
+            <a:spAutoFit/>
+          </a:bodyPr>
+          <a:lstStyle/>
+          <a:p>
+            <a:pPr algn="ctr"/>
+            <a:r>
+              <a:rPr sz="2000" b="1" i="0">
+                <a:solidFill>
+                  <a:srgbClr val="C9A84C"/>
+                </a:solidFill>
+                <a:latin typeface="Barlow Condensed"/>
+              </a:rPr>
+              <a:t>87%</a:t>
+            </a:r>
+          </a:p>
+        </p:txBody>
+      </p:sp>
+      <p:sp>
+        <p:nvSpPr>
           <p:cNvPr id="17" name="TextBox 16"/>
           <p:cNvSpPr txBox="1"/>
           <p:nvPr/>
         </p:nvSpPr>
         <p:spPr>
           <a:xfrm>
-            <a:off x="7141464" y="1591056"/>
-            <a:ext cx="822960" cy="402336"/>
-          </a:xfrm>
-          <a:prstGeom prst="rect">
-            <a:avLst/>
-          </a:prstGeom>
-          <a:noFill/>
-        </p:spPr>
-        <p:txBody>
-          <a:bodyPr wrap="square">
-            <a:spAutoFit/>
-          </a:bodyPr>
-          <a:lstStyle/>
-          <a:p>
-            <a:pPr algn="ctr"/>
-            <a:r>
-              <a:rPr sz="2000" b="1" i="0">
-                <a:solidFill>
-                  <a:srgbClr val="C9A84C"/>
-                </a:solidFill>
-                <a:latin typeface="Barlow Condensed"/>
-              </a:rPr>
-              <a:t>87%</a:t>
+            <a:off x="4462272" y="1682496"/>
+            <a:ext cx="2496312" cy="365760"/>
+          </a:xfrm>
+          <a:prstGeom prst="rect">
+            <a:avLst/>
+          </a:prstGeom>
+          <a:noFill/>
+        </p:spPr>
+        <p:txBody>
+          <a:bodyPr wrap="square">
+            <a:spAutoFit/>
+          </a:bodyPr>
+          <a:lstStyle/>
+          <a:p>
+            <a:pPr algn="l"/>
+            <a:r>
+              <a:rPr sz="900" b="1" i="0">
+                <a:solidFill>
+                  <a:srgbClr val="2B8A6E"/>
+                </a:solidFill>
+                <a:latin typeface="Barlow Condensed"/>
+              </a:rPr>
+              <a:t>REGULATORY</a:t>
             </a:r>
           </a:p>
         </p:txBody>
@@ -7482,7 +7562,7 @@
         </p:nvSpPr>
         <p:spPr>
           <a:xfrm>
-            <a:off x="4462272" y="2212848"/>
+            <a:off x="4462272" y="2231136"/>
             <a:ext cx="3429000" cy="969264"/>
           </a:xfrm>
           <a:prstGeom prst="rect">
@@ -7518,7 +7598,7 @@
         </p:nvSpPr>
         <p:spPr>
           <a:xfrm>
-            <a:off x="4462272" y="3291840"/>
+            <a:off x="4462272" y="3328416"/>
             <a:ext cx="3429000" cy="310896"/>
           </a:xfrm>
           <a:prstGeom prst="rect">
@@ -7553,7 +7633,7 @@
         </p:nvSpPr>
         <p:spPr>
           <a:xfrm>
-            <a:off x="4462272" y="3712464"/>
+            <a:off x="4462272" y="3749040"/>
             <a:ext cx="3429000" cy="50800"/>
           </a:xfrm>
           <a:prstGeom prst="rect">
@@ -7596,7 +7676,7 @@
         </p:nvSpPr>
         <p:spPr>
           <a:xfrm>
-            <a:off x="4462272" y="3712464"/>
+            <a:off x="4462272" y="3749040"/>
             <a:ext cx="2983230" cy="50800"/>
           </a:xfrm>
           <a:prstGeom prst="rect">
@@ -7678,49 +7758,14 @@
       </p:sp>
       <p:sp>
         <p:nvSpPr>
-          <p:cNvPr id="23" name="TextBox 22"/>
-          <p:cNvSpPr txBox="1"/>
-          <p:nvPr/>
-        </p:nvSpPr>
-        <p:spPr>
-          <a:xfrm>
-            <a:off x="8412480" y="1664208"/>
-            <a:ext cx="2560320" cy="402336"/>
-          </a:xfrm>
-          <a:prstGeom prst="rect">
-            <a:avLst/>
-          </a:prstGeom>
-          <a:noFill/>
-        </p:spPr>
-        <p:txBody>
-          <a:bodyPr wrap="square">
-            <a:spAutoFit/>
-          </a:bodyPr>
-          <a:lstStyle/>
-          <a:p>
-            <a:pPr algn="l"/>
-            <a:r>
-              <a:rPr sz="900" b="1" i="0">
-                <a:solidFill>
-                  <a:srgbClr val="2B8A6E"/>
-                </a:solidFill>
-                <a:latin typeface="Barlow Condensed"/>
-              </a:rPr>
-              <a:t>GROWTH &amp; POSITIONING</a:t>
-            </a:r>
-          </a:p>
-        </p:txBody>
-      </p:sp>
-      <p:sp>
-        <p:nvSpPr>
-          <p:cNvPr id="24" name="Rectangle 23"/>
+          <p:cNvPr id="23" name="Rectangle 22"/>
           <p:cNvSpPr/>
           <p:nvPr/>
         </p:nvSpPr>
         <p:spPr>
           <a:xfrm>
-            <a:off x="11091672" y="1591056"/>
-            <a:ext cx="822960" cy="402336"/>
+            <a:off x="11018520" y="1609344"/>
+            <a:ext cx="877824" cy="402336"/>
           </a:xfrm>
           <a:prstGeom prst="rect">
             <a:avLst/>
@@ -7728,7 +7773,7 @@
           <a:solidFill>
             <a:srgbClr val="060C28"/>
           </a:solidFill>
-          <a:ln w="15240">
+          <a:ln w="17780">
             <a:solidFill>
               <a:srgbClr val="C9A84C"/>
             </a:solidFill>
@@ -7758,35 +7803,70 @@
       </p:sp>
       <p:sp>
         <p:nvSpPr>
+          <p:cNvPr id="24" name="TextBox 23"/>
+          <p:cNvSpPr txBox="1"/>
+          <p:nvPr/>
+        </p:nvSpPr>
+        <p:spPr>
+          <a:xfrm>
+            <a:off x="11018520" y="1609344"/>
+            <a:ext cx="877824" cy="402336"/>
+          </a:xfrm>
+          <a:prstGeom prst="rect">
+            <a:avLst/>
+          </a:prstGeom>
+          <a:noFill/>
+        </p:spPr>
+        <p:txBody>
+          <a:bodyPr wrap="square">
+            <a:spAutoFit/>
+          </a:bodyPr>
+          <a:lstStyle/>
+          <a:p>
+            <a:pPr algn="ctr"/>
+            <a:r>
+              <a:rPr sz="2000" b="1" i="0">
+                <a:solidFill>
+                  <a:srgbClr val="C9A84C"/>
+                </a:solidFill>
+                <a:latin typeface="Barlow Condensed"/>
+              </a:rPr>
+              <a:t>82%</a:t>
+            </a:r>
+          </a:p>
+        </p:txBody>
+      </p:sp>
+      <p:sp>
+        <p:nvSpPr>
           <p:cNvPr id="25" name="TextBox 24"/>
           <p:cNvSpPr txBox="1"/>
           <p:nvPr/>
         </p:nvSpPr>
         <p:spPr>
           <a:xfrm>
-            <a:off x="11091672" y="1591056"/>
-            <a:ext cx="822960" cy="402336"/>
-          </a:xfrm>
-          <a:prstGeom prst="rect">
-            <a:avLst/>
-          </a:prstGeom>
-          <a:noFill/>
-        </p:spPr>
-        <p:txBody>
-          <a:bodyPr wrap="square">
-            <a:spAutoFit/>
-          </a:bodyPr>
-          <a:lstStyle/>
-          <a:p>
-            <a:pPr algn="ctr"/>
-            <a:r>
-              <a:rPr sz="2000" b="1" i="0">
-                <a:solidFill>
-                  <a:srgbClr val="C9A84C"/>
-                </a:solidFill>
-                <a:latin typeface="Barlow Condensed"/>
-              </a:rPr>
-              <a:t>82%</a:t>
+            <a:off x="8412480" y="1682496"/>
+            <a:ext cx="2496312" cy="365760"/>
+          </a:xfrm>
+          <a:prstGeom prst="rect">
+            <a:avLst/>
+          </a:prstGeom>
+          <a:noFill/>
+        </p:spPr>
+        <p:txBody>
+          <a:bodyPr wrap="square">
+            <a:spAutoFit/>
+          </a:bodyPr>
+          <a:lstStyle/>
+          <a:p>
+            <a:pPr algn="l"/>
+            <a:r>
+              <a:rPr sz="900" b="1" i="0">
+                <a:solidFill>
+                  <a:srgbClr val="2B8A6E"/>
+                </a:solidFill>
+                <a:latin typeface="Barlow Condensed"/>
+              </a:rPr>
+              <a:t>GROWTH &amp; POSITIONING</a:t>
             </a:r>
           </a:p>
         </p:txBody>
@@ -7799,7 +7879,7 @@
         </p:nvSpPr>
         <p:spPr>
           <a:xfrm>
-            <a:off x="8412480" y="2212848"/>
+            <a:off x="8412480" y="2231136"/>
             <a:ext cx="3429000" cy="969264"/>
           </a:xfrm>
           <a:prstGeom prst="rect">
@@ -7835,7 +7915,7 @@
         </p:nvSpPr>
         <p:spPr>
           <a:xfrm>
-            <a:off x="8412480" y="3291840"/>
+            <a:off x="8412480" y="3328416"/>
             <a:ext cx="3429000" cy="310896"/>
           </a:xfrm>
           <a:prstGeom prst="rect">
@@ -7870,7 +7950,7 @@
         </p:nvSpPr>
         <p:spPr>
           <a:xfrm>
-            <a:off x="8412480" y="3712464"/>
+            <a:off x="8412480" y="3749040"/>
             <a:ext cx="3429000" cy="50800"/>
           </a:xfrm>
           <a:prstGeom prst="rect">
@@ -7913,7 +7993,7 @@
         </p:nvSpPr>
         <p:spPr>
           <a:xfrm>
-            <a:off x="8412480" y="3712464"/>
+            <a:off x="8412480" y="3749040"/>
             <a:ext cx="2811780" cy="50800"/>
           </a:xfrm>
           <a:prstGeom prst="rect">
@@ -7956,8 +8036,8 @@
         </p:nvSpPr>
         <p:spPr>
           <a:xfrm>
-            <a:off x="329184" y="5888736"/>
-            <a:ext cx="11530584" cy="402336"/>
+            <a:off x="329184" y="5870448"/>
+            <a:ext cx="11530584" cy="384048"/>
           </a:xfrm>
           <a:prstGeom prst="rect">
             <a:avLst/>
@@ -7999,8 +8079,8 @@
         </p:nvSpPr>
         <p:spPr>
           <a:xfrm>
-            <a:off x="457200" y="5943600"/>
-            <a:ext cx="11274552" cy="347472"/>
+            <a:off x="457200" y="5925312"/>
+            <a:ext cx="11274552" cy="329184"/>
           </a:xfrm>
           <a:prstGeom prst="rect">
             <a:avLst/>
@@ -8146,8 +8226,8 @@
         </p:blipFill>
         <p:spPr>
           <a:xfrm>
-            <a:off x="329184" y="6387930"/>
-            <a:ext cx="1389888" cy="373210"/>
+            <a:off x="329184" y="6369635"/>
+            <a:ext cx="1389888" cy="373224"/>
           </a:xfrm>
           <a:prstGeom prst="rect">
             <a:avLst/>
@@ -8156,50 +8236,7 @@
       </p:pic>
       <p:sp>
         <p:nvSpPr>
-          <p:cNvPr id="4" name="Rectangle 3"/>
-          <p:cNvSpPr/>
-          <p:nvPr/>
-        </p:nvSpPr>
-        <p:spPr>
-          <a:xfrm>
-            <a:off x="6858000" y="0"/>
-            <a:ext cx="5330952" cy="3657600"/>
-          </a:xfrm>
-          <a:prstGeom prst="rect">
-            <a:avLst/>
-          </a:prstGeom>
-          <a:solidFill>
-            <a:srgbClr val="101C4A"/>
-          </a:solidFill>
-          <a:ln>
-            <a:noFill/>
-          </a:ln>
-        </p:spPr>
-        <p:style>
-          <a:lnRef idx="1">
-            <a:schemeClr val="accent1"/>
-          </a:lnRef>
-          <a:fillRef idx="3">
-            <a:schemeClr val="accent1"/>
-          </a:fillRef>
-          <a:effectRef idx="2">
-            <a:schemeClr val="accent1"/>
-          </a:effectRef>
-          <a:fontRef idx="minor">
-            <a:schemeClr val="lt1"/>
-          </a:fontRef>
-        </p:style>
-        <p:txBody>
-          <a:bodyPr rtlCol="0" anchor="ctr"/>
-          <a:lstStyle/>
-          <a:p>
-            <a:pPr algn="ctr"/>
-          </a:p>
-        </p:txBody>
-      </p:sp>
-      <p:sp>
-        <p:nvSpPr>
-          <p:cNvPr id="5" name="TextBox 4"/>
+          <p:cNvPr id="4" name="TextBox 3"/>
           <p:cNvSpPr txBox="1"/>
           <p:nvPr/>
         </p:nvSpPr>
@@ -8234,14 +8271,49 @@
       </p:sp>
       <p:sp>
         <p:nvSpPr>
+          <p:cNvPr id="5" name="TextBox 4"/>
+          <p:cNvSpPr txBox="1"/>
+          <p:nvPr/>
+        </p:nvSpPr>
+        <p:spPr>
+          <a:xfrm>
+            <a:off x="914400" y="731520"/>
+            <a:ext cx="10360152" cy="1042415"/>
+          </a:xfrm>
+          <a:prstGeom prst="rect">
+            <a:avLst/>
+          </a:prstGeom>
+          <a:noFill/>
+        </p:spPr>
+        <p:txBody>
+          <a:bodyPr wrap="square">
+            <a:spAutoFit/>
+          </a:bodyPr>
+          <a:lstStyle/>
+          <a:p>
+            <a:pPr algn="ctr"/>
+            <a:r>
+              <a:rPr sz="5200" b="1">
+                <a:solidFill>
+                  <a:srgbClr val="FFFFFF"/>
+                </a:solidFill>
+                <a:latin typeface="Barlow Condensed"/>
+              </a:rPr>
+              <a:t>The response is ready</a:t>
+            </a:r>
+          </a:p>
+        </p:txBody>
+      </p:sp>
+      <p:sp>
+        <p:nvSpPr>
           <p:cNvPr id="6" name="TextBox 5"/>
           <p:cNvSpPr txBox="1"/>
           <p:nvPr/>
         </p:nvSpPr>
         <p:spPr>
           <a:xfrm>
-            <a:off x="914400" y="749808"/>
-            <a:ext cx="10360152" cy="1024128"/>
+            <a:off x="914400" y="1719072"/>
+            <a:ext cx="10360152" cy="1042415"/>
           </a:xfrm>
           <a:prstGeom prst="rect">
             <a:avLst/>
@@ -8258,11 +8330,11 @@
             <a:r>
               <a:rPr sz="5200" b="1">
                 <a:solidFill>
-                  <a:srgbClr val="FFFFFF"/>
-                </a:solidFill>
-                <a:latin typeface="Barlow Condensed"/>
-              </a:rPr>
-              <a:t>The response is ready</a:t>
+                  <a:srgbClr val="C9A84C"/>
+                </a:solidFill>
+                <a:latin typeface="Barlow Condensed"/>
+              </a:rPr>
+              <a:t>before the trigger fires.</a:t>
             </a:r>
           </a:p>
         </p:txBody>
@@ -8275,8 +8347,8 @@
         </p:nvSpPr>
         <p:spPr>
           <a:xfrm>
-            <a:off x="914400" y="1700784"/>
-            <a:ext cx="10360152" cy="1024128"/>
+            <a:off x="914400" y="2798064"/>
+            <a:ext cx="10360152" cy="457200"/>
           </a:xfrm>
           <a:prstGeom prst="rect">
             <a:avLst/>
@@ -8291,41 +8363,6 @@
           <a:p>
             <a:pPr algn="ctr"/>
             <a:r>
-              <a:rPr sz="5200" b="1">
-                <a:solidFill>
-                  <a:srgbClr val="C9A84C"/>
-                </a:solidFill>
-                <a:latin typeface="Barlow Condensed"/>
-              </a:rPr>
-              <a:t>before the trigger fires.</a:t>
-            </a:r>
-          </a:p>
-        </p:txBody>
-      </p:sp>
-      <p:sp>
-        <p:nvSpPr>
-          <p:cNvPr id="8" name="TextBox 7"/>
-          <p:cNvSpPr txBox="1"/>
-          <p:nvPr/>
-        </p:nvSpPr>
-        <p:spPr>
-          <a:xfrm>
-            <a:off x="914400" y="2761488"/>
-            <a:ext cx="10360152" cy="457200"/>
-          </a:xfrm>
-          <a:prstGeom prst="rect">
-            <a:avLst/>
-          </a:prstGeom>
-          <a:noFill/>
-        </p:spPr>
-        <p:txBody>
-          <a:bodyPr wrap="square">
-            <a:spAutoFit/>
-          </a:bodyPr>
-          <a:lstStyle/>
-          <a:p>
-            <a:pPr algn="ctr"/>
-            <a:r>
               <a:rPr sz="1600" b="0" i="1">
                 <a:solidFill>
                   <a:srgbClr val="99A5BB"/>
@@ -8339,13 +8376,13 @@
       </p:sp>
       <p:sp>
         <p:nvSpPr>
-          <p:cNvPr id="9" name="Rectangle 8"/>
+          <p:cNvPr id="8" name="Rectangle 7"/>
           <p:cNvSpPr/>
           <p:nvPr/>
         </p:nvSpPr>
         <p:spPr>
           <a:xfrm>
-            <a:off x="3813048" y="3310128"/>
+            <a:off x="3813048" y="3328416"/>
             <a:ext cx="4572000" cy="19050"/>
           </a:xfrm>
           <a:prstGeom prst="rect">
@@ -8382,13 +8419,83 @@
       </p:sp>
       <p:sp>
         <p:nvSpPr>
+          <p:cNvPr id="9" name="TextBox 8"/>
+          <p:cNvSpPr txBox="1"/>
+          <p:nvPr/>
+        </p:nvSpPr>
+        <p:spPr>
+          <a:xfrm>
+            <a:off x="502920" y="3511296"/>
+            <a:ext cx="3657600" cy="1097280"/>
+          </a:xfrm>
+          <a:prstGeom prst="rect">
+            <a:avLst/>
+          </a:prstGeom>
+          <a:noFill/>
+        </p:spPr>
+        <p:txBody>
+          <a:bodyPr wrap="square">
+            <a:spAutoFit/>
+          </a:bodyPr>
+          <a:lstStyle/>
+          <a:p>
+            <a:pPr algn="ctr"/>
+            <a:r>
+              <a:rPr sz="5200" b="1" i="0">
+                <a:solidFill>
+                  <a:srgbClr val="C9A84C"/>
+                </a:solidFill>
+                <a:latin typeface="Barlow Condensed"/>
+              </a:rPr>
+              <a:t>170</a:t>
+            </a:r>
+          </a:p>
+        </p:txBody>
+      </p:sp>
+      <p:sp>
+        <p:nvSpPr>
           <p:cNvPr id="10" name="TextBox 9"/>
           <p:cNvSpPr txBox="1"/>
           <p:nvPr/>
         </p:nvSpPr>
         <p:spPr>
           <a:xfrm>
-            <a:off x="502920" y="3493008"/>
+            <a:off x="502920" y="4590288"/>
+            <a:ext cx="3657600" cy="304800"/>
+          </a:xfrm>
+          <a:prstGeom prst="rect">
+            <a:avLst/>
+          </a:prstGeom>
+          <a:noFill/>
+        </p:spPr>
+        <p:txBody>
+          <a:bodyPr wrap="square">
+            <a:spAutoFit/>
+          </a:bodyPr>
+          <a:lstStyle/>
+          <a:p>
+            <a:pPr algn="ctr"/>
+            <a:r>
+              <a:rPr sz="1300" b="0" i="0">
+                <a:solidFill>
+                  <a:srgbClr val="FFFFFF"/>
+                </a:solidFill>
+                <a:latin typeface="Barlow Condensed"/>
+              </a:rPr>
+              <a:t>Readiness Protocols</a:t>
+            </a:r>
+          </a:p>
+        </p:txBody>
+      </p:sp>
+      <p:sp>
+        <p:nvSpPr>
+          <p:cNvPr id="11" name="TextBox 10"/>
+          <p:cNvSpPr txBox="1"/>
+          <p:nvPr/>
+        </p:nvSpPr>
+        <p:spPr>
+          <a:xfrm>
+            <a:off x="4361688" y="3511296"/>
             <a:ext cx="3657600" cy="1097280"/>
           </a:xfrm>
           <a:prstGeom prst="rect">
@@ -8410,20 +8517,20 @@
                 </a:solidFill>
                 <a:latin typeface="Barlow Condensed"/>
               </a:rPr>
-              <a:t>170</a:t>
-            </a:r>
-          </a:p>
-        </p:txBody>
-      </p:sp>
-      <p:sp>
-        <p:nvSpPr>
-          <p:cNvPr id="11" name="TextBox 10"/>
-          <p:cNvSpPr txBox="1"/>
-          <p:nvPr/>
-        </p:nvSpPr>
-        <p:spPr>
-          <a:xfrm>
-            <a:off x="502920" y="4572000"/>
+              <a:t>221</a:t>
+            </a:r>
+          </a:p>
+        </p:txBody>
+      </p:sp>
+      <p:sp>
+        <p:nvSpPr>
+          <p:cNvPr id="12" name="TextBox 11"/>
+          <p:cNvSpPr txBox="1"/>
+          <p:nvPr/>
+        </p:nvSpPr>
+        <p:spPr>
+          <a:xfrm>
+            <a:off x="4361688" y="4590288"/>
             <a:ext cx="3657600" cy="304800"/>
           </a:xfrm>
           <a:prstGeom prst="rect">
@@ -8445,20 +8552,20 @@
                 </a:solidFill>
                 <a:latin typeface="Barlow Condensed"/>
               </a:rPr>
-              <a:t>Readiness Protocols</a:t>
-            </a:r>
-          </a:p>
-        </p:txBody>
-      </p:sp>
-      <p:sp>
-        <p:nvSpPr>
-          <p:cNvPr id="12" name="TextBox 11"/>
-          <p:cNvSpPr txBox="1"/>
-          <p:nvPr/>
-        </p:nvSpPr>
-        <p:spPr>
-          <a:xfrm>
-            <a:off x="4361688" y="3493008"/>
+              <a:t>Strategic Triggers</a:t>
+            </a:r>
+          </a:p>
+        </p:txBody>
+      </p:sp>
+      <p:sp>
+        <p:nvSpPr>
+          <p:cNvPr id="13" name="TextBox 12"/>
+          <p:cNvSpPr txBox="1"/>
+          <p:nvPr/>
+        </p:nvSpPr>
+        <p:spPr>
+          <a:xfrm>
+            <a:off x="8220456" y="3511296"/>
             <a:ext cx="3657600" cy="1097280"/>
           </a:xfrm>
           <a:prstGeom prst="rect">
@@ -8474,26 +8581,26 @@
           <a:p>
             <a:pPr algn="ctr"/>
             <a:r>
-              <a:rPr sz="5200" b="1" i="0">
+              <a:rPr sz="3800" b="1" i="0">
                 <a:solidFill>
                   <a:srgbClr val="C9A84C"/>
                 </a:solidFill>
                 <a:latin typeface="Barlow Condensed"/>
               </a:rPr>
-              <a:t>221</a:t>
-            </a:r>
-          </a:p>
-        </p:txBody>
-      </p:sp>
-      <p:sp>
-        <p:nvSpPr>
-          <p:cNvPr id="13" name="TextBox 12"/>
-          <p:cNvSpPr txBox="1"/>
-          <p:nvPr/>
-        </p:nvSpPr>
-        <p:spPr>
-          <a:xfrm>
-            <a:off x="4361688" y="4572000"/>
+              <a:t>12 MIN</a:t>
+            </a:r>
+          </a:p>
+        </p:txBody>
+      </p:sp>
+      <p:sp>
+        <p:nvSpPr>
+          <p:cNvPr id="14" name="TextBox 13"/>
+          <p:cNvSpPr txBox="1"/>
+          <p:nvPr/>
+        </p:nvSpPr>
+        <p:spPr>
+          <a:xfrm>
+            <a:off x="8220456" y="4590288"/>
             <a:ext cx="3657600" cy="304800"/>
           </a:xfrm>
           <a:prstGeom prst="rect">
@@ -8515,76 +8622,6 @@
                 </a:solidFill>
                 <a:latin typeface="Barlow Condensed"/>
               </a:rPr>
-              <a:t>Strategic Triggers</a:t>
-            </a:r>
-          </a:p>
-        </p:txBody>
-      </p:sp>
-      <p:sp>
-        <p:nvSpPr>
-          <p:cNvPr id="14" name="TextBox 13"/>
-          <p:cNvSpPr txBox="1"/>
-          <p:nvPr/>
-        </p:nvSpPr>
-        <p:spPr>
-          <a:xfrm>
-            <a:off x="8220456" y="3493008"/>
-            <a:ext cx="3657600" cy="1097280"/>
-          </a:xfrm>
-          <a:prstGeom prst="rect">
-            <a:avLst/>
-          </a:prstGeom>
-          <a:noFill/>
-        </p:spPr>
-        <p:txBody>
-          <a:bodyPr wrap="square">
-            <a:spAutoFit/>
-          </a:bodyPr>
-          <a:lstStyle/>
-          <a:p>
-            <a:pPr algn="ctr"/>
-            <a:r>
-              <a:rPr sz="3800" b="1" i="0">
-                <a:solidFill>
-                  <a:srgbClr val="C9A84C"/>
-                </a:solidFill>
-                <a:latin typeface="Barlow Condensed"/>
-              </a:rPr>
-              <a:t>12 MIN</a:t>
-            </a:r>
-          </a:p>
-        </p:txBody>
-      </p:sp>
-      <p:sp>
-        <p:nvSpPr>
-          <p:cNvPr id="15" name="TextBox 14"/>
-          <p:cNvSpPr txBox="1"/>
-          <p:nvPr/>
-        </p:nvSpPr>
-        <p:spPr>
-          <a:xfrm>
-            <a:off x="8220456" y="4572000"/>
-            <a:ext cx="3657600" cy="304800"/>
-          </a:xfrm>
-          <a:prstGeom prst="rect">
-            <a:avLst/>
-          </a:prstGeom>
-          <a:noFill/>
-        </p:spPr>
-        <p:txBody>
-          <a:bodyPr wrap="square">
-            <a:spAutoFit/>
-          </a:bodyPr>
-          <a:lstStyle/>
-          <a:p>
-            <a:pPr algn="ctr"/>
-            <a:r>
-              <a:rPr sz="1300" b="0" i="0">
-                <a:solidFill>
-                  <a:srgbClr val="FFFFFF"/>
-                </a:solidFill>
-                <a:latin typeface="Barlow Condensed"/>
-              </a:rPr>
               <a:t>Execution Window</a:t>
             </a:r>
           </a:p>
@@ -8592,13 +8629,13 @@
       </p:sp>
       <p:sp>
         <p:nvSpPr>
-          <p:cNvPr id="16" name="Rectangle 15"/>
+          <p:cNvPr id="15" name="Rectangle 14"/>
           <p:cNvSpPr/>
           <p:nvPr/>
         </p:nvSpPr>
         <p:spPr>
           <a:xfrm>
-            <a:off x="1828800" y="5559552"/>
+            <a:off x="1828800" y="5577840"/>
             <a:ext cx="8531352" cy="475488"/>
           </a:xfrm>
           <a:prstGeom prst="rect">
@@ -8637,42 +8674,42 @@
       </p:sp>
       <p:sp>
         <p:nvSpPr>
+          <p:cNvPr id="16" name="TextBox 15"/>
+          <p:cNvSpPr txBox="1"/>
+          <p:nvPr/>
+        </p:nvSpPr>
+        <p:spPr>
+          <a:xfrm>
+            <a:off x="1920240" y="5669280"/>
+            <a:ext cx="8348472" cy="402336"/>
+          </a:xfrm>
+          <a:prstGeom prst="rect">
+            <a:avLst/>
+          </a:prstGeom>
+          <a:noFill/>
+        </p:spPr>
+        <p:txBody>
+          <a:bodyPr wrap="square">
+            <a:spAutoFit/>
+          </a:bodyPr>
+          <a:lstStyle/>
+          <a:p>
+            <a:pPr algn="ctr"/>
+            <a:r>
+              <a:rPr sz="1400" b="1" i="0">
+                <a:solidFill>
+                  <a:srgbClr val="C9A84C"/>
+                </a:solidFill>
+                <a:latin typeface="Barlow Condensed"/>
+              </a:rPr>
+              <a:t>AI monitors.   Executives authorize.   Teams execute.</a:t>
+            </a:r>
+          </a:p>
+        </p:txBody>
+      </p:sp>
+      <p:sp>
+        <p:nvSpPr>
           <p:cNvPr id="17" name="TextBox 16"/>
-          <p:cNvSpPr txBox="1"/>
-          <p:nvPr/>
-        </p:nvSpPr>
-        <p:spPr>
-          <a:xfrm>
-            <a:off x="1920240" y="5641848"/>
-            <a:ext cx="8348472" cy="402336"/>
-          </a:xfrm>
-          <a:prstGeom prst="rect">
-            <a:avLst/>
-          </a:prstGeom>
-          <a:noFill/>
-        </p:spPr>
-        <p:txBody>
-          <a:bodyPr wrap="square">
-            <a:spAutoFit/>
-          </a:bodyPr>
-          <a:lstStyle/>
-          <a:p>
-            <a:pPr algn="ctr"/>
-            <a:r>
-              <a:rPr sz="1400" b="1" i="0">
-                <a:solidFill>
-                  <a:srgbClr val="C9A84C"/>
-                </a:solidFill>
-                <a:latin typeface="Barlow Condensed"/>
-              </a:rPr>
-              <a:t>AI monitors.   Executives authorize.   Teams execute.</a:t>
-            </a:r>
-          </a:p>
-        </p:txBody>
-      </p:sp>
-      <p:sp>
-        <p:nvSpPr>
-          <p:cNvPr id="18" name="TextBox 17"/>
           <p:cNvSpPr txBox="1"/>
           <p:nvPr/>
         </p:nvSpPr>
@@ -8790,8 +8827,8 @@
         </p:blipFill>
         <p:spPr>
           <a:xfrm>
-            <a:off x="329184" y="6387930"/>
-            <a:ext cx="1389888" cy="373210"/>
+            <a:off x="329184" y="6369635"/>
+            <a:ext cx="1389888" cy="373224"/>
           </a:xfrm>
           <a:prstGeom prst="rect">
             <a:avLst/>
@@ -8876,7 +8913,7 @@
         </p:nvSpPr>
         <p:spPr>
           <a:xfrm>
-            <a:off x="457200" y="1444752"/>
+            <a:off x="457200" y="1463040"/>
             <a:ext cx="11274552" cy="19050"/>
           </a:xfrm>
           <a:prstGeom prst="rect">
@@ -8919,8 +8956,8 @@
         </p:nvSpPr>
         <p:spPr>
           <a:xfrm>
-            <a:off x="329184" y="1554480"/>
-            <a:ext cx="5486400" cy="4462272"/>
+            <a:off x="329184" y="1591056"/>
+            <a:ext cx="5687568" cy="3840480"/>
           </a:xfrm>
           <a:prstGeom prst="rect">
             <a:avLst/>
@@ -8962,8 +8999,8 @@
         </p:nvSpPr>
         <p:spPr>
           <a:xfrm>
-            <a:off x="603504" y="1719072"/>
-            <a:ext cx="5120640" cy="279400"/>
+            <a:off x="603504" y="1755648"/>
+            <a:ext cx="5358384" cy="279400"/>
           </a:xfrm>
           <a:prstGeom prst="rect">
             <a:avLst/>
@@ -8997,8 +9034,8 @@
         </p:nvSpPr>
         <p:spPr>
           <a:xfrm>
-            <a:off x="603504" y="2066543"/>
-            <a:ext cx="5120640" cy="566928"/>
+            <a:off x="603504" y="2084832"/>
+            <a:ext cx="5358384" cy="585216"/>
           </a:xfrm>
           <a:prstGeom prst="rect">
             <a:avLst/>
@@ -9032,8 +9069,8 @@
         </p:nvSpPr>
         <p:spPr>
           <a:xfrm>
-            <a:off x="603504" y="2670047"/>
-            <a:ext cx="5120640" cy="566928"/>
+            <a:off x="603504" y="2724912"/>
+            <a:ext cx="5358384" cy="585216"/>
           </a:xfrm>
           <a:prstGeom prst="rect">
             <a:avLst/>
@@ -9067,8 +9104,8 @@
         </p:nvSpPr>
         <p:spPr>
           <a:xfrm>
-            <a:off x="603504" y="3273551"/>
-            <a:ext cx="5120640" cy="566928"/>
+            <a:off x="603504" y="3364992"/>
+            <a:ext cx="5358384" cy="585216"/>
           </a:xfrm>
           <a:prstGeom prst="rect">
             <a:avLst/>
@@ -9102,8 +9139,8 @@
         </p:nvSpPr>
         <p:spPr>
           <a:xfrm>
-            <a:off x="603504" y="3877055"/>
-            <a:ext cx="5120640" cy="566928"/>
+            <a:off x="603504" y="4005072"/>
+            <a:ext cx="5358384" cy="585216"/>
           </a:xfrm>
           <a:prstGeom prst="rect">
             <a:avLst/>
@@ -9137,8 +9174,8 @@
         </p:nvSpPr>
         <p:spPr>
           <a:xfrm>
-            <a:off x="603504" y="4480559"/>
-            <a:ext cx="5120640" cy="566928"/>
+            <a:off x="603504" y="4645152"/>
+            <a:ext cx="5358384" cy="585216"/>
           </a:xfrm>
           <a:prstGeom prst="rect">
             <a:avLst/>
@@ -9172,8 +9209,8 @@
         </p:nvSpPr>
         <p:spPr>
           <a:xfrm>
-            <a:off x="6373368" y="1554480"/>
-            <a:ext cx="5486400" cy="4462272"/>
+            <a:off x="6172200" y="1591056"/>
+            <a:ext cx="5687568" cy="3840480"/>
           </a:xfrm>
           <a:prstGeom prst="rect">
             <a:avLst/>
@@ -9215,8 +9252,8 @@
         </p:nvSpPr>
         <p:spPr>
           <a:xfrm>
-            <a:off x="6647688" y="1719072"/>
-            <a:ext cx="5120640" cy="279400"/>
+            <a:off x="6446520" y="1755648"/>
+            <a:ext cx="5358384" cy="279400"/>
           </a:xfrm>
           <a:prstGeom prst="rect">
             <a:avLst/>
@@ -9250,8 +9287,8 @@
         </p:nvSpPr>
         <p:spPr>
           <a:xfrm>
-            <a:off x="6647688" y="2066543"/>
-            <a:ext cx="5120640" cy="566928"/>
+            <a:off x="6446520" y="2084832"/>
+            <a:ext cx="5358384" cy="585216"/>
           </a:xfrm>
           <a:prstGeom prst="rect">
             <a:avLst/>
@@ -9285,8 +9322,8 @@
         </p:nvSpPr>
         <p:spPr>
           <a:xfrm>
-            <a:off x="6647688" y="2670047"/>
-            <a:ext cx="5120640" cy="566928"/>
+            <a:off x="6446520" y="2724912"/>
+            <a:ext cx="5358384" cy="585216"/>
           </a:xfrm>
           <a:prstGeom prst="rect">
             <a:avLst/>
@@ -9320,8 +9357,8 @@
         </p:nvSpPr>
         <p:spPr>
           <a:xfrm>
-            <a:off x="6647688" y="3273551"/>
-            <a:ext cx="5120640" cy="566928"/>
+            <a:off x="6446520" y="3364992"/>
+            <a:ext cx="5358384" cy="585216"/>
           </a:xfrm>
           <a:prstGeom prst="rect">
             <a:avLst/>
@@ -9355,8 +9392,8 @@
         </p:nvSpPr>
         <p:spPr>
           <a:xfrm>
-            <a:off x="6647688" y="3877055"/>
-            <a:ext cx="5120640" cy="566928"/>
+            <a:off x="6446520" y="4005072"/>
+            <a:ext cx="5358384" cy="585216"/>
           </a:xfrm>
           <a:prstGeom prst="rect">
             <a:avLst/>
@@ -9390,8 +9427,8 @@
         </p:nvSpPr>
         <p:spPr>
           <a:xfrm>
-            <a:off x="6647688" y="4480559"/>
-            <a:ext cx="5120640" cy="566928"/>
+            <a:off x="6446520" y="4645152"/>
+            <a:ext cx="5358384" cy="585216"/>
           </a:xfrm>
           <a:prstGeom prst="rect">
             <a:avLst/>
@@ -9425,8 +9462,8 @@
         </p:nvSpPr>
         <p:spPr>
           <a:xfrm>
-            <a:off x="6099048" y="1554480"/>
-            <a:ext cx="6350" cy="4462272"/>
+            <a:off x="5989320" y="1591056"/>
+            <a:ext cx="6350" cy="3840480"/>
           </a:xfrm>
           <a:prstGeom prst="rect">
             <a:avLst/>
@@ -9470,15 +9507,15 @@
         </p:nvPicPr>
         <p:blipFill>
           <a:blip r:embed="rId3"/>
-          <a:srcRect t="46193" b="46193"/>
+          <a:srcRect t="-471553" b="-471553"/>
           <a:stretch>
             <a:fillRect/>
           </a:stretch>
         </p:blipFill>
         <p:spPr>
           <a:xfrm>
-            <a:off x="329184" y="5522976"/>
-            <a:ext cx="11530584" cy="493776"/>
+            <a:off x="329184" y="5559552"/>
+            <a:ext cx="11530584" cy="621792"/>
           </a:xfrm>
           <a:prstGeom prst="rect">
             <a:avLst/>
@@ -9493,8 +9530,8 @@
         </p:nvSpPr>
         <p:spPr>
           <a:xfrm>
-            <a:off x="329184" y="5522976"/>
-            <a:ext cx="11530584" cy="493776"/>
+            <a:off x="329184" y="5559552"/>
+            <a:ext cx="11530584" cy="621792"/>
           </a:xfrm>
           <a:prstGeom prst="rect">
             <a:avLst/>
@@ -9536,17 +9573,19 @@
         </p:nvSpPr>
         <p:spPr>
           <a:xfrm>
-            <a:off x="329184" y="5522976"/>
-            <a:ext cx="11530584" cy="493776"/>
+            <a:off x="329184" y="5559552"/>
+            <a:ext cx="11530584" cy="621792"/>
           </a:xfrm>
           <a:prstGeom prst="rect">
             <a:avLst/>
           </a:prstGeom>
           <a:solidFill>
-            <a:srgbClr val="0A0F2E"/>
+            <a:srgbClr val="06081A"/>
           </a:solidFill>
-          <a:ln>
-            <a:noFill/>
+          <a:ln w="10160">
+            <a:solidFill>
+              <a:srgbClr val="C9A84C"/>
+            </a:solidFill>
           </a:ln>
         </p:spPr>
         <p:style>
@@ -9579,8 +9618,8 @@
         </p:nvSpPr>
         <p:spPr>
           <a:xfrm>
-            <a:off x="457200" y="5624576"/>
-            <a:ext cx="11274552" cy="493776"/>
+            <a:off x="457200" y="5737352"/>
+            <a:ext cx="11274552" cy="621792"/>
           </a:xfrm>
           <a:prstGeom prst="rect">
             <a:avLst/>
@@ -9601,7 +9640,7 @@
                 </a:solidFill>
                 <a:latin typeface="Barlow Condensed"/>
               </a:rPr>
-              <a:t>LIVE PLATFORM  ·  170 Readiness Protocols  ·  Startup to Fortune 500</a:t>
+              <a:t>LIVE PLATFORM  ·  170 Readiness Protocols  ·  startup to Fortune 500  ·  vaughnmartin.com</a:t>
             </a:r>
           </a:p>
         </p:txBody>
@@ -9726,8 +9765,8 @@
         </p:blipFill>
         <p:spPr>
           <a:xfrm>
-            <a:off x="329184" y="6387930"/>
-            <a:ext cx="1389888" cy="373210"/>
+            <a:off x="329184" y="6369635"/>
+            <a:ext cx="1389888" cy="373224"/>
           </a:xfrm>
           <a:prstGeom prst="rect">
             <a:avLst/>
@@ -9814,7 +9853,7 @@
         </p:nvPicPr>
         <p:blipFill>
           <a:blip r:embed="rId3"/>
-          <a:srcRect l="8679" r="8679"/>
+          <a:srcRect l="9670" r="9670"/>
           <a:stretch>
             <a:fillRect/>
           </a:stretch>
@@ -9822,7 +9861,7 @@
         <p:spPr>
           <a:xfrm>
             <a:off x="329184" y="1444752"/>
-            <a:ext cx="5669280" cy="3858768"/>
+            <a:ext cx="5559552" cy="3877056"/>
           </a:xfrm>
           <a:prstGeom prst="rect">
             <a:avLst/>
@@ -9838,7 +9877,7 @@
         <p:spPr>
           <a:xfrm>
             <a:off x="329184" y="1444752"/>
-            <a:ext cx="5669280" cy="3858768"/>
+            <a:ext cx="5559552" cy="3877056"/>
           </a:xfrm>
           <a:prstGeom prst="rect">
             <a:avLst/>
@@ -9880,14 +9919,14 @@
         </p:nvSpPr>
         <p:spPr>
           <a:xfrm>
-            <a:off x="329184" y="5065776"/>
-            <a:ext cx="5669280" cy="237744"/>
+            <a:off x="329184" y="5084064"/>
+            <a:ext cx="5559552" cy="237744"/>
           </a:xfrm>
           <a:prstGeom prst="rect">
             <a:avLst/>
           </a:prstGeom>
           <a:solidFill>
-            <a:srgbClr val="080C22"/>
+            <a:srgbClr val="060A1E"/>
           </a:solidFill>
           <a:ln>
             <a:noFill/>
@@ -9923,8 +9962,8 @@
         </p:nvSpPr>
         <p:spPr>
           <a:xfrm>
-            <a:off x="420624" y="5129276"/>
-            <a:ext cx="5486400" cy="237744"/>
+            <a:off x="420624" y="5147564"/>
+            <a:ext cx="5376672" cy="237744"/>
           </a:xfrm>
           <a:prstGeom prst="rect">
             <a:avLst/>
@@ -9945,7 +9984,7 @@
                 </a:solidFill>
                 <a:latin typeface="Barlow Condensed"/>
               </a:rPr>
-              <a:t>LIVE TRIGGER DETECTED WITH CONFIDENCE SCORING</a:t>
+              <a:t>LIVE TRIGGER DETECTION · CONFIDENCE SCORING · STARTUP TO FORTUNE 500</a:t>
             </a:r>
           </a:p>
         </p:txBody>
@@ -9960,15 +9999,15 @@
         </p:nvPicPr>
         <p:blipFill>
           <a:blip r:embed="rId4"/>
-          <a:srcRect l="8679" r="8679"/>
+          <a:srcRect l="8655" r="8655"/>
           <a:stretch>
             <a:fillRect/>
           </a:stretch>
         </p:blipFill>
         <p:spPr>
           <a:xfrm>
-            <a:off x="6190488" y="1444752"/>
-            <a:ext cx="5669280" cy="3858768"/>
+            <a:off x="6163056" y="1444752"/>
+            <a:ext cx="5699455" cy="3877056"/>
           </a:xfrm>
           <a:prstGeom prst="rect">
             <a:avLst/>
@@ -9983,8 +10022,8 @@
         </p:nvSpPr>
         <p:spPr>
           <a:xfrm>
-            <a:off x="6190488" y="1444752"/>
-            <a:ext cx="5669280" cy="3858768"/>
+            <a:off x="6163056" y="1444752"/>
+            <a:ext cx="5699455" cy="3877056"/>
           </a:xfrm>
           <a:prstGeom prst="rect">
             <a:avLst/>
@@ -10026,14 +10065,14 @@
         </p:nvSpPr>
         <p:spPr>
           <a:xfrm>
-            <a:off x="6190488" y="5065776"/>
-            <a:ext cx="5669280" cy="237744"/>
+            <a:off x="6163056" y="5084064"/>
+            <a:ext cx="5699455" cy="237744"/>
           </a:xfrm>
           <a:prstGeom prst="rect">
             <a:avLst/>
           </a:prstGeom>
           <a:solidFill>
-            <a:srgbClr val="080C22"/>
+            <a:srgbClr val="060A1E"/>
           </a:solidFill>
           <a:ln>
             <a:noFill/>
@@ -10069,8 +10108,8 @@
         </p:nvSpPr>
         <p:spPr>
           <a:xfrm>
-            <a:off x="6281928" y="5129276"/>
-            <a:ext cx="5486400" cy="237744"/>
+            <a:off x="6254496" y="5147564"/>
+            <a:ext cx="5516575" cy="237744"/>
           </a:xfrm>
           <a:prstGeom prst="rect">
             <a:avLst/>
@@ -10104,14 +10143,14 @@
         </p:nvSpPr>
         <p:spPr>
           <a:xfrm>
-            <a:off x="0" y="5449824"/>
-            <a:ext cx="12191695" cy="786384"/>
+            <a:off x="0" y="5394960"/>
+            <a:ext cx="12191695" cy="822960"/>
           </a:xfrm>
           <a:prstGeom prst="rect">
             <a:avLst/>
           </a:prstGeom>
           <a:solidFill>
-            <a:srgbClr val="080C22"/>
+            <a:srgbClr val="06081C"/>
           </a:solidFill>
           <a:ln>
             <a:noFill/>
@@ -10147,8 +10186,8 @@
         </p:nvSpPr>
         <p:spPr>
           <a:xfrm>
-            <a:off x="457200" y="5559552"/>
-            <a:ext cx="11274552" cy="457200"/>
+            <a:off x="457200" y="5504688"/>
+            <a:ext cx="11274552" cy="438912"/>
           </a:xfrm>
           <a:prstGeom prst="rect">
             <a:avLst/>
@@ -10182,8 +10221,8 @@
         </p:nvSpPr>
         <p:spPr>
           <a:xfrm>
-            <a:off x="457200" y="6089904"/>
-            <a:ext cx="11274552" cy="310896"/>
+            <a:off x="457200" y="5980176"/>
+            <a:ext cx="11274552" cy="274320"/>
           </a:xfrm>
           <a:prstGeom prst="rect">
             <a:avLst/>
@@ -10329,8 +10368,8 @@
         </p:blipFill>
         <p:spPr>
           <a:xfrm>
-            <a:off x="329184" y="6387930"/>
-            <a:ext cx="1389888" cy="373210"/>
+            <a:off x="329184" y="6369635"/>
+            <a:ext cx="1389888" cy="373224"/>
           </a:xfrm>
           <a:prstGeom prst="rect">
             <a:avLst/>
@@ -10381,7 +10420,7 @@
         <p:spPr>
           <a:xfrm>
             <a:off x="457200" y="694944"/>
-            <a:ext cx="7132320" cy="749808"/>
+            <a:ext cx="7132320" cy="768096"/>
           </a:xfrm>
           <a:prstGeom prst="rect">
             <a:avLst/>
@@ -10415,8 +10454,8 @@
         </p:nvSpPr>
         <p:spPr>
           <a:xfrm>
-            <a:off x="457200" y="1371600"/>
-            <a:ext cx="7132320" cy="749808"/>
+            <a:off x="457200" y="1389888"/>
+            <a:ext cx="7132320" cy="768096"/>
           </a:xfrm>
           <a:prstGeom prst="rect">
             <a:avLst/>
@@ -10450,7 +10489,7 @@
         </p:nvSpPr>
         <p:spPr>
           <a:xfrm>
-            <a:off x="457200" y="2212848"/>
+            <a:off x="457200" y="2231136"/>
             <a:ext cx="11274552" cy="19050"/>
           </a:xfrm>
           <a:prstGeom prst="rect">
@@ -10493,8 +10532,8 @@
         </p:nvSpPr>
         <p:spPr>
           <a:xfrm>
-            <a:off x="457200" y="2395728"/>
-            <a:ext cx="5120640" cy="1261872"/>
+            <a:off x="457200" y="2414016"/>
+            <a:ext cx="5120640" cy="1243584"/>
           </a:xfrm>
           <a:prstGeom prst="rect">
             <a:avLst/>
@@ -10528,7 +10567,7 @@
         </p:nvSpPr>
         <p:spPr>
           <a:xfrm>
-            <a:off x="457200" y="3529584"/>
+            <a:off x="457200" y="3547872"/>
             <a:ext cx="5120640" cy="330200"/>
           </a:xfrm>
           <a:prstGeom prst="rect">
@@ -10550,7 +10589,7 @@
                 </a:solidFill>
                 <a:latin typeface="Barlow Condensed"/>
               </a:rPr>
-              <a:t>Execution head start vs. old mobilization model</a:t>
+              <a:t>Execution head start — 30 days compressed to 12 minutes</a:t>
             </a:r>
           </a:p>
         </p:txBody>
@@ -10563,7 +10602,7 @@
         </p:nvSpPr>
         <p:spPr>
           <a:xfrm>
-            <a:off x="457200" y="3877056"/>
+            <a:off x="457200" y="3895344"/>
             <a:ext cx="5120640" cy="19050"/>
           </a:xfrm>
           <a:prstGeom prst="rect">
@@ -10606,7 +10645,7 @@
         </p:nvSpPr>
         <p:spPr>
           <a:xfrm>
-            <a:off x="457200" y="4078224"/>
+            <a:off x="457200" y="4096512"/>
             <a:ext cx="5120640" cy="530352"/>
           </a:xfrm>
           <a:prstGeom prst="rect">
@@ -10641,7 +10680,7 @@
         </p:nvSpPr>
         <p:spPr>
           <a:xfrm>
-            <a:off x="457200" y="4645152"/>
+            <a:off x="457200" y="4663440"/>
             <a:ext cx="5120640" cy="530352"/>
           </a:xfrm>
           <a:prstGeom prst="rect">
@@ -10676,7 +10715,7 @@
         </p:nvSpPr>
         <p:spPr>
           <a:xfrm>
-            <a:off x="457200" y="5212080"/>
+            <a:off x="457200" y="5230368"/>
             <a:ext cx="5120640" cy="530352"/>
           </a:xfrm>
           <a:prstGeom prst="rect">
@@ -10711,8 +10750,8 @@
         </p:nvSpPr>
         <p:spPr>
           <a:xfrm>
-            <a:off x="6217920" y="2340864"/>
-            <a:ext cx="5641848" cy="3858768"/>
+            <a:off x="6236208" y="2359152"/>
+            <a:ext cx="5623560" cy="3803904"/>
           </a:xfrm>
           <a:prstGeom prst="rect">
             <a:avLst/>
@@ -10754,7 +10793,7 @@
         </p:nvSpPr>
         <p:spPr>
           <a:xfrm>
-            <a:off x="6492240" y="2523744"/>
+            <a:off x="6510528" y="2542032"/>
             <a:ext cx="10972800" cy="203200"/>
           </a:xfrm>
           <a:prstGeom prst="rect">
@@ -10789,8 +10828,8 @@
         </p:nvSpPr>
         <p:spPr>
           <a:xfrm>
-            <a:off x="6675120" y="2724912"/>
-            <a:ext cx="5102352" cy="694944"/>
+            <a:off x="6693408" y="2743200"/>
+            <a:ext cx="5084064" cy="694944"/>
           </a:xfrm>
           <a:prstGeom prst="rect">
             <a:avLst/>
@@ -10825,8 +10864,8 @@
         </p:nvSpPr>
         <p:spPr>
           <a:xfrm>
-            <a:off x="6492240" y="3522472"/>
-            <a:ext cx="5120640" cy="6350"/>
+            <a:off x="6510528" y="3540760"/>
+            <a:ext cx="5084064" cy="6350"/>
           </a:xfrm>
           <a:prstGeom prst="rect">
             <a:avLst/>
@@ -10868,7 +10907,7 @@
         </p:nvSpPr>
         <p:spPr>
           <a:xfrm>
-            <a:off x="6492240" y="3547872"/>
+            <a:off x="6510528" y="3566160"/>
             <a:ext cx="2103120" cy="304800"/>
           </a:xfrm>
           <a:prstGeom prst="rect">
@@ -10903,7 +10942,7 @@
         </p:nvSpPr>
         <p:spPr>
           <a:xfrm>
-            <a:off x="8686800" y="3547872"/>
+            <a:off x="8705088" y="3566160"/>
             <a:ext cx="2834640" cy="304800"/>
           </a:xfrm>
           <a:prstGeom prst="rect">
@@ -10938,8 +10977,8 @@
         </p:nvSpPr>
         <p:spPr>
           <a:xfrm>
-            <a:off x="6492240" y="4125976"/>
-            <a:ext cx="5120640" cy="6350"/>
+            <a:off x="6510528" y="4144264"/>
+            <a:ext cx="5084064" cy="6350"/>
           </a:xfrm>
           <a:prstGeom prst="rect">
             <a:avLst/>
@@ -10981,7 +11020,7 @@
         </p:nvSpPr>
         <p:spPr>
           <a:xfrm>
-            <a:off x="6492240" y="4151376"/>
+            <a:off x="6510528" y="4169664"/>
             <a:ext cx="2103120" cy="304800"/>
           </a:xfrm>
           <a:prstGeom prst="rect">
@@ -11016,7 +11055,7 @@
         </p:nvSpPr>
         <p:spPr>
           <a:xfrm>
-            <a:off x="8686800" y="4151376"/>
+            <a:off x="8705088" y="4169664"/>
             <a:ext cx="2834640" cy="304800"/>
           </a:xfrm>
           <a:prstGeom prst="rect">
@@ -11051,8 +11090,8 @@
         </p:nvSpPr>
         <p:spPr>
           <a:xfrm>
-            <a:off x="6492240" y="4729480"/>
-            <a:ext cx="5120640" cy="6350"/>
+            <a:off x="6510528" y="4747768"/>
+            <a:ext cx="5084064" cy="6350"/>
           </a:xfrm>
           <a:prstGeom prst="rect">
             <a:avLst/>
@@ -11094,7 +11133,7 @@
         </p:nvSpPr>
         <p:spPr>
           <a:xfrm>
-            <a:off x="6492240" y="4754880"/>
+            <a:off x="6510528" y="4773168"/>
             <a:ext cx="2103120" cy="304800"/>
           </a:xfrm>
           <a:prstGeom prst="rect">
@@ -11129,7 +11168,7 @@
         </p:nvSpPr>
         <p:spPr>
           <a:xfrm>
-            <a:off x="8686800" y="4754880"/>
+            <a:off x="8705088" y="4773168"/>
             <a:ext cx="2834640" cy="304800"/>
           </a:xfrm>
           <a:prstGeom prst="rect">
@@ -11164,8 +11203,8 @@
         </p:nvSpPr>
         <p:spPr>
           <a:xfrm>
-            <a:off x="6492240" y="5332984"/>
-            <a:ext cx="5120640" cy="6350"/>
+            <a:off x="6510528" y="5351272"/>
+            <a:ext cx="5084064" cy="6350"/>
           </a:xfrm>
           <a:prstGeom prst="rect">
             <a:avLst/>
@@ -11207,7 +11246,7 @@
         </p:nvSpPr>
         <p:spPr>
           <a:xfrm>
-            <a:off x="6492240" y="5358384"/>
+            <a:off x="6510528" y="5376672"/>
             <a:ext cx="2103120" cy="304800"/>
           </a:xfrm>
           <a:prstGeom prst="rect">
@@ -11242,7 +11281,7 @@
         </p:nvSpPr>
         <p:spPr>
           <a:xfrm>
-            <a:off x="8686800" y="5358384"/>
+            <a:off x="8705088" y="5376672"/>
             <a:ext cx="2834640" cy="304800"/>
           </a:xfrm>
           <a:prstGeom prst="rect">
@@ -11277,8 +11316,8 @@
         </p:nvSpPr>
         <p:spPr>
           <a:xfrm>
-            <a:off x="6035040" y="2157984"/>
-            <a:ext cx="6350" cy="4096512"/>
+            <a:off x="6053328" y="2176272"/>
+            <a:ext cx="6350" cy="4078224"/>
           </a:xfrm>
           <a:prstGeom prst="rect">
             <a:avLst/>
@@ -11432,8 +11471,8 @@
         </p:blipFill>
         <p:spPr>
           <a:xfrm>
-            <a:off x="329184" y="6387930"/>
-            <a:ext cx="1389888" cy="373210"/>
+            <a:off x="329184" y="6369635"/>
+            <a:ext cx="1389888" cy="373224"/>
           </a:xfrm>
           <a:prstGeom prst="rect">
             <a:avLst/>
@@ -11518,8 +11557,8 @@
         </p:nvSpPr>
         <p:spPr>
           <a:xfrm>
-            <a:off x="329184" y="1463040"/>
-            <a:ext cx="2834640" cy="1005840"/>
+            <a:off x="329184" y="1481328"/>
+            <a:ext cx="2834640" cy="987552"/>
           </a:xfrm>
           <a:prstGeom prst="rect">
             <a:avLst/>
@@ -11561,8 +11600,8 @@
         </p:nvSpPr>
         <p:spPr>
           <a:xfrm>
-            <a:off x="329184" y="1499616"/>
-            <a:ext cx="2834640" cy="621792"/>
+            <a:off x="329184" y="1517904"/>
+            <a:ext cx="2834640" cy="603504"/>
           </a:xfrm>
           <a:prstGeom prst="rect">
             <a:avLst/>
@@ -11631,8 +11670,8 @@
         </p:nvSpPr>
         <p:spPr>
           <a:xfrm>
-            <a:off x="3291840" y="1463040"/>
-            <a:ext cx="2834640" cy="1005840"/>
+            <a:off x="3291840" y="1481328"/>
+            <a:ext cx="2834640" cy="987552"/>
           </a:xfrm>
           <a:prstGeom prst="rect">
             <a:avLst/>
@@ -11674,8 +11713,8 @@
         </p:nvSpPr>
         <p:spPr>
           <a:xfrm>
-            <a:off x="3291840" y="1499616"/>
-            <a:ext cx="2834640" cy="621792"/>
+            <a:off x="3291840" y="1517904"/>
+            <a:ext cx="2834640" cy="603504"/>
           </a:xfrm>
           <a:prstGeom prst="rect">
             <a:avLst/>
@@ -11744,8 +11783,8 @@
         </p:nvSpPr>
         <p:spPr>
           <a:xfrm>
-            <a:off x="6254496" y="1463040"/>
-            <a:ext cx="2834640" cy="1005840"/>
+            <a:off x="6254496" y="1481328"/>
+            <a:ext cx="2834640" cy="987552"/>
           </a:xfrm>
           <a:prstGeom prst="rect">
             <a:avLst/>
@@ -11787,8 +11826,8 @@
         </p:nvSpPr>
         <p:spPr>
           <a:xfrm>
-            <a:off x="6254496" y="1499616"/>
-            <a:ext cx="2834640" cy="621792"/>
+            <a:off x="6254496" y="1517904"/>
+            <a:ext cx="2834640" cy="603504"/>
           </a:xfrm>
           <a:prstGeom prst="rect">
             <a:avLst/>
@@ -11857,8 +11896,8 @@
         </p:nvSpPr>
         <p:spPr>
           <a:xfrm>
-            <a:off x="9217152" y="1463040"/>
-            <a:ext cx="2834640" cy="1005840"/>
+            <a:off x="9217152" y="1481328"/>
+            <a:ext cx="2834640" cy="987552"/>
           </a:xfrm>
           <a:prstGeom prst="rect">
             <a:avLst/>
@@ -11900,8 +11939,8 @@
         </p:nvSpPr>
         <p:spPr>
           <a:xfrm>
-            <a:off x="9217152" y="1499616"/>
-            <a:ext cx="2834640" cy="621792"/>
+            <a:off x="9217152" y="1517904"/>
+            <a:ext cx="2834640" cy="603504"/>
           </a:xfrm>
           <a:prstGeom prst="rect">
             <a:avLst/>
@@ -11972,7 +12011,7 @@
         </p:nvPicPr>
         <p:blipFill>
           <a:blip r:embed="rId3"/>
-          <a:srcRect t="14990" b="14990"/>
+          <a:srcRect t="-17871" b="-17871"/>
           <a:stretch>
             <a:fillRect/>
           </a:stretch>
@@ -11980,7 +12019,7 @@
         <p:spPr>
           <a:xfrm>
             <a:off x="329184" y="2633472"/>
-            <a:ext cx="7754112" cy="3054096"/>
+            <a:ext cx="7370064" cy="3054096"/>
           </a:xfrm>
           <a:prstGeom prst="rect">
             <a:avLst/>
@@ -11996,7 +12035,7 @@
         <p:spPr>
           <a:xfrm>
             <a:off x="329184" y="2633472"/>
-            <a:ext cx="7754112" cy="3054096"/>
+            <a:ext cx="7370064" cy="3054096"/>
           </a:xfrm>
           <a:prstGeom prst="rect">
             <a:avLst/>
@@ -12039,13 +12078,13 @@
         <p:spPr>
           <a:xfrm>
             <a:off x="329184" y="5449824"/>
-            <a:ext cx="7754112" cy="237744"/>
+            <a:ext cx="7370064" cy="237744"/>
           </a:xfrm>
           <a:prstGeom prst="rect">
             <a:avLst/>
           </a:prstGeom>
           <a:solidFill>
-            <a:srgbClr val="080C22"/>
+            <a:srgbClr val="060A1E"/>
           </a:solidFill>
           <a:ln>
             <a:noFill/>
@@ -12082,7 +12121,7 @@
         <p:spPr>
           <a:xfrm>
             <a:off x="420624" y="5513324"/>
-            <a:ext cx="7571232" cy="237744"/>
+            <a:ext cx="7187184" cy="237744"/>
           </a:xfrm>
           <a:prstGeom prst="rect">
             <a:avLst/>
@@ -12118,15 +12157,15 @@
         </p:nvPicPr>
         <p:blipFill>
           <a:blip r:embed="rId4"/>
-          <a:srcRect l="16570" r="16570"/>
+          <a:srcRect l="14187" r="14187"/>
           <a:stretch>
             <a:fillRect/>
           </a:stretch>
         </p:blipFill>
         <p:spPr>
           <a:xfrm>
-            <a:off x="8229600" y="2633472"/>
-            <a:ext cx="3630168" cy="3054096"/>
+            <a:off x="7973568" y="2633472"/>
+            <a:ext cx="3888943" cy="3054096"/>
           </a:xfrm>
           <a:prstGeom prst="rect">
             <a:avLst/>
@@ -12141,8 +12180,8 @@
         </p:nvSpPr>
         <p:spPr>
           <a:xfrm>
-            <a:off x="8229600" y="2633472"/>
-            <a:ext cx="3630168" cy="3054096"/>
+            <a:off x="7973568" y="2633472"/>
+            <a:ext cx="3888943" cy="3054096"/>
           </a:xfrm>
           <a:prstGeom prst="rect">
             <a:avLst/>
@@ -12184,14 +12223,14 @@
         </p:nvSpPr>
         <p:spPr>
           <a:xfrm>
-            <a:off x="8229600" y="5449824"/>
-            <a:ext cx="3630168" cy="237744"/>
+            <a:off x="7973568" y="5449824"/>
+            <a:ext cx="3888943" cy="237744"/>
           </a:xfrm>
           <a:prstGeom prst="rect">
             <a:avLst/>
           </a:prstGeom>
           <a:solidFill>
-            <a:srgbClr val="080C22"/>
+            <a:srgbClr val="060A1E"/>
           </a:solidFill>
           <a:ln>
             <a:noFill/>
@@ -12227,8 +12266,8 @@
         </p:nvSpPr>
         <p:spPr>
           <a:xfrm>
-            <a:off x="8321040" y="5513324"/>
-            <a:ext cx="3447288" cy="237744"/>
+            <a:off x="8065008" y="5513324"/>
+            <a:ext cx="3706063" cy="237744"/>
           </a:xfrm>
           <a:prstGeom prst="rect">
             <a:avLst/>
@@ -12374,8 +12413,8 @@
         </p:blipFill>
         <p:spPr>
           <a:xfrm>
-            <a:off x="329184" y="6387930"/>
-            <a:ext cx="1389888" cy="373210"/>
+            <a:off x="329184" y="6369635"/>
+            <a:ext cx="1389888" cy="373224"/>
           </a:xfrm>
           <a:prstGeom prst="rect">
             <a:avLst/>
@@ -12392,15 +12431,15 @@
         </p:nvPicPr>
         <p:blipFill>
           <a:blip r:embed="rId3"/>
-          <a:srcRect l="26285" r="26285"/>
+          <a:srcRect l="22831" r="22831"/>
           <a:stretch>
             <a:fillRect/>
           </a:stretch>
         </p:blipFill>
         <p:spPr>
           <a:xfrm>
-            <a:off x="6858000" y="73152"/>
-            <a:ext cx="5212080" cy="6181344"/>
+            <a:off x="6400800" y="512064"/>
+            <a:ext cx="5458968" cy="5650992"/>
           </a:xfrm>
           <a:prstGeom prst="rect">
             <a:avLst/>
@@ -12415,8 +12454,8 @@
         </p:nvSpPr>
         <p:spPr>
           <a:xfrm>
-            <a:off x="6858000" y="73152"/>
-            <a:ext cx="5212080" cy="6181344"/>
+            <a:off x="6400800" y="512064"/>
+            <a:ext cx="5458968" cy="5650992"/>
           </a:xfrm>
           <a:prstGeom prst="rect">
             <a:avLst/>
@@ -12458,14 +12497,14 @@
         </p:nvSpPr>
         <p:spPr>
           <a:xfrm>
-            <a:off x="6400800" y="73152"/>
-            <a:ext cx="1097280" cy="6181344"/>
+            <a:off x="6400800" y="5925312"/>
+            <a:ext cx="5458968" cy="237744"/>
           </a:xfrm>
           <a:prstGeom prst="rect">
             <a:avLst/>
           </a:prstGeom>
           <a:solidFill>
-            <a:srgbClr val="F2F0EB"/>
+            <a:srgbClr val="060A1E"/>
           </a:solidFill>
           <a:ln>
             <a:noFill/>
@@ -12501,8 +12540,8 @@
         </p:nvSpPr>
         <p:spPr>
           <a:xfrm>
-            <a:off x="457200" y="438912"/>
-            <a:ext cx="10972800" cy="203200"/>
+            <a:off x="6492240" y="5988812"/>
+            <a:ext cx="5276088" cy="237744"/>
           </a:xfrm>
           <a:prstGeom prst="rect">
             <a:avLst/>
@@ -12517,62 +12556,27 @@
           <a:p>
             <a:pPr algn="l"/>
             <a:r>
-              <a:rPr sz="900" b="1" i="0">
-                <a:solidFill>
-                  <a:srgbClr val="444A68"/>
-                </a:solidFill>
-                <a:latin typeface="Barlow Condensed"/>
-              </a:rPr>
-              <a:t>WHY NOW</a:t>
-            </a:r>
-          </a:p>
-        </p:txBody>
-      </p:sp>
-      <p:sp>
-        <p:nvSpPr>
-          <p:cNvPr id="8" name="TextBox 7"/>
-          <p:cNvSpPr txBox="1"/>
-          <p:nvPr/>
-        </p:nvSpPr>
-        <p:spPr>
-          <a:xfrm>
-            <a:off x="457200" y="694944"/>
-            <a:ext cx="6126480" cy="1024128"/>
-          </a:xfrm>
-          <a:prstGeom prst="rect">
-            <a:avLst/>
-          </a:prstGeom>
-          <a:noFill/>
-        </p:spPr>
-        <p:txBody>
-          <a:bodyPr wrap="square">
-            <a:spAutoFit/>
-          </a:bodyPr>
-          <a:lstStyle/>
-          <a:p>
-            <a:pPr algn="l"/>
-            <a:r>
-              <a:rPr sz="2800" b="1">
-                <a:solidFill>
-                  <a:srgbClr val="0A0F2E"/>
-                </a:solidFill>
-                <a:latin typeface="Barlow Condensed"/>
-              </a:rPr>
-              <a:t>AI capability is accelerating faster than enterprise readiness.</a:t>
-            </a:r>
-          </a:p>
-        </p:txBody>
-      </p:sp>
-      <p:sp>
-        <p:nvSpPr>
-          <p:cNvPr id="9" name="Rectangle 8"/>
+              <a:rPr sz="800" b="1" i="0">
+                <a:solidFill>
+                  <a:srgbClr val="C9A84C"/>
+                </a:solidFill>
+                <a:latin typeface="Barlow Condensed"/>
+              </a:rPr>
+              <a:t>READINESS OS · PRODUCTION PLATFORM · VAUGHNMARTIN.COM</a:t>
+            </a:r>
+          </a:p>
+        </p:txBody>
+      </p:sp>
+      <p:sp>
+        <p:nvSpPr>
+          <p:cNvPr id="8" name="Rectangle 7"/>
           <p:cNvSpPr/>
           <p:nvPr/>
         </p:nvSpPr>
         <p:spPr>
           <a:xfrm>
-            <a:off x="457200" y="1810512"/>
-            <a:ext cx="6126480" cy="19050"/>
+            <a:off x="6272784" y="512064"/>
+            <a:ext cx="12700" cy="5650992"/>
           </a:xfrm>
           <a:prstGeom prst="rect">
             <a:avLst/>
@@ -12608,14 +12612,49 @@
       </p:sp>
       <p:sp>
         <p:nvSpPr>
+          <p:cNvPr id="9" name="TextBox 8"/>
+          <p:cNvSpPr txBox="1"/>
+          <p:nvPr/>
+        </p:nvSpPr>
+        <p:spPr>
+          <a:xfrm>
+            <a:off x="457200" y="475488"/>
+            <a:ext cx="10972800" cy="203200"/>
+          </a:xfrm>
+          <a:prstGeom prst="rect">
+            <a:avLst/>
+          </a:prstGeom>
+          <a:noFill/>
+        </p:spPr>
+        <p:txBody>
+          <a:bodyPr wrap="square">
+            <a:spAutoFit/>
+          </a:bodyPr>
+          <a:lstStyle/>
+          <a:p>
+            <a:pPr algn="l"/>
+            <a:r>
+              <a:rPr sz="900" b="1" i="0">
+                <a:solidFill>
+                  <a:srgbClr val="444A68"/>
+                </a:solidFill>
+                <a:latin typeface="Barlow Condensed"/>
+              </a:rPr>
+              <a:t>WHY NOW</a:t>
+            </a:r>
+          </a:p>
+        </p:txBody>
+      </p:sp>
+      <p:sp>
+        <p:nvSpPr>
           <p:cNvPr id="10" name="TextBox 9"/>
           <p:cNvSpPr txBox="1"/>
           <p:nvPr/>
         </p:nvSpPr>
         <p:spPr>
           <a:xfrm>
-            <a:off x="457200" y="2029968"/>
-            <a:ext cx="621792" cy="822960"/>
+            <a:off x="457200" y="749808"/>
+            <a:ext cx="5632704" cy="1024128"/>
           </a:xfrm>
           <a:prstGeom prst="rect">
             <a:avLst/>
@@ -12630,6 +12669,84 @@
           <a:p>
             <a:pPr algn="l"/>
             <a:r>
+              <a:rPr sz="2600" b="1">
+                <a:solidFill>
+                  <a:srgbClr val="0A0F2E"/>
+                </a:solidFill>
+                <a:latin typeface="Barlow Condensed"/>
+              </a:rPr>
+              <a:t>AI capability is accelerating faster than enterprise readiness.</a:t>
+            </a:r>
+          </a:p>
+        </p:txBody>
+      </p:sp>
+      <p:sp>
+        <p:nvSpPr>
+          <p:cNvPr id="11" name="Rectangle 10"/>
+          <p:cNvSpPr/>
+          <p:nvPr/>
+        </p:nvSpPr>
+        <p:spPr>
+          <a:xfrm>
+            <a:off x="457200" y="1847088"/>
+            <a:ext cx="5632704" cy="19050"/>
+          </a:xfrm>
+          <a:prstGeom prst="rect">
+            <a:avLst/>
+          </a:prstGeom>
+          <a:solidFill>
+            <a:srgbClr val="887850"/>
+          </a:solidFill>
+          <a:ln>
+            <a:noFill/>
+          </a:ln>
+        </p:spPr>
+        <p:style>
+          <a:lnRef idx="1">
+            <a:schemeClr val="accent1"/>
+          </a:lnRef>
+          <a:fillRef idx="3">
+            <a:schemeClr val="accent1"/>
+          </a:fillRef>
+          <a:effectRef idx="2">
+            <a:schemeClr val="accent1"/>
+          </a:effectRef>
+          <a:fontRef idx="minor">
+            <a:schemeClr val="lt1"/>
+          </a:fontRef>
+        </p:style>
+        <p:txBody>
+          <a:bodyPr rtlCol="0" anchor="ctr"/>
+          <a:lstStyle/>
+          <a:p>
+            <a:pPr algn="ctr"/>
+          </a:p>
+        </p:txBody>
+      </p:sp>
+      <p:sp>
+        <p:nvSpPr>
+          <p:cNvPr id="12" name="TextBox 11"/>
+          <p:cNvSpPr txBox="1"/>
+          <p:nvPr/>
+        </p:nvSpPr>
+        <p:spPr>
+          <a:xfrm>
+            <a:off x="457200" y="2066543"/>
+            <a:ext cx="658368" cy="841248"/>
+          </a:xfrm>
+          <a:prstGeom prst="rect">
+            <a:avLst/>
+          </a:prstGeom>
+          <a:noFill/>
+        </p:spPr>
+        <p:txBody>
+          <a:bodyPr wrap="square">
+            <a:spAutoFit/>
+          </a:bodyPr>
+          <a:lstStyle/>
+          <a:p>
+            <a:pPr algn="l"/>
+            <a:r>
               <a:rPr sz="2200" b="1" i="0">
                 <a:solidFill>
                   <a:srgbClr val="C9A84C"/>
@@ -12643,14 +12760,14 @@
       </p:sp>
       <p:sp>
         <p:nvSpPr>
-          <p:cNvPr id="11" name="TextBox 10"/>
-          <p:cNvSpPr txBox="1"/>
-          <p:nvPr/>
-        </p:nvSpPr>
-        <p:spPr>
-          <a:xfrm>
-            <a:off x="1152144" y="2029968"/>
-            <a:ext cx="5321808" cy="822960"/>
+          <p:cNvPr id="13" name="TextBox 12"/>
+          <p:cNvSpPr txBox="1"/>
+          <p:nvPr/>
+        </p:nvSpPr>
+        <p:spPr>
+          <a:xfrm>
+            <a:off x="1188720" y="2066543"/>
+            <a:ext cx="4901184" cy="841248"/>
           </a:xfrm>
           <a:prstGeom prst="rect">
             <a:avLst/>
@@ -12665,7 +12782,7 @@
           <a:p>
             <a:pPr algn="l"/>
             <a:r>
-              <a:rPr sz="1600" b="0" i="0">
+              <a:rPr sz="1500" b="0" i="0">
                 <a:solidFill>
                   <a:srgbClr val="0A0F2E"/>
                 </a:solidFill>
@@ -12678,14 +12795,14 @@
       </p:sp>
       <p:sp>
         <p:nvSpPr>
-          <p:cNvPr id="12" name="TextBox 11"/>
-          <p:cNvSpPr txBox="1"/>
-          <p:nvPr/>
-        </p:nvSpPr>
-        <p:spPr>
-          <a:xfrm>
-            <a:off x="457200" y="3163824"/>
-            <a:ext cx="621792" cy="822960"/>
+          <p:cNvPr id="14" name="TextBox 13"/>
+          <p:cNvSpPr txBox="1"/>
+          <p:nvPr/>
+        </p:nvSpPr>
+        <p:spPr>
+          <a:xfrm>
+            <a:off x="457200" y="3236975"/>
+            <a:ext cx="658368" cy="841248"/>
           </a:xfrm>
           <a:prstGeom prst="rect">
             <a:avLst/>
@@ -12713,14 +12830,14 @@
       </p:sp>
       <p:sp>
         <p:nvSpPr>
-          <p:cNvPr id="13" name="TextBox 12"/>
-          <p:cNvSpPr txBox="1"/>
-          <p:nvPr/>
-        </p:nvSpPr>
-        <p:spPr>
-          <a:xfrm>
-            <a:off x="1152144" y="3163824"/>
-            <a:ext cx="5321808" cy="822960"/>
+          <p:cNvPr id="15" name="TextBox 14"/>
+          <p:cNvSpPr txBox="1"/>
+          <p:nvPr/>
+        </p:nvSpPr>
+        <p:spPr>
+          <a:xfrm>
+            <a:off x="1188720" y="3236975"/>
+            <a:ext cx="4901184" cy="841248"/>
           </a:xfrm>
           <a:prstGeom prst="rect">
             <a:avLst/>
@@ -12735,7 +12852,7 @@
           <a:p>
             <a:pPr algn="l"/>
             <a:r>
-              <a:rPr sz="1600" b="0" i="0">
+              <a:rPr sz="1500" b="0" i="0">
                 <a:solidFill>
                   <a:srgbClr val="0A0F2E"/>
                 </a:solidFill>
@@ -12748,14 +12865,14 @@
       </p:sp>
       <p:sp>
         <p:nvSpPr>
-          <p:cNvPr id="14" name="TextBox 13"/>
-          <p:cNvSpPr txBox="1"/>
-          <p:nvPr/>
-        </p:nvSpPr>
-        <p:spPr>
-          <a:xfrm>
-            <a:off x="457200" y="4297680"/>
-            <a:ext cx="621792" cy="822960"/>
+          <p:cNvPr id="16" name="TextBox 15"/>
+          <p:cNvSpPr txBox="1"/>
+          <p:nvPr/>
+        </p:nvSpPr>
+        <p:spPr>
+          <a:xfrm>
+            <a:off x="457200" y="4407407"/>
+            <a:ext cx="658368" cy="841248"/>
           </a:xfrm>
           <a:prstGeom prst="rect">
             <a:avLst/>
@@ -12783,14 +12900,14 @@
       </p:sp>
       <p:sp>
         <p:nvSpPr>
-          <p:cNvPr id="15" name="TextBox 14"/>
-          <p:cNvSpPr txBox="1"/>
-          <p:nvPr/>
-        </p:nvSpPr>
-        <p:spPr>
-          <a:xfrm>
-            <a:off x="1152144" y="4297680"/>
-            <a:ext cx="5321808" cy="822960"/>
+          <p:cNvPr id="17" name="TextBox 16"/>
+          <p:cNvSpPr txBox="1"/>
+          <p:nvPr/>
+        </p:nvSpPr>
+        <p:spPr>
+          <a:xfrm>
+            <a:off x="1188720" y="4407407"/>
+            <a:ext cx="4901184" cy="841248"/>
           </a:xfrm>
           <a:prstGeom prst="rect">
             <a:avLst/>
@@ -12805,27 +12922,27 @@
           <a:p>
             <a:pPr algn="l"/>
             <a:r>
-              <a:rPr sz="1600" b="0" i="0">
+              <a:rPr sz="1500" b="0" i="0">
                 <a:solidFill>
                   <a:srgbClr val="0A0F2E"/>
                 </a:solidFill>
                 <a:latin typeface="Barlow Condensed"/>
               </a:rPr>
-              <a:t>Winners pair AI sensing with governed 12-minute execution speed.</a:t>
-            </a:r>
-          </a:p>
-        </p:txBody>
-      </p:sp>
-      <p:sp>
-        <p:nvSpPr>
-          <p:cNvPr id="16" name="TextBox 15"/>
-          <p:cNvSpPr txBox="1"/>
-          <p:nvPr/>
-        </p:nvSpPr>
-        <p:spPr>
-          <a:xfrm>
-            <a:off x="457200" y="5449824"/>
-            <a:ext cx="6126480" cy="304800"/>
+              <a:t>Winners pair signal detection with governed 12-minute execution.</a:t>
+            </a:r>
+          </a:p>
+        </p:txBody>
+      </p:sp>
+      <p:sp>
+        <p:nvSpPr>
+          <p:cNvPr id="18" name="TextBox 17"/>
+          <p:cNvSpPr txBox="1"/>
+          <p:nvPr/>
+        </p:nvSpPr>
+        <p:spPr>
+          <a:xfrm>
+            <a:off x="457200" y="5577840"/>
+            <a:ext cx="5632704" cy="304800"/>
           </a:xfrm>
           <a:prstGeom prst="rect">
             <a:avLst/>
@@ -12853,7 +12970,7 @@
       </p:sp>
       <p:sp>
         <p:nvSpPr>
-          <p:cNvPr id="17" name="TextBox 16"/>
+          <p:cNvPr id="19" name="TextBox 18"/>
           <p:cNvSpPr txBox="1"/>
           <p:nvPr/>
         </p:nvSpPr>

</xml_diff>

<commit_message>
Fix cutoff images on presentation slides 6 and 9
Adjust image frame dimensions in scripts/build_pptx.py to match native 16:9 aspect ratio, resolving cutoff issues on slides 6 and 9.

Replit-Commit-Author: Agent
Replit-Commit-Session-Id: 85f09f3c-352d-446d-b98e-3f307c26fc5a
Replit-Commit-Checkpoint-Type: full_checkpoint
Replit-Commit-Event-Id: df2437ae-5a77-4ce5-bd96-5b232c5186a1
Replit-Commit-Screenshot-Url: https://storage.googleapis.com/screenshot-production-us-central1/3bd53afc-ff4f-401b-9e3d-b367791ef629/85f09f3c-352d-446d-b98e-3f307c26fc5a/v9XelxY
Replit-Helium-Checkpoint-Created: true
</commit_message>
<xml_diff>
--- a/attached_assets/VaughnMartin-Investor-Pitch-Deck-v10.pptx
+++ b/attached_assets/VaughnMartin-Investor-Pitch-Deck-v10.pptx
@@ -9853,15 +9853,15 @@
         </p:nvPicPr>
         <p:blipFill>
           <a:blip r:embed="rId3"/>
-          <a:srcRect l="9670" r="9670"/>
+          <a:srcRect t="-6" b="-6"/>
           <a:stretch>
             <a:fillRect/>
           </a:stretch>
         </p:blipFill>
         <p:spPr>
           <a:xfrm>
-            <a:off x="329184" y="1444752"/>
-            <a:ext cx="5559552" cy="3877056"/>
+            <a:off x="329184" y="1481328"/>
+            <a:ext cx="5623560" cy="3162857"/>
           </a:xfrm>
           <a:prstGeom prst="rect">
             <a:avLst/>
@@ -9876,8 +9876,8 @@
         </p:nvSpPr>
         <p:spPr>
           <a:xfrm>
-            <a:off x="329184" y="1444752"/>
-            <a:ext cx="5559552" cy="3877056"/>
+            <a:off x="329184" y="1481328"/>
+            <a:ext cx="5623560" cy="3162857"/>
           </a:xfrm>
           <a:prstGeom prst="rect">
             <a:avLst/>
@@ -9919,8 +9919,8 @@
         </p:nvSpPr>
         <p:spPr>
           <a:xfrm>
-            <a:off x="329184" y="5084064"/>
-            <a:ext cx="5559552" cy="237744"/>
+            <a:off x="329184" y="4406441"/>
+            <a:ext cx="5623560" cy="237744"/>
           </a:xfrm>
           <a:prstGeom prst="rect">
             <a:avLst/>
@@ -9962,8 +9962,8 @@
         </p:nvSpPr>
         <p:spPr>
           <a:xfrm>
-            <a:off x="420624" y="5147564"/>
-            <a:ext cx="5376672" cy="237744"/>
+            <a:off x="420624" y="4469941"/>
+            <a:ext cx="5440680" cy="237744"/>
           </a:xfrm>
           <a:prstGeom prst="rect">
             <a:avLst/>
@@ -9999,15 +9999,15 @@
         </p:nvPicPr>
         <p:blipFill>
           <a:blip r:embed="rId4"/>
-          <a:srcRect l="8655" r="8655"/>
+          <a:srcRect t="-112" b="-112"/>
           <a:stretch>
             <a:fillRect/>
           </a:stretch>
         </p:blipFill>
         <p:spPr>
           <a:xfrm>
-            <a:off x="6163056" y="1444752"/>
-            <a:ext cx="5699455" cy="3877056"/>
+            <a:off x="6227064" y="1481328"/>
+            <a:ext cx="5635447" cy="3162857"/>
           </a:xfrm>
           <a:prstGeom prst="rect">
             <a:avLst/>
@@ -10022,8 +10022,8 @@
         </p:nvSpPr>
         <p:spPr>
           <a:xfrm>
-            <a:off x="6163056" y="1444752"/>
-            <a:ext cx="5699455" cy="3877056"/>
+            <a:off x="6227064" y="1481328"/>
+            <a:ext cx="5635447" cy="3162857"/>
           </a:xfrm>
           <a:prstGeom prst="rect">
             <a:avLst/>
@@ -10065,8 +10065,8 @@
         </p:nvSpPr>
         <p:spPr>
           <a:xfrm>
-            <a:off x="6163056" y="5084064"/>
-            <a:ext cx="5699455" cy="237744"/>
+            <a:off x="6227064" y="4406441"/>
+            <a:ext cx="5635447" cy="237744"/>
           </a:xfrm>
           <a:prstGeom prst="rect">
             <a:avLst/>
@@ -10108,8 +10108,8 @@
         </p:nvSpPr>
         <p:spPr>
           <a:xfrm>
-            <a:off x="6254496" y="5147564"/>
-            <a:ext cx="5516575" cy="237744"/>
+            <a:off x="6318504" y="4469941"/>
+            <a:ext cx="5452567" cy="237744"/>
           </a:xfrm>
           <a:prstGeom prst="rect">
             <a:avLst/>
@@ -10143,8 +10143,8 @@
         </p:nvSpPr>
         <p:spPr>
           <a:xfrm>
-            <a:off x="0" y="5394960"/>
-            <a:ext cx="12191695" cy="822960"/>
+            <a:off x="0" y="4753913"/>
+            <a:ext cx="12191695" cy="1957782"/>
           </a:xfrm>
           <a:prstGeom prst="rect">
             <a:avLst/>
@@ -10186,8 +10186,8 @@
         </p:nvSpPr>
         <p:spPr>
           <a:xfrm>
-            <a:off x="457200" y="5504688"/>
-            <a:ext cx="11274552" cy="438912"/>
+            <a:off x="457200" y="4845353"/>
+            <a:ext cx="11274552" cy="457200"/>
           </a:xfrm>
           <a:prstGeom prst="rect">
             <a:avLst/>
@@ -10202,7 +10202,7 @@
           <a:p>
             <a:pPr algn="ctr"/>
             <a:r>
-              <a:rPr sz="2200" b="1" i="0">
+              <a:rPr sz="2000" b="1" i="0">
                 <a:solidFill>
                   <a:srgbClr val="C9A84C"/>
                 </a:solidFill>
@@ -10221,7 +10221,7 @@
         </p:nvSpPr>
         <p:spPr>
           <a:xfrm>
-            <a:off x="457200" y="5980176"/>
+            <a:off x="457200" y="5393993"/>
             <a:ext cx="11274552" cy="274320"/>
           </a:xfrm>
           <a:prstGeom prst="rect">
@@ -12431,15 +12431,15 @@
         </p:nvPicPr>
         <p:blipFill>
           <a:blip r:embed="rId3"/>
-          <a:srcRect l="22831" r="22831"/>
+          <a:srcRect t="-6" b="-6"/>
           <a:stretch>
             <a:fillRect/>
           </a:stretch>
         </p:blipFill>
         <p:spPr>
           <a:xfrm>
-            <a:off x="6400800" y="512064"/>
-            <a:ext cx="5458968" cy="5650992"/>
+            <a:off x="6400800" y="1848137"/>
+            <a:ext cx="5458968" cy="3070285"/>
           </a:xfrm>
           <a:prstGeom prst="rect">
             <a:avLst/>
@@ -12454,8 +12454,8 @@
         </p:nvSpPr>
         <p:spPr>
           <a:xfrm>
-            <a:off x="6400800" y="512064"/>
-            <a:ext cx="5458968" cy="5650992"/>
+            <a:off x="6400800" y="1848137"/>
+            <a:ext cx="5458968" cy="3070285"/>
           </a:xfrm>
           <a:prstGeom prst="rect">
             <a:avLst/>
@@ -12497,7 +12497,7 @@
         </p:nvSpPr>
         <p:spPr>
           <a:xfrm>
-            <a:off x="6400800" y="5925312"/>
+            <a:off x="6400800" y="4680678"/>
             <a:ext cx="5458968" cy="237744"/>
           </a:xfrm>
           <a:prstGeom prst="rect">
@@ -12540,7 +12540,7 @@
         </p:nvSpPr>
         <p:spPr>
           <a:xfrm>
-            <a:off x="6492240" y="5988812"/>
+            <a:off x="6492240" y="4744178"/>
             <a:ext cx="5276088" cy="237744"/>
           </a:xfrm>
           <a:prstGeom prst="rect">
@@ -12576,7 +12576,7 @@
         <p:spPr>
           <a:xfrm>
             <a:off x="6272784" y="512064"/>
-            <a:ext cx="12700" cy="5650992"/>
+            <a:ext cx="12700" cy="5742432"/>
           </a:xfrm>
           <a:prstGeom prst="rect">
             <a:avLst/>

</xml_diff>

<commit_message>
Refine presentation slides for better impact and clarity
Update pitch deck content and metadata, including refining slide text for conciseness and adjusting asset details in .agents/agent_assets_metadata.toml.

Replit-Commit-Author: Agent
Replit-Commit-Session-Id: 85f09f3c-352d-446d-b98e-3f307c26fc5a
Replit-Commit-Checkpoint-Type: full_checkpoint
Replit-Commit-Event-Id: b59c537b-5455-47b8-ba5c-08b307188354
Replit-Commit-Screenshot-Url: https://storage.googleapis.com/screenshot-production-us-central1/3bd53afc-ff4f-401b-9e3d-b367791ef629/85f09f3c-352d-446d-b98e-3f307c26fc5a/v9XelxY
Replit-Helium-Checkpoint-Created: true
</commit_message>
<xml_diff>
--- a/attached_assets/VaughnMartin-Investor-Pitch-Deck-v10.pptx
+++ b/attached_assets/VaughnMartin-Investor-Pitch-Deck-v10.pptx
@@ -3442,7 +3442,7 @@
         <p:spPr>
           <a:xfrm>
             <a:off x="384048" y="3584448"/>
-            <a:ext cx="5760720" cy="804672"/>
+            <a:ext cx="5760720" cy="640080"/>
           </a:xfrm>
           <a:prstGeom prst="rect">
             <a:avLst/>
@@ -3457,14 +3457,14 @@
           <a:p>
             <a:pPr algn="l"/>
             <a:r>
-              <a:rPr sz="1400" b="0" i="0">
+              <a:rPr sz="1600" b="0" i="0">
                 <a:solidFill>
                   <a:srgbClr val="99A5BB"/>
                 </a:solidFill>
                 <a:latin typeface="Barlow Condensed"/>
               </a:rPr>
-              <a:t>Every enterprise plans to respond. VaughnMartin ensures
-the response is already staged when the moment arrives.</a:t>
+              <a:t>Most enterprises plan to respond.
+VaughnMartin is already executing.</a:t>
             </a:r>
           </a:p>
         </p:txBody>
@@ -5779,7 +5779,7 @@
                 </a:solidFill>
                 <a:latin typeface="Barlow Condensed"/>
               </a:rPr>
-              <a:t>Enterprise work was designed for a world without AI. Committees, cycles, and coordination delays exist because humans couldn't process information fast enough to act decisively.</a:t>
+              <a:t>Enterprise work was built for a world without AI — coordination delays exist because humans couldn't act fast enough. AI changed the constraint. The operating model hasn't.</a:t>
             </a:r>
           </a:p>
         </p:txBody>
@@ -5935,7 +5935,7 @@
                 </a:solidFill>
                 <a:latin typeface="Barlow Condensed"/>
               </a:rPr>
-              <a:t>VaughnMartin pre-stages every response. 170 Readiness Protocols map to 221 strategic triggers — so executives authorize in minutes, not meetings.</a:t>
+              <a:t>170 Readiness Protocols. 221 strategic triggers. The response pre-staged before the trigger fires. Executives authorize in minutes, not meetings.</a:t>
             </a:r>
           </a:p>
         </p:txBody>
@@ -6091,7 +6091,7 @@
                 </a:solidFill>
                 <a:latin typeface="Barlow Condensed"/>
               </a:rPr>
-              <a:t>Any organization prepared for every situation it will face is no longer afraid of strategic triggers. It is fearless.</a:t>
+              <a:t>Any organization prepared for every situation it will face is no longer afraid of what comes next. It is fearless.</a:t>
             </a:r>
           </a:p>
         </p:txBody>
@@ -9035,7 +9035,7 @@
         <p:spPr>
           <a:xfrm>
             <a:off x="603504" y="2084832"/>
-            <a:ext cx="5358384" cy="585216"/>
+            <a:ext cx="5358384" cy="621792"/>
           </a:xfrm>
           <a:prstGeom prst="rect">
             <a:avLst/>
@@ -9069,8 +9069,8 @@
         </p:nvSpPr>
         <p:spPr>
           <a:xfrm>
-            <a:off x="603504" y="2724912"/>
-            <a:ext cx="5358384" cy="585216"/>
+            <a:off x="603504" y="2779776"/>
+            <a:ext cx="5358384" cy="621792"/>
           </a:xfrm>
           <a:prstGeom prst="rect">
             <a:avLst/>
@@ -9091,7 +9091,7 @@
                 </a:solidFill>
                 <a:latin typeface="Barlow Condensed"/>
               </a:rPr>
-              <a:t>✕  No readiness architecture before triggers fire</a:t>
+              <a:t>✕  No readiness architecture — triggers catch you cold</a:t>
             </a:r>
           </a:p>
         </p:txBody>
@@ -9104,8 +9104,8 @@
         </p:nvSpPr>
         <p:spPr>
           <a:xfrm>
-            <a:off x="603504" y="3364992"/>
-            <a:ext cx="5358384" cy="585216"/>
+            <a:off x="603504" y="3474720"/>
+            <a:ext cx="5358384" cy="621792"/>
           </a:xfrm>
           <a:prstGeom prst="rect">
             <a:avLst/>
@@ -9139,8 +9139,8 @@
         </p:nvSpPr>
         <p:spPr>
           <a:xfrm>
-            <a:off x="603504" y="4005072"/>
-            <a:ext cx="5358384" cy="585216"/>
+            <a:off x="603504" y="4169664"/>
+            <a:ext cx="5358384" cy="621792"/>
           </a:xfrm>
           <a:prstGeom prst="rect">
             <a:avLst/>
@@ -9161,49 +9161,14 @@
                 </a:solidFill>
                 <a:latin typeface="Barlow Condensed"/>
               </a:rPr>
-              <a:t>✕  Governance added after the fact — if at all</a:t>
-            </a:r>
-          </a:p>
-        </p:txBody>
-      </p:sp>
-      <p:sp>
-        <p:nvSpPr>
-          <p:cNvPr id="13" name="TextBox 12"/>
-          <p:cNvSpPr txBox="1"/>
-          <p:nvPr/>
-        </p:nvSpPr>
-        <p:spPr>
-          <a:xfrm>
-            <a:off x="603504" y="4645152"/>
-            <a:ext cx="5358384" cy="585216"/>
-          </a:xfrm>
-          <a:prstGeom prst="rect">
-            <a:avLst/>
-          </a:prstGeom>
-          <a:noFill/>
-        </p:spPr>
-        <p:txBody>
-          <a:bodyPr wrap="square">
-            <a:spAutoFit/>
-          </a:bodyPr>
-          <a:lstStyle/>
-          <a:p>
-            <a:pPr algn="l"/>
-            <a:r>
-              <a:rPr sz="1300" b="0" i="0">
-                <a:solidFill>
-                  <a:srgbClr val="FF8888"/>
-                </a:solidFill>
-                <a:latin typeface="Barlow Condensed"/>
-              </a:rPr>
-              <a:t>✕  30-day mobilization before execution starts</a:t>
-            </a:r>
-          </a:p>
-        </p:txBody>
-      </p:sp>
-      <p:sp>
-        <p:nvSpPr>
-          <p:cNvPr id="14" name="Rectangle 13"/>
+              <a:t>✕  30 days to mobilize before execution starts</a:t>
+            </a:r>
+          </a:p>
+        </p:txBody>
+      </p:sp>
+      <p:sp>
+        <p:nvSpPr>
+          <p:cNvPr id="13" name="Rectangle 12"/>
           <p:cNvSpPr/>
           <p:nvPr/>
         </p:nvSpPr>
@@ -9246,7 +9211,7 @@
       </p:sp>
       <p:sp>
         <p:nvSpPr>
-          <p:cNvPr id="15" name="TextBox 14"/>
+          <p:cNvPr id="14" name="TextBox 13"/>
           <p:cNvSpPr txBox="1"/>
           <p:nvPr/>
         </p:nvSpPr>
@@ -9281,14 +9246,49 @@
       </p:sp>
       <p:sp>
         <p:nvSpPr>
+          <p:cNvPr id="15" name="TextBox 14"/>
+          <p:cNvSpPr txBox="1"/>
+          <p:nvPr/>
+        </p:nvSpPr>
+        <p:spPr>
+          <a:xfrm>
+            <a:off x="6446520" y="2084832"/>
+            <a:ext cx="5358384" cy="621792"/>
+          </a:xfrm>
+          <a:prstGeom prst="rect">
+            <a:avLst/>
+          </a:prstGeom>
+          <a:noFill/>
+        </p:spPr>
+        <p:txBody>
+          <a:bodyPr wrap="square">
+            <a:spAutoFit/>
+          </a:bodyPr>
+          <a:lstStyle/>
+          <a:p>
+            <a:pPr algn="l"/>
+            <a:r>
+              <a:rPr sz="1300" b="0" i="0">
+                <a:solidFill>
+                  <a:srgbClr val="66CC99"/>
+                </a:solidFill>
+                <a:latin typeface="Barlow Condensed"/>
+              </a:rPr>
+              <a:t>✓  Response pre-staged before the trigger fires</a:t>
+            </a:r>
+          </a:p>
+        </p:txBody>
+      </p:sp>
+      <p:sp>
+        <p:nvSpPr>
           <p:cNvPr id="16" name="TextBox 15"/>
           <p:cNvSpPr txBox="1"/>
           <p:nvPr/>
         </p:nvSpPr>
         <p:spPr>
           <a:xfrm>
-            <a:off x="6446520" y="2084832"/>
-            <a:ext cx="5358384" cy="585216"/>
+            <a:off x="6446520" y="2779776"/>
+            <a:ext cx="5358384" cy="621792"/>
           </a:xfrm>
           <a:prstGeom prst="rect">
             <a:avLst/>
@@ -9309,7 +9309,7 @@
                 </a:solidFill>
                 <a:latin typeface="Barlow Condensed"/>
               </a:rPr>
-              <a:t>✓  Response pre-staged before trigger fires</a:t>
+              <a:t>✓  170 protocols · 221 triggers · ready before the moment</a:t>
             </a:r>
           </a:p>
         </p:txBody>
@@ -9322,8 +9322,8 @@
         </p:nvSpPr>
         <p:spPr>
           <a:xfrm>
-            <a:off x="6446520" y="2724912"/>
-            <a:ext cx="5358384" cy="585216"/>
+            <a:off x="6446520" y="3474720"/>
+            <a:ext cx="5358384" cy="621792"/>
           </a:xfrm>
           <a:prstGeom prst="rect">
             <a:avLst/>
@@ -9344,7 +9344,7 @@
                 </a:solidFill>
                 <a:latin typeface="Barlow Condensed"/>
               </a:rPr>
-              <a:t>✓  170 protocols mapped to 221 strategic triggers</a:t>
+              <a:t>✓  Executive authorization gate at every activation</a:t>
             </a:r>
           </a:p>
         </p:txBody>
@@ -9357,8 +9357,8 @@
         </p:nvSpPr>
         <p:spPr>
           <a:xfrm>
-            <a:off x="6446520" y="3364992"/>
-            <a:ext cx="5358384" cy="585216"/>
+            <a:off x="6446520" y="4169664"/>
+            <a:ext cx="5358384" cy="621792"/>
           </a:xfrm>
           <a:prstGeom prst="rect">
             <a:avLst/>
@@ -9379,76 +9379,6 @@
                 </a:solidFill>
                 <a:latin typeface="Barlow Condensed"/>
               </a:rPr>
-              <a:t>✓  Human authorization gate at every activation</a:t>
-            </a:r>
-          </a:p>
-        </p:txBody>
-      </p:sp>
-      <p:sp>
-        <p:nvSpPr>
-          <p:cNvPr id="19" name="TextBox 18"/>
-          <p:cNvSpPr txBox="1"/>
-          <p:nvPr/>
-        </p:nvSpPr>
-        <p:spPr>
-          <a:xfrm>
-            <a:off x="6446520" y="4005072"/>
-            <a:ext cx="5358384" cy="585216"/>
-          </a:xfrm>
-          <a:prstGeom prst="rect">
-            <a:avLst/>
-          </a:prstGeom>
-          <a:noFill/>
-        </p:spPr>
-        <p:txBody>
-          <a:bodyPr wrap="square">
-            <a:spAutoFit/>
-          </a:bodyPr>
-          <a:lstStyle/>
-          <a:p>
-            <a:pPr algn="l"/>
-            <a:r>
-              <a:rPr sz="1300" b="0" i="0">
-                <a:solidFill>
-                  <a:srgbClr val="66CC99"/>
-                </a:solidFill>
-                <a:latin typeface="Barlow Condensed"/>
-              </a:rPr>
-              <a:t>✓  Audit trail built in — board-ready from day one</a:t>
-            </a:r>
-          </a:p>
-        </p:txBody>
-      </p:sp>
-      <p:sp>
-        <p:nvSpPr>
-          <p:cNvPr id="20" name="TextBox 19"/>
-          <p:cNvSpPr txBox="1"/>
-          <p:nvPr/>
-        </p:nvSpPr>
-        <p:spPr>
-          <a:xfrm>
-            <a:off x="6446520" y="4645152"/>
-            <a:ext cx="5358384" cy="585216"/>
-          </a:xfrm>
-          <a:prstGeom prst="rect">
-            <a:avLst/>
-          </a:prstGeom>
-          <a:noFill/>
-        </p:spPr>
-        <p:txBody>
-          <a:bodyPr wrap="square">
-            <a:spAutoFit/>
-          </a:bodyPr>
-          <a:lstStyle/>
-          <a:p>
-            <a:pPr algn="l"/>
-            <a:r>
-              <a:rPr sz="1300" b="0" i="0">
-                <a:solidFill>
-                  <a:srgbClr val="66CC99"/>
-                </a:solidFill>
-                <a:latin typeface="Barlow Condensed"/>
-              </a:rPr>
               <a:t>✓  12-minute execution window from signal to action</a:t>
             </a:r>
           </a:p>
@@ -9456,7 +9386,7 @@
       </p:sp>
       <p:sp>
         <p:nvSpPr>
-          <p:cNvPr id="21" name="Rectangle 20"/>
+          <p:cNvPr id="19" name="Rectangle 18"/>
           <p:cNvSpPr/>
           <p:nvPr/>
         </p:nvSpPr>
@@ -9499,7 +9429,7 @@
       </p:sp>
       <p:pic>
         <p:nvPicPr>
-          <p:cNvPr id="22" name="Picture 21" descr="protocols-raw.png"/>
+          <p:cNvPr id="20" name="Picture 19" descr="protocols-raw.png"/>
           <p:cNvPicPr>
             <a:picLocks noChangeAspect="1"/>
           </p:cNvPicPr>
@@ -9524,7 +9454,7 @@
       </p:pic>
       <p:sp>
         <p:nvSpPr>
-          <p:cNvPr id="23" name="Rectangle 22"/>
+          <p:cNvPr id="21" name="Rectangle 20"/>
           <p:cNvSpPr/>
           <p:nvPr/>
         </p:nvSpPr>
@@ -9567,7 +9497,7 @@
       </p:sp>
       <p:sp>
         <p:nvSpPr>
-          <p:cNvPr id="24" name="Rectangle 23"/>
+          <p:cNvPr id="22" name="Rectangle 21"/>
           <p:cNvSpPr/>
           <p:nvPr/>
         </p:nvSpPr>
@@ -9612,7 +9542,7 @@
       </p:sp>
       <p:sp>
         <p:nvSpPr>
-          <p:cNvPr id="25" name="TextBox 24"/>
+          <p:cNvPr id="23" name="TextBox 22"/>
           <p:cNvSpPr txBox="1"/>
           <p:nvPr/>
         </p:nvSpPr>
@@ -9647,7 +9577,7 @@
       </p:sp>
       <p:sp>
         <p:nvSpPr>
-          <p:cNvPr id="26" name="TextBox 25"/>
+          <p:cNvPr id="24" name="TextBox 23"/>
           <p:cNvSpPr txBox="1"/>
           <p:nvPr/>
         </p:nvSpPr>

</xml_diff>

<commit_message>
Update pitch deck slides to fix image display issues
Adjusted slide 1 image framing for better display and replaced the image on slide 9 for improved visual storytelling.

Replit-Commit-Author: Agent
Replit-Commit-Session-Id: 85f09f3c-352d-446d-b98e-3f307c26fc5a
Replit-Commit-Checkpoint-Type: full_checkpoint
Replit-Commit-Event-Id: 60592ab5-34fc-4666-81cb-8991dbcc4c3c
Replit-Commit-Screenshot-Url: https://storage.googleapis.com/screenshot-production-us-central1/3bd53afc-ff4f-401b-9e3d-b367791ef629/85f09f3c-352d-446d-b98e-3f307c26fc5a/dDieS6H
Replit-Helium-Checkpoint-Created: true
</commit_message>
<xml_diff>
--- a/attached_assets/VaughnMartin-Investor-Pitch-Deck-v10.pptx
+++ b/attached_assets/VaughnMartin-Investor-Pitch-Deck-v10.pptx
@@ -3159,15 +3159,15 @@
         </p:nvPicPr>
         <p:blipFill>
           <a:blip r:embed="rId2"/>
-          <a:srcRect l="23092" r="23092"/>
+          <a:srcRect t="-6" b="-6"/>
           <a:stretch>
             <a:fillRect/>
           </a:stretch>
         </p:blipFill>
         <p:spPr>
           <a:xfrm>
-            <a:off x="6492240" y="512064"/>
-            <a:ext cx="5458968" cy="5705856"/>
+            <a:off x="6492240" y="1848137"/>
+            <a:ext cx="5458968" cy="3070285"/>
           </a:xfrm>
           <a:prstGeom prst="rect">
             <a:avLst/>
@@ -3182,8 +3182,8 @@
         </p:nvSpPr>
         <p:spPr>
           <a:xfrm>
-            <a:off x="6492240" y="512064"/>
-            <a:ext cx="5458968" cy="5705856"/>
+            <a:off x="6492240" y="1848137"/>
+            <a:ext cx="5458968" cy="3070285"/>
           </a:xfrm>
           <a:prstGeom prst="rect">
             <a:avLst/>
@@ -3225,7 +3225,7 @@
         </p:nvSpPr>
         <p:spPr>
           <a:xfrm>
-            <a:off x="6492240" y="5980176"/>
+            <a:off x="6492240" y="4680678"/>
             <a:ext cx="5458968" cy="237744"/>
           </a:xfrm>
           <a:prstGeom prst="rect">
@@ -3268,7 +3268,7 @@
         </p:nvSpPr>
         <p:spPr>
           <a:xfrm>
-            <a:off x="6583680" y="6043676"/>
+            <a:off x="6583680" y="4744178"/>
             <a:ext cx="5276088" cy="237744"/>
           </a:xfrm>
           <a:prstGeom prst="rect">
@@ -12353,7 +12353,7 @@
       </p:pic>
       <p:pic>
         <p:nvPicPr>
-          <p:cNvPr id="4" name="Picture 3" descr="home-raw.png"/>
+          <p:cNvPr id="4" name="Picture 3" descr="activation-raw.png"/>
           <p:cNvPicPr>
             <a:picLocks noChangeAspect="1"/>
           </p:cNvPicPr>
@@ -12492,7 +12492,7 @@
                 </a:solidFill>
                 <a:latin typeface="Barlow Condensed"/>
               </a:rPr>
-              <a:t>READINESS OS · PRODUCTION PLATFORM · VAUGHNMARTIN.COM</a:t>
+              <a:t>LIVE ACTIVATION CONSOLE · EXECUTION IN PROGRESS · PRODUCTION</a:t>
             </a:r>
           </a:p>
         </p:txBody>

</xml_diff>

<commit_message>
Improve slide layout for better visual clarity and aspect ratio display
Update presentation script to use equal-width, 16:9 aspect ratio images side-by-side on slide 8, eliminating cropping and improving visual balance.

Replit-Commit-Author: Agent
Replit-Commit-Session-Id: 85f09f3c-352d-446d-b98e-3f307c26fc5a
Replit-Commit-Checkpoint-Type: full_checkpoint
Replit-Commit-Event-Id: 641fe553-c867-48d2-81ca-4c17a0426caa
Replit-Commit-Screenshot-Url: https://storage.googleapis.com/screenshot-production-us-central1/3bd53afc-ff4f-401b-9e3d-b367791ef629/85f09f3c-352d-446d-b98e-3f307c26fc5a/dDieS6H
Replit-Helium-Checkpoint-Created: true
</commit_message>
<xml_diff>
--- a/attached_assets/VaughnMartin-Investor-Pitch-Deck-v10.pptx
+++ b/attached_assets/VaughnMartin-Investor-Pitch-Deck-v10.pptx
@@ -11487,8 +11487,8 @@
         </p:nvSpPr>
         <p:spPr>
           <a:xfrm>
-            <a:off x="329184" y="1481328"/>
-            <a:ext cx="2834640" cy="987552"/>
+            <a:off x="329184" y="1426464"/>
+            <a:ext cx="2834640" cy="877824"/>
           </a:xfrm>
           <a:prstGeom prst="rect">
             <a:avLst/>
@@ -11530,8 +11530,8 @@
         </p:nvSpPr>
         <p:spPr>
           <a:xfrm>
-            <a:off x="329184" y="1517904"/>
-            <a:ext cx="2834640" cy="603504"/>
+            <a:off x="329184" y="1444752"/>
+            <a:ext cx="2834640" cy="530352"/>
           </a:xfrm>
           <a:prstGeom prst="rect">
             <a:avLst/>
@@ -11546,7 +11546,7 @@
           <a:p>
             <a:pPr algn="ctr"/>
             <a:r>
-              <a:rPr sz="4000" b="1" i="0">
+              <a:rPr sz="3600" b="1" i="0">
                 <a:solidFill>
                   <a:srgbClr val="C9A84C"/>
                 </a:solidFill>
@@ -11565,8 +11565,8 @@
         </p:nvSpPr>
         <p:spPr>
           <a:xfrm>
-            <a:off x="329184" y="2103120"/>
-            <a:ext cx="2834640" cy="330200"/>
+            <a:off x="329184" y="1956816"/>
+            <a:ext cx="2834640" cy="279400"/>
           </a:xfrm>
           <a:prstGeom prst="rect">
             <a:avLst/>
@@ -11581,7 +11581,7 @@
           <a:p>
             <a:pPr algn="ctr"/>
             <a:r>
-              <a:rPr sz="1200" b="0" i="0">
+              <a:rPr sz="1100" b="0" i="0">
                 <a:solidFill>
                   <a:srgbClr val="99A5BB"/>
                 </a:solidFill>
@@ -11600,8 +11600,8 @@
         </p:nvSpPr>
         <p:spPr>
           <a:xfrm>
-            <a:off x="3291840" y="1481328"/>
-            <a:ext cx="2834640" cy="987552"/>
+            <a:off x="3291840" y="1426464"/>
+            <a:ext cx="2834640" cy="877824"/>
           </a:xfrm>
           <a:prstGeom prst="rect">
             <a:avLst/>
@@ -11643,8 +11643,8 @@
         </p:nvSpPr>
         <p:spPr>
           <a:xfrm>
-            <a:off x="3291840" y="1517904"/>
-            <a:ext cx="2834640" cy="603504"/>
+            <a:off x="3291840" y="1444752"/>
+            <a:ext cx="2834640" cy="530352"/>
           </a:xfrm>
           <a:prstGeom prst="rect">
             <a:avLst/>
@@ -11659,7 +11659,7 @@
           <a:p>
             <a:pPr algn="ctr"/>
             <a:r>
-              <a:rPr sz="4000" b="1" i="0">
+              <a:rPr sz="3600" b="1" i="0">
                 <a:solidFill>
                   <a:srgbClr val="C9A84C"/>
                 </a:solidFill>
@@ -11678,8 +11678,8 @@
         </p:nvSpPr>
         <p:spPr>
           <a:xfrm>
-            <a:off x="3291840" y="2103120"/>
-            <a:ext cx="2834640" cy="330200"/>
+            <a:off x="3291840" y="1956816"/>
+            <a:ext cx="2834640" cy="279400"/>
           </a:xfrm>
           <a:prstGeom prst="rect">
             <a:avLst/>
@@ -11694,7 +11694,7 @@
           <a:p>
             <a:pPr algn="ctr"/>
             <a:r>
-              <a:rPr sz="1200" b="0" i="0">
+              <a:rPr sz="1100" b="0" i="0">
                 <a:solidFill>
                   <a:srgbClr val="99A5BB"/>
                 </a:solidFill>
@@ -11713,8 +11713,8 @@
         </p:nvSpPr>
         <p:spPr>
           <a:xfrm>
-            <a:off x="6254496" y="1481328"/>
-            <a:ext cx="2834640" cy="987552"/>
+            <a:off x="6254496" y="1426464"/>
+            <a:ext cx="2834640" cy="877824"/>
           </a:xfrm>
           <a:prstGeom prst="rect">
             <a:avLst/>
@@ -11756,8 +11756,8 @@
         </p:nvSpPr>
         <p:spPr>
           <a:xfrm>
-            <a:off x="6254496" y="1517904"/>
-            <a:ext cx="2834640" cy="603504"/>
+            <a:off x="6254496" y="1444752"/>
+            <a:ext cx="2834640" cy="530352"/>
           </a:xfrm>
           <a:prstGeom prst="rect">
             <a:avLst/>
@@ -11772,7 +11772,7 @@
           <a:p>
             <a:pPr algn="ctr"/>
             <a:r>
-              <a:rPr sz="4000" b="1" i="0">
+              <a:rPr sz="3600" b="1" i="0">
                 <a:solidFill>
                   <a:srgbClr val="2B8A6E"/>
                 </a:solidFill>
@@ -11791,8 +11791,8 @@
         </p:nvSpPr>
         <p:spPr>
           <a:xfrm>
-            <a:off x="6254496" y="2103120"/>
-            <a:ext cx="2834640" cy="330200"/>
+            <a:off x="6254496" y="1956816"/>
+            <a:ext cx="2834640" cy="279400"/>
           </a:xfrm>
           <a:prstGeom prst="rect">
             <a:avLst/>
@@ -11807,7 +11807,7 @@
           <a:p>
             <a:pPr algn="ctr"/>
             <a:r>
-              <a:rPr sz="1200" b="0" i="0">
+              <a:rPr sz="1100" b="0" i="0">
                 <a:solidFill>
                   <a:srgbClr val="99A5BB"/>
                 </a:solidFill>
@@ -11826,8 +11826,8 @@
         </p:nvSpPr>
         <p:spPr>
           <a:xfrm>
-            <a:off x="9217152" y="1481328"/>
-            <a:ext cx="2834640" cy="987552"/>
+            <a:off x="9217152" y="1426464"/>
+            <a:ext cx="2834640" cy="877824"/>
           </a:xfrm>
           <a:prstGeom prst="rect">
             <a:avLst/>
@@ -11869,8 +11869,8 @@
         </p:nvSpPr>
         <p:spPr>
           <a:xfrm>
-            <a:off x="9217152" y="1517904"/>
-            <a:ext cx="2834640" cy="603504"/>
+            <a:off x="9217152" y="1444752"/>
+            <a:ext cx="2834640" cy="530352"/>
           </a:xfrm>
           <a:prstGeom prst="rect">
             <a:avLst/>
@@ -11885,7 +11885,7 @@
           <a:p>
             <a:pPr algn="ctr"/>
             <a:r>
-              <a:rPr sz="4000" b="1" i="0">
+              <a:rPr sz="3600" b="1" i="0">
                 <a:solidFill>
                   <a:srgbClr val="C9A84C"/>
                 </a:solidFill>
@@ -11904,8 +11904,8 @@
         </p:nvSpPr>
         <p:spPr>
           <a:xfrm>
-            <a:off x="9217152" y="2103120"/>
-            <a:ext cx="2834640" cy="330200"/>
+            <a:off x="9217152" y="1956816"/>
+            <a:ext cx="2834640" cy="279400"/>
           </a:xfrm>
           <a:prstGeom prst="rect">
             <a:avLst/>
@@ -11920,20 +11920,90 @@
           <a:p>
             <a:pPr algn="ctr"/>
             <a:r>
-              <a:rPr sz="1200" b="0" i="0">
+              <a:rPr sz="1100" b="0" i="0">
                 <a:solidFill>
                   <a:srgbClr val="99A5BB"/>
                 </a:solidFill>
                 <a:latin typeface="Barlow Condensed"/>
               </a:rPr>
               <a:t>Refresh</a:t>
+            </a:r>
+          </a:p>
+        </p:txBody>
+      </p:sp>
+      <p:sp>
+        <p:nvSpPr>
+          <p:cNvPr id="18" name="TextBox 17"/>
+          <p:cNvSpPr txBox="1"/>
+          <p:nvPr/>
+        </p:nvSpPr>
+        <p:spPr>
+          <a:xfrm>
+            <a:off x="329184" y="2377440"/>
+            <a:ext cx="5629503" cy="237744"/>
+          </a:xfrm>
+          <a:prstGeom prst="rect">
+            <a:avLst/>
+          </a:prstGeom>
+          <a:noFill/>
+        </p:spPr>
+        <p:txBody>
+          <a:bodyPr wrap="square">
+            <a:spAutoFit/>
+          </a:bodyPr>
+          <a:lstStyle/>
+          <a:p>
+            <a:pPr algn="l"/>
+            <a:r>
+              <a:rPr sz="900" b="1" i="0">
+                <a:solidFill>
+                  <a:srgbClr val="C9A84C"/>
+                </a:solidFill>
+                <a:latin typeface="Barlow Condensed"/>
+              </a:rPr>
+              <a:t>Signal Intelligence · Live Detection Feed</a:t>
+            </a:r>
+          </a:p>
+        </p:txBody>
+      </p:sp>
+      <p:sp>
+        <p:nvSpPr>
+          <p:cNvPr id="19" name="TextBox 18"/>
+          <p:cNvSpPr txBox="1"/>
+          <p:nvPr/>
+        </p:nvSpPr>
+        <p:spPr>
+          <a:xfrm>
+            <a:off x="6233007" y="2377440"/>
+            <a:ext cx="5629503" cy="237744"/>
+          </a:xfrm>
+          <a:prstGeom prst="rect">
+            <a:avLst/>
+          </a:prstGeom>
+          <a:noFill/>
+        </p:spPr>
+        <p:txBody>
+          <a:bodyPr wrap="square">
+            <a:spAutoFit/>
+          </a:bodyPr>
+          <a:lstStyle/>
+          <a:p>
+            <a:pPr algn="l"/>
+            <a:r>
+              <a:rPr sz="900" b="1" i="0">
+                <a:solidFill>
+                  <a:srgbClr val="C9A84C"/>
+                </a:solidFill>
+                <a:latin typeface="Barlow Condensed"/>
+              </a:rPr>
+              <a:t>Live Activation Console · Execution in Progress</a:t>
             </a:r>
           </a:p>
         </p:txBody>
       </p:sp>
       <p:pic>
         <p:nvPicPr>
-          <p:cNvPr id="18" name="Picture 17" descr="signals-raw.png"/>
+          <p:cNvPr id="20" name="Picture 19" descr="signals-raw.png"/>
           <p:cNvPicPr>
             <a:picLocks noChangeAspect="1"/>
           </p:cNvPicPr>
@@ -11941,7 +12011,7 @@
         </p:nvPicPr>
         <p:blipFill>
           <a:blip r:embed="rId3"/>
-          <a:srcRect t="-17871" b="-17871"/>
+          <a:srcRect t="-6" b="-6"/>
           <a:stretch>
             <a:fillRect/>
           </a:stretch>
@@ -11949,7 +12019,7 @@
         <p:spPr>
           <a:xfrm>
             <a:off x="329184" y="2633472"/>
-            <a:ext cx="7370064" cy="3054096"/>
+            <a:ext cx="5629503" cy="3166199"/>
           </a:xfrm>
           <a:prstGeom prst="rect">
             <a:avLst/>
@@ -11958,14 +12028,14 @@
       </p:pic>
       <p:sp>
         <p:nvSpPr>
-          <p:cNvPr id="19" name="Rectangle 18"/>
+          <p:cNvPr id="21" name="Rectangle 20"/>
           <p:cNvSpPr/>
           <p:nvPr/>
         </p:nvSpPr>
         <p:spPr>
           <a:xfrm>
             <a:off x="329184" y="2633472"/>
-            <a:ext cx="7370064" cy="3054096"/>
+            <a:ext cx="5629503" cy="3166199"/>
           </a:xfrm>
           <a:prstGeom prst="rect">
             <a:avLst/>
@@ -12001,14 +12071,14 @@
       </p:sp>
       <p:sp>
         <p:nvSpPr>
-          <p:cNvPr id="20" name="Rectangle 19"/>
+          <p:cNvPr id="22" name="Rectangle 21"/>
           <p:cNvSpPr/>
           <p:nvPr/>
         </p:nvSpPr>
         <p:spPr>
           <a:xfrm>
-            <a:off x="329184" y="5449824"/>
-            <a:ext cx="7370064" cy="237744"/>
+            <a:off x="329184" y="5561927"/>
+            <a:ext cx="5629503" cy="237744"/>
           </a:xfrm>
           <a:prstGeom prst="rect">
             <a:avLst/>
@@ -12044,14 +12114,14 @@
       </p:sp>
       <p:sp>
         <p:nvSpPr>
-          <p:cNvPr id="21" name="TextBox 20"/>
-          <p:cNvSpPr txBox="1"/>
-          <p:nvPr/>
-        </p:nvSpPr>
-        <p:spPr>
-          <a:xfrm>
-            <a:off x="420624" y="5513324"/>
-            <a:ext cx="7187184" cy="237744"/>
+          <p:cNvPr id="23" name="TextBox 22"/>
+          <p:cNvSpPr txBox="1"/>
+          <p:nvPr/>
+        </p:nvSpPr>
+        <p:spPr>
+          <a:xfrm>
+            <a:off x="420624" y="5625427"/>
+            <a:ext cx="5446623" cy="237744"/>
           </a:xfrm>
           <a:prstGeom prst="rect">
             <a:avLst/>
@@ -12079,7 +12149,7 @@
       </p:sp>
       <p:pic>
         <p:nvPicPr>
-          <p:cNvPr id="22" name="Picture 21" descr="activation-raw.png"/>
+          <p:cNvPr id="24" name="Picture 23" descr="activation-raw.png"/>
           <p:cNvPicPr>
             <a:picLocks noChangeAspect="1"/>
           </p:cNvPicPr>
@@ -12087,15 +12157,15 @@
         </p:nvPicPr>
         <p:blipFill>
           <a:blip r:embed="rId4"/>
-          <a:srcRect l="14187" r="14187"/>
+          <a:srcRect t="-6" b="-6"/>
           <a:stretch>
             <a:fillRect/>
           </a:stretch>
         </p:blipFill>
         <p:spPr>
           <a:xfrm>
-            <a:off x="7973568" y="2633472"/>
-            <a:ext cx="3888943" cy="3054096"/>
+            <a:off x="6233007" y="2633472"/>
+            <a:ext cx="5629503" cy="3166199"/>
           </a:xfrm>
           <a:prstGeom prst="rect">
             <a:avLst/>
@@ -12104,14 +12174,14 @@
       </p:pic>
       <p:sp>
         <p:nvSpPr>
-          <p:cNvPr id="23" name="Rectangle 22"/>
+          <p:cNvPr id="25" name="Rectangle 24"/>
           <p:cNvSpPr/>
           <p:nvPr/>
         </p:nvSpPr>
         <p:spPr>
           <a:xfrm>
-            <a:off x="7973568" y="2633472"/>
-            <a:ext cx="3888943" cy="3054096"/>
+            <a:off x="6233007" y="2633472"/>
+            <a:ext cx="5629503" cy="3166199"/>
           </a:xfrm>
           <a:prstGeom prst="rect">
             <a:avLst/>
@@ -12147,14 +12217,14 @@
       </p:sp>
       <p:sp>
         <p:nvSpPr>
-          <p:cNvPr id="24" name="Rectangle 23"/>
+          <p:cNvPr id="26" name="Rectangle 25"/>
           <p:cNvSpPr/>
           <p:nvPr/>
         </p:nvSpPr>
         <p:spPr>
           <a:xfrm>
-            <a:off x="7973568" y="5449824"/>
-            <a:ext cx="3888943" cy="237744"/>
+            <a:off x="6233007" y="5561927"/>
+            <a:ext cx="5629503" cy="237744"/>
           </a:xfrm>
           <a:prstGeom prst="rect">
             <a:avLst/>
@@ -12190,14 +12260,14 @@
       </p:sp>
       <p:sp>
         <p:nvSpPr>
-          <p:cNvPr id="25" name="TextBox 24"/>
-          <p:cNvSpPr txBox="1"/>
-          <p:nvPr/>
-        </p:nvSpPr>
-        <p:spPr>
-          <a:xfrm>
-            <a:off x="8065008" y="5513324"/>
-            <a:ext cx="3706063" cy="237744"/>
+          <p:cNvPr id="27" name="TextBox 26"/>
+          <p:cNvSpPr txBox="1"/>
+          <p:nvPr/>
+        </p:nvSpPr>
+        <p:spPr>
+          <a:xfrm>
+            <a:off x="6324447" y="5625427"/>
+            <a:ext cx="5446623" cy="237744"/>
           </a:xfrm>
           <a:prstGeom prst="rect">
             <a:avLst/>
@@ -12218,14 +12288,14 @@
                 </a:solidFill>
                 <a:latin typeface="Barlow Condensed"/>
               </a:rPr>
-              <a:t>LIVE ACTIVATION CONSOLE</a:t>
-            </a:r>
-          </a:p>
-        </p:txBody>
-      </p:sp>
-      <p:sp>
-        <p:nvSpPr>
-          <p:cNvPr id="26" name="TextBox 25"/>
+              <a:t>LIVE ACTIVATION CONSOLE · AUTHORIZED EXECUTION · VAUGHNMARTIN.COM</a:t>
+            </a:r>
+          </a:p>
+        </p:txBody>
+      </p:sp>
+      <p:sp>
+        <p:nvSpPr>
+          <p:cNvPr id="28" name="TextBox 27"/>
           <p:cNvSpPr txBox="1"/>
           <p:nvPr/>
         </p:nvSpPr>

</xml_diff>

<commit_message>
Update pitch deck to improve clarity and visual flow
Refine pitch deck slides with a new execution timeline, sharpened messaging, and clarified value proposition.

Replit-Commit-Author: Agent
Replit-Commit-Session-Id: 85f09f3c-352d-446d-b98e-3f307c26fc5a
Replit-Commit-Checkpoint-Type: full_checkpoint
Replit-Commit-Event-Id: 5a62c3dc-102f-4334-9af8-8cef283cebeb
Replit-Commit-Screenshot-Url: https://storage.googleapis.com/screenshot-production-us-central1/3bd53afc-ff4f-401b-9e3d-b367791ef629/85f09f3c-352d-446d-b98e-3f307c26fc5a/dDieS6H
Replit-Helium-Checkpoint-Created: true
</commit_message>
<xml_diff>
--- a/attached_assets/VaughnMartin-Investor-Pitch-Deck-v10.pptx
+++ b/attached_assets/VaughnMartin-Investor-Pitch-Deck-v10.pptx
@@ -6775,7 +6775,7 @@
         <p:spPr>
           <a:xfrm>
             <a:off x="6437376" y="4005072"/>
-            <a:ext cx="5303520" cy="512064"/>
+            <a:ext cx="5303520" cy="493776"/>
           </a:xfrm>
           <a:prstGeom prst="rect">
             <a:avLst/>
@@ -6796,7 +6796,7 @@
                 </a:solidFill>
                 <a:latin typeface="Barlow Condensed"/>
               </a:rPr>
-              <a:t>— Coordination restarts from zero at every trigger</a:t>
+              <a:t>— Every trigger restarts the mobilization clock from zero</a:t>
             </a:r>
           </a:p>
         </p:txBody>
@@ -6809,8 +6809,8 @@
         </p:nvSpPr>
         <p:spPr>
           <a:xfrm>
-            <a:off x="6437376" y="4572000"/>
-            <a:ext cx="5303520" cy="512064"/>
+            <a:off x="6437376" y="4535424"/>
+            <a:ext cx="5303520" cy="493776"/>
           </a:xfrm>
           <a:prstGeom prst="rect">
             <a:avLst/>
@@ -6831,14 +6831,49 @@
                 </a:solidFill>
                 <a:latin typeface="Barlow Condensed"/>
               </a:rPr>
-              <a:t>— The strategic window closes before execution begins</a:t>
-            </a:r>
-          </a:p>
-        </p:txBody>
-      </p:sp>
-      <p:sp>
-        <p:nvSpPr>
-          <p:cNvPr id="18" name="Rectangle 17"/>
+              <a:t>— The window to act closes before execution begins</a:t>
+            </a:r>
+          </a:p>
+        </p:txBody>
+      </p:sp>
+      <p:sp>
+        <p:nvSpPr>
+          <p:cNvPr id="18" name="TextBox 17"/>
+          <p:cNvSpPr txBox="1"/>
+          <p:nvPr/>
+        </p:nvSpPr>
+        <p:spPr>
+          <a:xfrm>
+            <a:off x="6437376" y="5065776"/>
+            <a:ext cx="5303520" cy="493776"/>
+          </a:xfrm>
+          <a:prstGeom prst="rect">
+            <a:avLst/>
+          </a:prstGeom>
+          <a:noFill/>
+        </p:spPr>
+        <p:txBody>
+          <a:bodyPr wrap="square">
+            <a:spAutoFit/>
+          </a:bodyPr>
+          <a:lstStyle/>
+          <a:p>
+            <a:pPr algn="l"/>
+            <a:r>
+              <a:rPr sz="1300" b="0" i="0">
+                <a:solidFill>
+                  <a:srgbClr val="99A5BB"/>
+                </a:solidFill>
+                <a:latin typeface="Barlow Condensed"/>
+              </a:rPr>
+              <a:t>— Every enterprise has talent. None have pre-staged responses.</a:t>
+            </a:r>
+          </a:p>
+        </p:txBody>
+      </p:sp>
+      <p:sp>
+        <p:nvSpPr>
+          <p:cNvPr id="19" name="Rectangle 18"/>
           <p:cNvSpPr/>
           <p:nvPr/>
         </p:nvSpPr>
@@ -6881,7 +6916,7 @@
       </p:sp>
       <p:sp>
         <p:nvSpPr>
-          <p:cNvPr id="19" name="TextBox 18"/>
+          <p:cNvPr id="20" name="TextBox 19"/>
           <p:cNvSpPr txBox="1"/>
           <p:nvPr/>
         </p:nvSpPr>
@@ -9773,9 +9808,904 @@
           </a:p>
         </p:txBody>
       </p:sp>
+      <p:sp>
+        <p:nvSpPr>
+          <p:cNvPr id="6" name="Rectangle 5"/>
+          <p:cNvSpPr/>
+          <p:nvPr/>
+        </p:nvSpPr>
+        <p:spPr>
+          <a:xfrm>
+            <a:off x="673455" y="1481328"/>
+            <a:ext cx="1609344" cy="548640"/>
+          </a:xfrm>
+          <a:prstGeom prst="rect">
+            <a:avLst/>
+          </a:prstGeom>
+          <a:solidFill>
+            <a:srgbClr val="0E163C"/>
+          </a:solidFill>
+          <a:ln>
+            <a:noFill/>
+          </a:ln>
+        </p:spPr>
+        <p:style>
+          <a:lnRef idx="1">
+            <a:schemeClr val="accent1"/>
+          </a:lnRef>
+          <a:fillRef idx="3">
+            <a:schemeClr val="accent1"/>
+          </a:fillRef>
+          <a:effectRef idx="2">
+            <a:schemeClr val="accent1"/>
+          </a:effectRef>
+          <a:fontRef idx="minor">
+            <a:schemeClr val="lt1"/>
+          </a:fontRef>
+        </p:style>
+        <p:txBody>
+          <a:bodyPr rtlCol="0" anchor="ctr"/>
+          <a:lstStyle/>
+          <a:p>
+            <a:pPr algn="ctr"/>
+          </a:p>
+        </p:txBody>
+      </p:sp>
+      <p:sp>
+        <p:nvSpPr>
+          <p:cNvPr id="7" name="TextBox 6"/>
+          <p:cNvSpPr txBox="1"/>
+          <p:nvPr/>
+        </p:nvSpPr>
+        <p:spPr>
+          <a:xfrm>
+            <a:off x="673455" y="1517904"/>
+            <a:ext cx="1609344" cy="201168"/>
+          </a:xfrm>
+          <a:prstGeom prst="rect">
+            <a:avLst/>
+          </a:prstGeom>
+          <a:noFill/>
+        </p:spPr>
+        <p:txBody>
+          <a:bodyPr wrap="square">
+            <a:spAutoFit/>
+          </a:bodyPr>
+          <a:lstStyle/>
+          <a:p>
+            <a:pPr algn="ctr"/>
+            <a:r>
+              <a:rPr sz="1100" b="1" i="0">
+                <a:solidFill>
+                  <a:srgbClr val="C9A84C"/>
+                </a:solidFill>
+                <a:latin typeface="Barlow Condensed"/>
+              </a:rPr>
+              <a:t>01</a:t>
+            </a:r>
+          </a:p>
+        </p:txBody>
+      </p:sp>
+      <p:sp>
+        <p:nvSpPr>
+          <p:cNvPr id="8" name="TextBox 7"/>
+          <p:cNvSpPr txBox="1"/>
+          <p:nvPr/>
+        </p:nvSpPr>
+        <p:spPr>
+          <a:xfrm>
+            <a:off x="673455" y="1719072"/>
+            <a:ext cx="1609344" cy="292608"/>
+          </a:xfrm>
+          <a:prstGeom prst="rect">
+            <a:avLst/>
+          </a:prstGeom>
+          <a:noFill/>
+        </p:spPr>
+        <p:txBody>
+          <a:bodyPr wrap="square">
+            <a:spAutoFit/>
+          </a:bodyPr>
+          <a:lstStyle/>
+          <a:p>
+            <a:pPr algn="ctr"/>
+            <a:r>
+              <a:rPr sz="900" b="0" i="0">
+                <a:solidFill>
+                  <a:srgbClr val="FFFFFF"/>
+                </a:solidFill>
+                <a:latin typeface="Barlow Condensed"/>
+              </a:rPr>
+              <a:t>Signal
+Detected</a:t>
+            </a:r>
+          </a:p>
+        </p:txBody>
+      </p:sp>
+      <p:sp>
+        <p:nvSpPr>
+          <p:cNvPr id="9" name="TextBox 8"/>
+          <p:cNvSpPr txBox="1"/>
+          <p:nvPr/>
+        </p:nvSpPr>
+        <p:spPr>
+          <a:xfrm>
+            <a:off x="2282799" y="1645920"/>
+            <a:ext cx="237744" cy="237744"/>
+          </a:xfrm>
+          <a:prstGeom prst="rect">
+            <a:avLst/>
+          </a:prstGeom>
+          <a:noFill/>
+        </p:spPr>
+        <p:txBody>
+          <a:bodyPr wrap="square">
+            <a:spAutoFit/>
+          </a:bodyPr>
+          <a:lstStyle/>
+          <a:p>
+            <a:pPr algn="ctr"/>
+            <a:r>
+              <a:rPr sz="1400" b="1" i="0">
+                <a:solidFill>
+                  <a:srgbClr val="C9A84C"/>
+                </a:solidFill>
+                <a:latin typeface="Barlow Condensed"/>
+              </a:rPr>
+              <a:t>→</a:t>
+            </a:r>
+          </a:p>
+        </p:txBody>
+      </p:sp>
+      <p:sp>
+        <p:nvSpPr>
+          <p:cNvPr id="10" name="Rectangle 9"/>
+          <p:cNvSpPr/>
+          <p:nvPr/>
+        </p:nvSpPr>
+        <p:spPr>
+          <a:xfrm>
+            <a:off x="2520543" y="1481328"/>
+            <a:ext cx="1609344" cy="548640"/>
+          </a:xfrm>
+          <a:prstGeom prst="rect">
+            <a:avLst/>
+          </a:prstGeom>
+          <a:solidFill>
+            <a:srgbClr val="0E163C"/>
+          </a:solidFill>
+          <a:ln>
+            <a:noFill/>
+          </a:ln>
+        </p:spPr>
+        <p:style>
+          <a:lnRef idx="1">
+            <a:schemeClr val="accent1"/>
+          </a:lnRef>
+          <a:fillRef idx="3">
+            <a:schemeClr val="accent1"/>
+          </a:fillRef>
+          <a:effectRef idx="2">
+            <a:schemeClr val="accent1"/>
+          </a:effectRef>
+          <a:fontRef idx="minor">
+            <a:schemeClr val="lt1"/>
+          </a:fontRef>
+        </p:style>
+        <p:txBody>
+          <a:bodyPr rtlCol="0" anchor="ctr"/>
+          <a:lstStyle/>
+          <a:p>
+            <a:pPr algn="ctr"/>
+          </a:p>
+        </p:txBody>
+      </p:sp>
+      <p:sp>
+        <p:nvSpPr>
+          <p:cNvPr id="11" name="TextBox 10"/>
+          <p:cNvSpPr txBox="1"/>
+          <p:nvPr/>
+        </p:nvSpPr>
+        <p:spPr>
+          <a:xfrm>
+            <a:off x="2520543" y="1517904"/>
+            <a:ext cx="1609344" cy="201168"/>
+          </a:xfrm>
+          <a:prstGeom prst="rect">
+            <a:avLst/>
+          </a:prstGeom>
+          <a:noFill/>
+        </p:spPr>
+        <p:txBody>
+          <a:bodyPr wrap="square">
+            <a:spAutoFit/>
+          </a:bodyPr>
+          <a:lstStyle/>
+          <a:p>
+            <a:pPr algn="ctr"/>
+            <a:r>
+              <a:rPr sz="1100" b="1" i="0">
+                <a:solidFill>
+                  <a:srgbClr val="C9A84C"/>
+                </a:solidFill>
+                <a:latin typeface="Barlow Condensed"/>
+              </a:rPr>
+              <a:t>02</a:t>
+            </a:r>
+          </a:p>
+        </p:txBody>
+      </p:sp>
+      <p:sp>
+        <p:nvSpPr>
+          <p:cNvPr id="12" name="TextBox 11"/>
+          <p:cNvSpPr txBox="1"/>
+          <p:nvPr/>
+        </p:nvSpPr>
+        <p:spPr>
+          <a:xfrm>
+            <a:off x="2520543" y="1719072"/>
+            <a:ext cx="1609344" cy="292608"/>
+          </a:xfrm>
+          <a:prstGeom prst="rect">
+            <a:avLst/>
+          </a:prstGeom>
+          <a:noFill/>
+        </p:spPr>
+        <p:txBody>
+          <a:bodyPr wrap="square">
+            <a:spAutoFit/>
+          </a:bodyPr>
+          <a:lstStyle/>
+          <a:p>
+            <a:pPr algn="ctr"/>
+            <a:r>
+              <a:rPr sz="900" b="0" i="0">
+                <a:solidFill>
+                  <a:srgbClr val="FFFFFF"/>
+                </a:solidFill>
+                <a:latin typeface="Barlow Condensed"/>
+              </a:rPr>
+              <a:t>Threat
+Classified</a:t>
+            </a:r>
+          </a:p>
+        </p:txBody>
+      </p:sp>
+      <p:sp>
+        <p:nvSpPr>
+          <p:cNvPr id="13" name="TextBox 12"/>
+          <p:cNvSpPr txBox="1"/>
+          <p:nvPr/>
+        </p:nvSpPr>
+        <p:spPr>
+          <a:xfrm>
+            <a:off x="4129887" y="1645920"/>
+            <a:ext cx="237744" cy="237744"/>
+          </a:xfrm>
+          <a:prstGeom prst="rect">
+            <a:avLst/>
+          </a:prstGeom>
+          <a:noFill/>
+        </p:spPr>
+        <p:txBody>
+          <a:bodyPr wrap="square">
+            <a:spAutoFit/>
+          </a:bodyPr>
+          <a:lstStyle/>
+          <a:p>
+            <a:pPr algn="ctr"/>
+            <a:r>
+              <a:rPr sz="1400" b="1" i="0">
+                <a:solidFill>
+                  <a:srgbClr val="C9A84C"/>
+                </a:solidFill>
+                <a:latin typeface="Barlow Condensed"/>
+              </a:rPr>
+              <a:t>→</a:t>
+            </a:r>
+          </a:p>
+        </p:txBody>
+      </p:sp>
+      <p:sp>
+        <p:nvSpPr>
+          <p:cNvPr id="14" name="Rectangle 13"/>
+          <p:cNvSpPr/>
+          <p:nvPr/>
+        </p:nvSpPr>
+        <p:spPr>
+          <a:xfrm>
+            <a:off x="4367631" y="1481328"/>
+            <a:ext cx="1609344" cy="548640"/>
+          </a:xfrm>
+          <a:prstGeom prst="rect">
+            <a:avLst/>
+          </a:prstGeom>
+          <a:solidFill>
+            <a:srgbClr val="0E163C"/>
+          </a:solidFill>
+          <a:ln>
+            <a:noFill/>
+          </a:ln>
+        </p:spPr>
+        <p:style>
+          <a:lnRef idx="1">
+            <a:schemeClr val="accent1"/>
+          </a:lnRef>
+          <a:fillRef idx="3">
+            <a:schemeClr val="accent1"/>
+          </a:fillRef>
+          <a:effectRef idx="2">
+            <a:schemeClr val="accent1"/>
+          </a:effectRef>
+          <a:fontRef idx="minor">
+            <a:schemeClr val="lt1"/>
+          </a:fontRef>
+        </p:style>
+        <p:txBody>
+          <a:bodyPr rtlCol="0" anchor="ctr"/>
+          <a:lstStyle/>
+          <a:p>
+            <a:pPr algn="ctr"/>
+          </a:p>
+        </p:txBody>
+      </p:sp>
+      <p:sp>
+        <p:nvSpPr>
+          <p:cNvPr id="15" name="TextBox 14"/>
+          <p:cNvSpPr txBox="1"/>
+          <p:nvPr/>
+        </p:nvSpPr>
+        <p:spPr>
+          <a:xfrm>
+            <a:off x="4367631" y="1517904"/>
+            <a:ext cx="1609344" cy="201168"/>
+          </a:xfrm>
+          <a:prstGeom prst="rect">
+            <a:avLst/>
+          </a:prstGeom>
+          <a:noFill/>
+        </p:spPr>
+        <p:txBody>
+          <a:bodyPr wrap="square">
+            <a:spAutoFit/>
+          </a:bodyPr>
+          <a:lstStyle/>
+          <a:p>
+            <a:pPr algn="ctr"/>
+            <a:r>
+              <a:rPr sz="1100" b="1" i="0">
+                <a:solidFill>
+                  <a:srgbClr val="C9A84C"/>
+                </a:solidFill>
+                <a:latin typeface="Barlow Condensed"/>
+              </a:rPr>
+              <a:t>03</a:t>
+            </a:r>
+          </a:p>
+        </p:txBody>
+      </p:sp>
+      <p:sp>
+        <p:nvSpPr>
+          <p:cNvPr id="16" name="TextBox 15"/>
+          <p:cNvSpPr txBox="1"/>
+          <p:nvPr/>
+        </p:nvSpPr>
+        <p:spPr>
+          <a:xfrm>
+            <a:off x="4367631" y="1719072"/>
+            <a:ext cx="1609344" cy="292608"/>
+          </a:xfrm>
+          <a:prstGeom prst="rect">
+            <a:avLst/>
+          </a:prstGeom>
+          <a:noFill/>
+        </p:spPr>
+        <p:txBody>
+          <a:bodyPr wrap="square">
+            <a:spAutoFit/>
+          </a:bodyPr>
+          <a:lstStyle/>
+          <a:p>
+            <a:pPr algn="ctr"/>
+            <a:r>
+              <a:rPr sz="900" b="0" i="0">
+                <a:solidFill>
+                  <a:srgbClr val="FFFFFF"/>
+                </a:solidFill>
+                <a:latin typeface="Barlow Condensed"/>
+              </a:rPr>
+              <a:t>Protocol
+Matched</a:t>
+            </a:r>
+          </a:p>
+        </p:txBody>
+      </p:sp>
+      <p:sp>
+        <p:nvSpPr>
+          <p:cNvPr id="17" name="TextBox 16"/>
+          <p:cNvSpPr txBox="1"/>
+          <p:nvPr/>
+        </p:nvSpPr>
+        <p:spPr>
+          <a:xfrm>
+            <a:off x="5976975" y="1645920"/>
+            <a:ext cx="237744" cy="237744"/>
+          </a:xfrm>
+          <a:prstGeom prst="rect">
+            <a:avLst/>
+          </a:prstGeom>
+          <a:noFill/>
+        </p:spPr>
+        <p:txBody>
+          <a:bodyPr wrap="square">
+            <a:spAutoFit/>
+          </a:bodyPr>
+          <a:lstStyle/>
+          <a:p>
+            <a:pPr algn="ctr"/>
+            <a:r>
+              <a:rPr sz="1400" b="1" i="0">
+                <a:solidFill>
+                  <a:srgbClr val="C9A84C"/>
+                </a:solidFill>
+                <a:latin typeface="Barlow Condensed"/>
+              </a:rPr>
+              <a:t>→</a:t>
+            </a:r>
+          </a:p>
+        </p:txBody>
+      </p:sp>
+      <p:sp>
+        <p:nvSpPr>
+          <p:cNvPr id="18" name="Rectangle 17"/>
+          <p:cNvSpPr/>
+          <p:nvPr/>
+        </p:nvSpPr>
+        <p:spPr>
+          <a:xfrm>
+            <a:off x="6214719" y="1481328"/>
+            <a:ext cx="1609344" cy="548640"/>
+          </a:xfrm>
+          <a:prstGeom prst="rect">
+            <a:avLst/>
+          </a:prstGeom>
+          <a:solidFill>
+            <a:srgbClr val="0E163C"/>
+          </a:solidFill>
+          <a:ln>
+            <a:noFill/>
+          </a:ln>
+        </p:spPr>
+        <p:style>
+          <a:lnRef idx="1">
+            <a:schemeClr val="accent1"/>
+          </a:lnRef>
+          <a:fillRef idx="3">
+            <a:schemeClr val="accent1"/>
+          </a:fillRef>
+          <a:effectRef idx="2">
+            <a:schemeClr val="accent1"/>
+          </a:effectRef>
+          <a:fontRef idx="minor">
+            <a:schemeClr val="lt1"/>
+          </a:fontRef>
+        </p:style>
+        <p:txBody>
+          <a:bodyPr rtlCol="0" anchor="ctr"/>
+          <a:lstStyle/>
+          <a:p>
+            <a:pPr algn="ctr"/>
+          </a:p>
+        </p:txBody>
+      </p:sp>
+      <p:sp>
+        <p:nvSpPr>
+          <p:cNvPr id="19" name="TextBox 18"/>
+          <p:cNvSpPr txBox="1"/>
+          <p:nvPr/>
+        </p:nvSpPr>
+        <p:spPr>
+          <a:xfrm>
+            <a:off x="6214719" y="1517904"/>
+            <a:ext cx="1609344" cy="201168"/>
+          </a:xfrm>
+          <a:prstGeom prst="rect">
+            <a:avLst/>
+          </a:prstGeom>
+          <a:noFill/>
+        </p:spPr>
+        <p:txBody>
+          <a:bodyPr wrap="square">
+            <a:spAutoFit/>
+          </a:bodyPr>
+          <a:lstStyle/>
+          <a:p>
+            <a:pPr algn="ctr"/>
+            <a:r>
+              <a:rPr sz="1100" b="1" i="0">
+                <a:solidFill>
+                  <a:srgbClr val="C9A84C"/>
+                </a:solidFill>
+                <a:latin typeface="Barlow Condensed"/>
+              </a:rPr>
+              <a:t>04</a:t>
+            </a:r>
+          </a:p>
+        </p:txBody>
+      </p:sp>
+      <p:sp>
+        <p:nvSpPr>
+          <p:cNvPr id="20" name="TextBox 19"/>
+          <p:cNvSpPr txBox="1"/>
+          <p:nvPr/>
+        </p:nvSpPr>
+        <p:spPr>
+          <a:xfrm>
+            <a:off x="6214719" y="1719072"/>
+            <a:ext cx="1609344" cy="292608"/>
+          </a:xfrm>
+          <a:prstGeom prst="rect">
+            <a:avLst/>
+          </a:prstGeom>
+          <a:noFill/>
+        </p:spPr>
+        <p:txBody>
+          <a:bodyPr wrap="square">
+            <a:spAutoFit/>
+          </a:bodyPr>
+          <a:lstStyle/>
+          <a:p>
+            <a:pPr algn="ctr"/>
+            <a:r>
+              <a:rPr sz="900" b="0" i="0">
+                <a:solidFill>
+                  <a:srgbClr val="FFFFFF"/>
+                </a:solidFill>
+                <a:latin typeface="Barlow Condensed"/>
+              </a:rPr>
+              <a:t>Team
+Notified</a:t>
+            </a:r>
+          </a:p>
+        </p:txBody>
+      </p:sp>
+      <p:sp>
+        <p:nvSpPr>
+          <p:cNvPr id="21" name="TextBox 20"/>
+          <p:cNvSpPr txBox="1"/>
+          <p:nvPr/>
+        </p:nvSpPr>
+        <p:spPr>
+          <a:xfrm>
+            <a:off x="7824063" y="1645920"/>
+            <a:ext cx="237744" cy="237744"/>
+          </a:xfrm>
+          <a:prstGeom prst="rect">
+            <a:avLst/>
+          </a:prstGeom>
+          <a:noFill/>
+        </p:spPr>
+        <p:txBody>
+          <a:bodyPr wrap="square">
+            <a:spAutoFit/>
+          </a:bodyPr>
+          <a:lstStyle/>
+          <a:p>
+            <a:pPr algn="ctr"/>
+            <a:r>
+              <a:rPr sz="1400" b="1" i="0">
+                <a:solidFill>
+                  <a:srgbClr val="C9A84C"/>
+                </a:solidFill>
+                <a:latin typeface="Barlow Condensed"/>
+              </a:rPr>
+              <a:t>→</a:t>
+            </a:r>
+          </a:p>
+        </p:txBody>
+      </p:sp>
+      <p:sp>
+        <p:nvSpPr>
+          <p:cNvPr id="22" name="Rectangle 21"/>
+          <p:cNvSpPr/>
+          <p:nvPr/>
+        </p:nvSpPr>
+        <p:spPr>
+          <a:xfrm>
+            <a:off x="8061807" y="1481328"/>
+            <a:ext cx="1609344" cy="548640"/>
+          </a:xfrm>
+          <a:prstGeom prst="rect">
+            <a:avLst/>
+          </a:prstGeom>
+          <a:solidFill>
+            <a:srgbClr val="0E163C"/>
+          </a:solidFill>
+          <a:ln>
+            <a:noFill/>
+          </a:ln>
+        </p:spPr>
+        <p:style>
+          <a:lnRef idx="1">
+            <a:schemeClr val="accent1"/>
+          </a:lnRef>
+          <a:fillRef idx="3">
+            <a:schemeClr val="accent1"/>
+          </a:fillRef>
+          <a:effectRef idx="2">
+            <a:schemeClr val="accent1"/>
+          </a:effectRef>
+          <a:fontRef idx="minor">
+            <a:schemeClr val="lt1"/>
+          </a:fontRef>
+        </p:style>
+        <p:txBody>
+          <a:bodyPr rtlCol="0" anchor="ctr"/>
+          <a:lstStyle/>
+          <a:p>
+            <a:pPr algn="ctr"/>
+          </a:p>
+        </p:txBody>
+      </p:sp>
+      <p:sp>
+        <p:nvSpPr>
+          <p:cNvPr id="23" name="TextBox 22"/>
+          <p:cNvSpPr txBox="1"/>
+          <p:nvPr/>
+        </p:nvSpPr>
+        <p:spPr>
+          <a:xfrm>
+            <a:off x="8061807" y="1517904"/>
+            <a:ext cx="1609344" cy="201168"/>
+          </a:xfrm>
+          <a:prstGeom prst="rect">
+            <a:avLst/>
+          </a:prstGeom>
+          <a:noFill/>
+        </p:spPr>
+        <p:txBody>
+          <a:bodyPr wrap="square">
+            <a:spAutoFit/>
+          </a:bodyPr>
+          <a:lstStyle/>
+          <a:p>
+            <a:pPr algn="ctr"/>
+            <a:r>
+              <a:rPr sz="1100" b="1" i="0">
+                <a:solidFill>
+                  <a:srgbClr val="C9A84C"/>
+                </a:solidFill>
+                <a:latin typeface="Barlow Condensed"/>
+              </a:rPr>
+              <a:t>05</a:t>
+            </a:r>
+          </a:p>
+        </p:txBody>
+      </p:sp>
+      <p:sp>
+        <p:nvSpPr>
+          <p:cNvPr id="24" name="TextBox 23"/>
+          <p:cNvSpPr txBox="1"/>
+          <p:nvPr/>
+        </p:nvSpPr>
+        <p:spPr>
+          <a:xfrm>
+            <a:off x="8061807" y="1719072"/>
+            <a:ext cx="1609344" cy="292608"/>
+          </a:xfrm>
+          <a:prstGeom prst="rect">
+            <a:avLst/>
+          </a:prstGeom>
+          <a:noFill/>
+        </p:spPr>
+        <p:txBody>
+          <a:bodyPr wrap="square">
+            <a:spAutoFit/>
+          </a:bodyPr>
+          <a:lstStyle/>
+          <a:p>
+            <a:pPr algn="ctr"/>
+            <a:r>
+              <a:rPr sz="900" b="0" i="0">
+                <a:solidFill>
+                  <a:srgbClr val="FFFFFF"/>
+                </a:solidFill>
+                <a:latin typeface="Barlow Condensed"/>
+              </a:rPr>
+              <a:t>Executive
+Authorizes</a:t>
+            </a:r>
+          </a:p>
+        </p:txBody>
+      </p:sp>
+      <p:sp>
+        <p:nvSpPr>
+          <p:cNvPr id="25" name="TextBox 24"/>
+          <p:cNvSpPr txBox="1"/>
+          <p:nvPr/>
+        </p:nvSpPr>
+        <p:spPr>
+          <a:xfrm>
+            <a:off x="9671151" y="1645920"/>
+            <a:ext cx="237744" cy="237744"/>
+          </a:xfrm>
+          <a:prstGeom prst="rect">
+            <a:avLst/>
+          </a:prstGeom>
+          <a:noFill/>
+        </p:spPr>
+        <p:txBody>
+          <a:bodyPr wrap="square">
+            <a:spAutoFit/>
+          </a:bodyPr>
+          <a:lstStyle/>
+          <a:p>
+            <a:pPr algn="ctr"/>
+            <a:r>
+              <a:rPr sz="1400" b="1" i="0">
+                <a:solidFill>
+                  <a:srgbClr val="C9A84C"/>
+                </a:solidFill>
+                <a:latin typeface="Barlow Condensed"/>
+              </a:rPr>
+              <a:t>→</a:t>
+            </a:r>
+          </a:p>
+        </p:txBody>
+      </p:sp>
+      <p:sp>
+        <p:nvSpPr>
+          <p:cNvPr id="26" name="Rectangle 25"/>
+          <p:cNvSpPr/>
+          <p:nvPr/>
+        </p:nvSpPr>
+        <p:spPr>
+          <a:xfrm>
+            <a:off x="9908895" y="1481328"/>
+            <a:ext cx="1609344" cy="548640"/>
+          </a:xfrm>
+          <a:prstGeom prst="rect">
+            <a:avLst/>
+          </a:prstGeom>
+          <a:solidFill>
+            <a:srgbClr val="2B8A6E"/>
+          </a:solidFill>
+          <a:ln>
+            <a:noFill/>
+          </a:ln>
+        </p:spPr>
+        <p:style>
+          <a:lnRef idx="1">
+            <a:schemeClr val="accent1"/>
+          </a:lnRef>
+          <a:fillRef idx="3">
+            <a:schemeClr val="accent1"/>
+          </a:fillRef>
+          <a:effectRef idx="2">
+            <a:schemeClr val="accent1"/>
+          </a:effectRef>
+          <a:fontRef idx="minor">
+            <a:schemeClr val="lt1"/>
+          </a:fontRef>
+        </p:style>
+        <p:txBody>
+          <a:bodyPr rtlCol="0" anchor="ctr"/>
+          <a:lstStyle/>
+          <a:p>
+            <a:pPr algn="ctr"/>
+          </a:p>
+        </p:txBody>
+      </p:sp>
+      <p:sp>
+        <p:nvSpPr>
+          <p:cNvPr id="27" name="TextBox 26"/>
+          <p:cNvSpPr txBox="1"/>
+          <p:nvPr/>
+        </p:nvSpPr>
+        <p:spPr>
+          <a:xfrm>
+            <a:off x="9908895" y="1517904"/>
+            <a:ext cx="1609344" cy="201168"/>
+          </a:xfrm>
+          <a:prstGeom prst="rect">
+            <a:avLst/>
+          </a:prstGeom>
+          <a:noFill/>
+        </p:spPr>
+        <p:txBody>
+          <a:bodyPr wrap="square">
+            <a:spAutoFit/>
+          </a:bodyPr>
+          <a:lstStyle/>
+          <a:p>
+            <a:pPr algn="ctr"/>
+            <a:r>
+              <a:rPr sz="1100" b="1" i="0">
+                <a:solidFill>
+                  <a:srgbClr val="C9A84C"/>
+                </a:solidFill>
+                <a:latin typeface="Barlow Condensed"/>
+              </a:rPr>
+              <a:t>06</a:t>
+            </a:r>
+          </a:p>
+        </p:txBody>
+      </p:sp>
+      <p:sp>
+        <p:nvSpPr>
+          <p:cNvPr id="28" name="TextBox 27"/>
+          <p:cNvSpPr txBox="1"/>
+          <p:nvPr/>
+        </p:nvSpPr>
+        <p:spPr>
+          <a:xfrm>
+            <a:off x="9908895" y="1719072"/>
+            <a:ext cx="1609344" cy="292608"/>
+          </a:xfrm>
+          <a:prstGeom prst="rect">
+            <a:avLst/>
+          </a:prstGeom>
+          <a:noFill/>
+        </p:spPr>
+        <p:txBody>
+          <a:bodyPr wrap="square">
+            <a:spAutoFit/>
+          </a:bodyPr>
+          <a:lstStyle/>
+          <a:p>
+            <a:pPr algn="ctr"/>
+            <a:r>
+              <a:rPr sz="900" b="0" i="0">
+                <a:solidFill>
+                  <a:srgbClr val="FFFFFF"/>
+                </a:solidFill>
+                <a:latin typeface="Barlow Condensed"/>
+              </a:rPr>
+              <a:t>Response
+Deploys</a:t>
+            </a:r>
+          </a:p>
+        </p:txBody>
+      </p:sp>
+      <p:sp>
+        <p:nvSpPr>
+          <p:cNvPr id="29" name="TextBox 28"/>
+          <p:cNvSpPr txBox="1"/>
+          <p:nvPr/>
+        </p:nvSpPr>
+        <p:spPr>
+          <a:xfrm>
+            <a:off x="9908895" y="1517904"/>
+            <a:ext cx="1609344" cy="548640"/>
+          </a:xfrm>
+          <a:prstGeom prst="rect">
+            <a:avLst/>
+          </a:prstGeom>
+          <a:noFill/>
+        </p:spPr>
+        <p:txBody>
+          <a:bodyPr wrap="square">
+            <a:spAutoFit/>
+          </a:bodyPr>
+          <a:lstStyle/>
+          <a:p>
+            <a:pPr algn="ctr"/>
+            <a:r>
+              <a:rPr sz="900" b="1" i="0">
+                <a:solidFill>
+                  <a:srgbClr val="FFFFFF"/>
+                </a:solidFill>
+                <a:latin typeface="Barlow Condensed"/>
+              </a:rPr>
+              <a:t>12 MIN
+END-TO-END</a:t>
+            </a:r>
+          </a:p>
+        </p:txBody>
+      </p:sp>
       <p:pic>
         <p:nvPicPr>
-          <p:cNvPr id="6" name="Picture 5" descr="signals-raw.png"/>
+          <p:cNvPr id="30" name="Picture 29" descr="signals-raw.png"/>
           <p:cNvPicPr>
             <a:picLocks noChangeAspect="1"/>
           </p:cNvPicPr>
@@ -9790,7 +10720,7 @@
         </p:blipFill>
         <p:spPr>
           <a:xfrm>
-            <a:off x="329184" y="1481328"/>
+            <a:off x="329184" y="2176272"/>
             <a:ext cx="5623560" cy="3162857"/>
           </a:xfrm>
           <a:prstGeom prst="rect">
@@ -9800,13 +10730,13 @@
       </p:pic>
       <p:sp>
         <p:nvSpPr>
-          <p:cNvPr id="7" name="Rectangle 6"/>
+          <p:cNvPr id="31" name="Rectangle 30"/>
           <p:cNvSpPr/>
           <p:nvPr/>
         </p:nvSpPr>
         <p:spPr>
           <a:xfrm>
-            <a:off x="329184" y="1481328"/>
+            <a:off x="329184" y="2176272"/>
             <a:ext cx="5623560" cy="3162857"/>
           </a:xfrm>
           <a:prstGeom prst="rect">
@@ -9843,13 +10773,13 @@
       </p:sp>
       <p:sp>
         <p:nvSpPr>
-          <p:cNvPr id="8" name="Rectangle 7"/>
+          <p:cNvPr id="32" name="Rectangle 31"/>
           <p:cNvSpPr/>
           <p:nvPr/>
         </p:nvSpPr>
         <p:spPr>
           <a:xfrm>
-            <a:off x="329184" y="4406441"/>
+            <a:off x="329184" y="5101385"/>
             <a:ext cx="5623560" cy="237744"/>
           </a:xfrm>
           <a:prstGeom prst="rect">
@@ -9886,13 +10816,13 @@
       </p:sp>
       <p:sp>
         <p:nvSpPr>
-          <p:cNvPr id="9" name="TextBox 8"/>
-          <p:cNvSpPr txBox="1"/>
-          <p:nvPr/>
-        </p:nvSpPr>
-        <p:spPr>
-          <a:xfrm>
-            <a:off x="420624" y="4469941"/>
+          <p:cNvPr id="33" name="TextBox 32"/>
+          <p:cNvSpPr txBox="1"/>
+          <p:nvPr/>
+        </p:nvSpPr>
+        <p:spPr>
+          <a:xfrm>
+            <a:off x="420624" y="5164885"/>
             <a:ext cx="5440680" cy="237744"/>
           </a:xfrm>
           <a:prstGeom prst="rect">
@@ -9921,7 +10851,7 @@
       </p:sp>
       <p:pic>
         <p:nvPicPr>
-          <p:cNvPr id="10" name="Picture 9" descr="builder-raw.png"/>
+          <p:cNvPr id="34" name="Picture 33" descr="builder-raw.png"/>
           <p:cNvPicPr>
             <a:picLocks noChangeAspect="1"/>
           </p:cNvPicPr>
@@ -9936,7 +10866,7 @@
         </p:blipFill>
         <p:spPr>
           <a:xfrm>
-            <a:off x="6227064" y="1481328"/>
+            <a:off x="6227064" y="2176272"/>
             <a:ext cx="5635447" cy="3162857"/>
           </a:xfrm>
           <a:prstGeom prst="rect">
@@ -9946,13 +10876,13 @@
       </p:pic>
       <p:sp>
         <p:nvSpPr>
-          <p:cNvPr id="11" name="Rectangle 10"/>
+          <p:cNvPr id="35" name="Rectangle 34"/>
           <p:cNvSpPr/>
           <p:nvPr/>
         </p:nvSpPr>
         <p:spPr>
           <a:xfrm>
-            <a:off x="6227064" y="1481328"/>
+            <a:off x="6227064" y="2176272"/>
             <a:ext cx="5635447" cy="3162857"/>
           </a:xfrm>
           <a:prstGeom prst="rect">
@@ -9989,13 +10919,13 @@
       </p:sp>
       <p:sp>
         <p:nvSpPr>
-          <p:cNvPr id="12" name="Rectangle 11"/>
+          <p:cNvPr id="36" name="Rectangle 35"/>
           <p:cNvSpPr/>
           <p:nvPr/>
         </p:nvSpPr>
         <p:spPr>
           <a:xfrm>
-            <a:off x="6227064" y="4406441"/>
+            <a:off x="6227064" y="5101385"/>
             <a:ext cx="5635447" cy="237744"/>
           </a:xfrm>
           <a:prstGeom prst="rect">
@@ -10032,13 +10962,13 @@
       </p:sp>
       <p:sp>
         <p:nvSpPr>
-          <p:cNvPr id="13" name="TextBox 12"/>
-          <p:cNvSpPr txBox="1"/>
-          <p:nvPr/>
-        </p:nvSpPr>
-        <p:spPr>
-          <a:xfrm>
-            <a:off x="6318504" y="4469941"/>
+          <p:cNvPr id="37" name="TextBox 36"/>
+          <p:cNvSpPr txBox="1"/>
+          <p:nvPr/>
+        </p:nvSpPr>
+        <p:spPr>
+          <a:xfrm>
+            <a:off x="6318504" y="5164885"/>
             <a:ext cx="5452567" cy="237744"/>
           </a:xfrm>
           <a:prstGeom prst="rect">
@@ -10067,14 +10997,14 @@
       </p:sp>
       <p:sp>
         <p:nvSpPr>
-          <p:cNvPr id="14" name="Rectangle 13"/>
+          <p:cNvPr id="38" name="Rectangle 37"/>
           <p:cNvSpPr/>
           <p:nvPr/>
         </p:nvSpPr>
         <p:spPr>
           <a:xfrm>
-            <a:off x="0" y="4753913"/>
-            <a:ext cx="12191695" cy="1957782"/>
+            <a:off x="0" y="5448857"/>
+            <a:ext cx="12191695" cy="1262838"/>
           </a:xfrm>
           <a:prstGeom prst="rect">
             <a:avLst/>
@@ -10110,13 +11040,13 @@
       </p:sp>
       <p:sp>
         <p:nvSpPr>
-          <p:cNvPr id="15" name="TextBox 14"/>
-          <p:cNvSpPr txBox="1"/>
-          <p:nvPr/>
-        </p:nvSpPr>
-        <p:spPr>
-          <a:xfrm>
-            <a:off x="457200" y="4845353"/>
+          <p:cNvPr id="39" name="TextBox 38"/>
+          <p:cNvSpPr txBox="1"/>
+          <p:nvPr/>
+        </p:nvSpPr>
+        <p:spPr>
+          <a:xfrm>
+            <a:off x="457200" y="5540297"/>
             <a:ext cx="11274552" cy="457200"/>
           </a:xfrm>
           <a:prstGeom prst="rect">
@@ -10145,13 +11075,13 @@
       </p:sp>
       <p:sp>
         <p:nvSpPr>
-          <p:cNvPr id="16" name="TextBox 15"/>
-          <p:cNvSpPr txBox="1"/>
-          <p:nvPr/>
-        </p:nvSpPr>
-        <p:spPr>
-          <a:xfrm>
-            <a:off x="457200" y="5393993"/>
+          <p:cNvPr id="40" name="TextBox 39"/>
+          <p:cNvSpPr txBox="1"/>
+          <p:nvPr/>
+        </p:nvSpPr>
+        <p:spPr>
+          <a:xfrm>
+            <a:off x="457200" y="6088937"/>
             <a:ext cx="11274552" cy="274320"/>
           </a:xfrm>
           <a:prstGeom prst="rect">
@@ -10180,7 +11110,7 @@
       </p:sp>
       <p:sp>
         <p:nvSpPr>
-          <p:cNvPr id="17" name="TextBox 16"/>
+          <p:cNvPr id="41" name="TextBox 40"/>
           <p:cNvSpPr txBox="1"/>
           <p:nvPr/>
         </p:nvSpPr>
@@ -10759,7 +11689,7 @@
         <p:spPr>
           <a:xfrm>
             <a:off x="6693408" y="2743200"/>
-            <a:ext cx="5084064" cy="694944"/>
+            <a:ext cx="5084064" cy="841248"/>
           </a:xfrm>
           <a:prstGeom prst="rect">
             <a:avLst/>
@@ -10780,8 +11710,8 @@
                 </a:solidFill>
                 <a:latin typeface="Barlow Condensed"/>
               </a:rPr>
-              <a:t>Replaces the $400K–$800K consulting retainer.
-Break-even before the 2nd activation.</a:t>
+              <a:t>Full platform deployment — 170 protocols configured, signals live, team onboarded.
+Replaces the $400K–$800K consulting retainer. Break-even before the 2nd activation.</a:t>
             </a:r>
           </a:p>
         </p:txBody>

</xml_diff>

<commit_message>
Fix text overlap issue on slide six timeline
Adjusted slide 6 timeline by modifying the step text to include the 12-minute duration and removed the redundant overlay badge.

Replit-Commit-Author: Agent
Replit-Commit-Session-Id: 85f09f3c-352d-446d-b98e-3f307c26fc5a
Replit-Commit-Checkpoint-Type: full_checkpoint
Replit-Commit-Event-Id: b188d059-6219-471f-aaa4-65201fc0de96
Replit-Commit-Screenshot-Url: https://storage.googleapis.com/screenshot-production-us-central1/3bd53afc-ff4f-401b-9e3d-b367791ef629/85f09f3c-352d-446d-b98e-3f307c26fc5a/dDieS6H
Replit-Helium-Checkpoint-Created: true
</commit_message>
<xml_diff>
--- a/attached_assets/VaughnMartin-Investor-Pitch-Deck-v10.pptx
+++ b/attached_assets/VaughnMartin-Investor-Pitch-Deck-v10.pptx
@@ -10662,50 +10662,15 @@
                 <a:latin typeface="Barlow Condensed"/>
               </a:rPr>
               <a:t>Response
-Deploys</a:t>
-            </a:r>
-          </a:p>
-        </p:txBody>
-      </p:sp>
-      <p:sp>
-        <p:nvSpPr>
-          <p:cNvPr id="29" name="TextBox 28"/>
-          <p:cNvSpPr txBox="1"/>
-          <p:nvPr/>
-        </p:nvSpPr>
-        <p:spPr>
-          <a:xfrm>
-            <a:off x="9908895" y="1517904"/>
-            <a:ext cx="1609344" cy="548640"/>
-          </a:xfrm>
-          <a:prstGeom prst="rect">
-            <a:avLst/>
-          </a:prstGeom>
-          <a:noFill/>
-        </p:spPr>
-        <p:txBody>
-          <a:bodyPr wrap="square">
-            <a:spAutoFit/>
-          </a:bodyPr>
-          <a:lstStyle/>
-          <a:p>
-            <a:pPr algn="ctr"/>
-            <a:r>
-              <a:rPr sz="900" b="1" i="0">
-                <a:solidFill>
-                  <a:srgbClr val="FFFFFF"/>
-                </a:solidFill>
-                <a:latin typeface="Barlow Condensed"/>
-              </a:rPr>
-              <a:t>12 MIN
-END-TO-END</a:t>
+Deploys
+· 12 MIN ·</a:t>
             </a:r>
           </a:p>
         </p:txBody>
       </p:sp>
       <p:pic>
         <p:nvPicPr>
-          <p:cNvPr id="30" name="Picture 29" descr="signals-raw.png"/>
+          <p:cNvPr id="29" name="Picture 28" descr="signals-raw.png"/>
           <p:cNvPicPr>
             <a:picLocks noChangeAspect="1"/>
           </p:cNvPicPr>
@@ -10730,7 +10695,7 @@
       </p:pic>
       <p:sp>
         <p:nvSpPr>
-          <p:cNvPr id="31" name="Rectangle 30"/>
+          <p:cNvPr id="30" name="Rectangle 29"/>
           <p:cNvSpPr/>
           <p:nvPr/>
         </p:nvSpPr>
@@ -10773,7 +10738,7 @@
       </p:sp>
       <p:sp>
         <p:nvSpPr>
-          <p:cNvPr id="32" name="Rectangle 31"/>
+          <p:cNvPr id="31" name="Rectangle 30"/>
           <p:cNvSpPr/>
           <p:nvPr/>
         </p:nvSpPr>
@@ -10816,7 +10781,7 @@
       </p:sp>
       <p:sp>
         <p:nvSpPr>
-          <p:cNvPr id="33" name="TextBox 32"/>
+          <p:cNvPr id="32" name="TextBox 31"/>
           <p:cNvSpPr txBox="1"/>
           <p:nvPr/>
         </p:nvSpPr>
@@ -10851,7 +10816,7 @@
       </p:sp>
       <p:pic>
         <p:nvPicPr>
-          <p:cNvPr id="34" name="Picture 33" descr="builder-raw.png"/>
+          <p:cNvPr id="33" name="Picture 32" descr="builder-raw.png"/>
           <p:cNvPicPr>
             <a:picLocks noChangeAspect="1"/>
           </p:cNvPicPr>
@@ -10876,7 +10841,7 @@
       </p:pic>
       <p:sp>
         <p:nvSpPr>
-          <p:cNvPr id="35" name="Rectangle 34"/>
+          <p:cNvPr id="34" name="Rectangle 33"/>
           <p:cNvSpPr/>
           <p:nvPr/>
         </p:nvSpPr>
@@ -10919,7 +10884,7 @@
       </p:sp>
       <p:sp>
         <p:nvSpPr>
-          <p:cNvPr id="36" name="Rectangle 35"/>
+          <p:cNvPr id="35" name="Rectangle 34"/>
           <p:cNvSpPr/>
           <p:nvPr/>
         </p:nvSpPr>
@@ -10962,7 +10927,7 @@
       </p:sp>
       <p:sp>
         <p:nvSpPr>
-          <p:cNvPr id="37" name="TextBox 36"/>
+          <p:cNvPr id="36" name="TextBox 35"/>
           <p:cNvSpPr txBox="1"/>
           <p:nvPr/>
         </p:nvSpPr>
@@ -10997,7 +10962,7 @@
       </p:sp>
       <p:sp>
         <p:nvSpPr>
-          <p:cNvPr id="38" name="Rectangle 37"/>
+          <p:cNvPr id="37" name="Rectangle 36"/>
           <p:cNvSpPr/>
           <p:nvPr/>
         </p:nvSpPr>
@@ -11040,7 +11005,7 @@
       </p:sp>
       <p:sp>
         <p:nvSpPr>
-          <p:cNvPr id="39" name="TextBox 38"/>
+          <p:cNvPr id="38" name="TextBox 37"/>
           <p:cNvSpPr txBox="1"/>
           <p:nvPr/>
         </p:nvSpPr>
@@ -11075,7 +11040,7 @@
       </p:sp>
       <p:sp>
         <p:nvSpPr>
-          <p:cNvPr id="40" name="TextBox 39"/>
+          <p:cNvPr id="39" name="TextBox 38"/>
           <p:cNvSpPr txBox="1"/>
           <p:nvPr/>
         </p:nvSpPr>
@@ -11110,7 +11075,7 @@
       </p:sp>
       <p:sp>
         <p:nvSpPr>
-          <p:cNvPr id="41" name="TextBox 40"/>
+          <p:cNvPr id="40" name="TextBox 39"/>
           <p:cNvSpPr txBox="1"/>
           <p:nvPr/>
         </p:nvSpPr>

</xml_diff>

<commit_message>
Add founder's story to the investor pitch deck
Updated the investor pitch deck to include founder credentials on "The Ask" slide by adjusting heading dimensions and adding attribution text.

Replit-Commit-Author: Agent
Replit-Commit-Session-Id: 85f09f3c-352d-446d-b98e-3f307c26fc5a
Replit-Commit-Checkpoint-Type: full_checkpoint
Replit-Commit-Event-Id: c52da3f4-5b8c-4630-911e-41f9468eda83
Replit-Commit-Screenshot-Url: https://storage.googleapis.com/screenshot-production-us-central1/3bd53afc-ff4f-401b-9e3d-b367791ef629/85f09f3c-352d-446d-b98e-3f307c26fc5a/yZH2El0
Replit-Helium-Checkpoint-Created: true
</commit_message>
<xml_diff>
--- a/attached_assets/VaughnMartin-Investor-Pitch-Deck-v10.pptx
+++ b/attached_assets/VaughnMartin-Investor-Pitch-Deck-v10.pptx
@@ -3959,7 +3959,7 @@
         <p:spPr>
           <a:xfrm>
             <a:off x="329184" y="950976"/>
-            <a:ext cx="8686800" cy="731520"/>
+            <a:ext cx="8686800" cy="621792"/>
           </a:xfrm>
           <a:prstGeom prst="rect">
             <a:avLst/>
@@ -3974,7 +3974,7 @@
           <a:p>
             <a:pPr algn="l"/>
             <a:r>
-              <a:rPr sz="2800" b="1">
+              <a:rPr sz="2600" b="1">
                 <a:solidFill>
                   <a:srgbClr val="FFFFFF"/>
                 </a:solidFill>
@@ -3987,13 +3987,48 @@
       </p:sp>
       <p:sp>
         <p:nvSpPr>
-          <p:cNvPr id="6" name="Rectangle 5"/>
+          <p:cNvPr id="6" name="TextBox 5"/>
+          <p:cNvSpPr txBox="1"/>
+          <p:nvPr/>
+        </p:nvSpPr>
+        <p:spPr>
+          <a:xfrm>
+            <a:off x="329184" y="1591056"/>
+            <a:ext cx="8686800" cy="164592"/>
+          </a:xfrm>
+          <a:prstGeom prst="rect">
+            <a:avLst/>
+          </a:prstGeom>
+          <a:noFill/>
+        </p:spPr>
+        <p:txBody>
+          <a:bodyPr wrap="square">
+            <a:spAutoFit/>
+          </a:bodyPr>
+          <a:lstStyle/>
+          <a:p>
+            <a:pPr algn="l"/>
+            <a:r>
+              <a:rPr sz="1000" b="0" i="1">
+                <a:solidFill>
+                  <a:srgbClr val="C9A84C"/>
+                </a:solidFill>
+                <a:latin typeface="Barlow Condensed"/>
+              </a:rPr>
+              <a:t>Martin Brunke, Founder  ·  20 years inside enterprise organizations  ·  5 years on a major college football sideline</a:t>
+            </a:r>
+          </a:p>
+        </p:txBody>
+      </p:sp>
+      <p:sp>
+        <p:nvSpPr>
+          <p:cNvPr id="7" name="Rectangle 6"/>
           <p:cNvSpPr/>
           <p:nvPr/>
         </p:nvSpPr>
         <p:spPr>
           <a:xfrm>
-            <a:off x="329184" y="1737360"/>
+            <a:off x="329184" y="1792224"/>
             <a:ext cx="11530584" cy="19050"/>
           </a:xfrm>
           <a:prstGeom prst="rect">
@@ -4030,7 +4065,7 @@
       </p:sp>
       <p:sp>
         <p:nvSpPr>
-          <p:cNvPr id="7" name="Rectangle 6"/>
+          <p:cNvPr id="8" name="Rectangle 7"/>
           <p:cNvSpPr/>
           <p:nvPr/>
         </p:nvSpPr>
@@ -4073,7 +4108,7 @@
       </p:sp>
       <p:sp>
         <p:nvSpPr>
-          <p:cNvPr id="8" name="TextBox 7"/>
+          <p:cNvPr id="9" name="TextBox 8"/>
           <p:cNvSpPr txBox="1"/>
           <p:nvPr/>
         </p:nvSpPr>
@@ -4108,7 +4143,7 @@
       </p:sp>
       <p:sp>
         <p:nvSpPr>
-          <p:cNvPr id="9" name="TextBox 8"/>
+          <p:cNvPr id="10" name="TextBox 9"/>
           <p:cNvSpPr txBox="1"/>
           <p:nvPr/>
         </p:nvSpPr>
@@ -4144,7 +4179,7 @@
       </p:sp>
       <p:sp>
         <p:nvSpPr>
-          <p:cNvPr id="10" name="Rectangle 9"/>
+          <p:cNvPr id="11" name="Rectangle 10"/>
           <p:cNvSpPr/>
           <p:nvPr/>
         </p:nvSpPr>
@@ -4187,7 +4222,7 @@
       </p:sp>
       <p:sp>
         <p:nvSpPr>
-          <p:cNvPr id="11" name="TextBox 10"/>
+          <p:cNvPr id="12" name="TextBox 11"/>
           <p:cNvSpPr txBox="1"/>
           <p:nvPr/>
         </p:nvSpPr>
@@ -4222,7 +4257,7 @@
       </p:sp>
       <p:sp>
         <p:nvSpPr>
-          <p:cNvPr id="12" name="TextBox 11"/>
+          <p:cNvPr id="13" name="TextBox 12"/>
           <p:cNvSpPr txBox="1"/>
           <p:nvPr/>
         </p:nvSpPr>
@@ -4258,7 +4293,7 @@
       </p:sp>
       <p:sp>
         <p:nvSpPr>
-          <p:cNvPr id="13" name="Rectangle 12"/>
+          <p:cNvPr id="14" name="Rectangle 13"/>
           <p:cNvSpPr/>
           <p:nvPr/>
         </p:nvSpPr>
@@ -4301,7 +4336,7 @@
       </p:sp>
       <p:sp>
         <p:nvSpPr>
-          <p:cNvPr id="14" name="TextBox 13"/>
+          <p:cNvPr id="15" name="TextBox 14"/>
           <p:cNvSpPr txBox="1"/>
           <p:nvPr/>
         </p:nvSpPr>
@@ -4336,7 +4371,7 @@
       </p:sp>
       <p:sp>
         <p:nvSpPr>
-          <p:cNvPr id="15" name="TextBox 14"/>
+          <p:cNvPr id="16" name="TextBox 15"/>
           <p:cNvSpPr txBox="1"/>
           <p:nvPr/>
         </p:nvSpPr>
@@ -4372,7 +4407,7 @@
       </p:sp>
       <p:sp>
         <p:nvSpPr>
-          <p:cNvPr id="16" name="TextBox 15"/>
+          <p:cNvPr id="17" name="TextBox 16"/>
           <p:cNvSpPr txBox="1"/>
           <p:nvPr/>
         </p:nvSpPr>
@@ -4407,7 +4442,7 @@
       </p:sp>
       <p:sp>
         <p:nvSpPr>
-          <p:cNvPr id="17" name="Rectangle 16"/>
+          <p:cNvPr id="18" name="Rectangle 17"/>
           <p:cNvSpPr/>
           <p:nvPr/>
         </p:nvSpPr>
@@ -4450,7 +4485,7 @@
       </p:sp>
       <p:sp>
         <p:nvSpPr>
-          <p:cNvPr id="18" name="TextBox 17"/>
+          <p:cNvPr id="19" name="TextBox 18"/>
           <p:cNvSpPr txBox="1"/>
           <p:nvPr/>
         </p:nvSpPr>
@@ -4485,7 +4520,7 @@
       </p:sp>
       <p:sp>
         <p:nvSpPr>
-          <p:cNvPr id="19" name="TextBox 18"/>
+          <p:cNvPr id="20" name="TextBox 19"/>
           <p:cNvSpPr txBox="1"/>
           <p:nvPr/>
         </p:nvSpPr>
@@ -4520,7 +4555,7 @@
       </p:sp>
       <p:sp>
         <p:nvSpPr>
-          <p:cNvPr id="20" name="Rectangle 19"/>
+          <p:cNvPr id="21" name="Rectangle 20"/>
           <p:cNvSpPr/>
           <p:nvPr/>
         </p:nvSpPr>
@@ -4563,7 +4598,7 @@
       </p:sp>
       <p:sp>
         <p:nvSpPr>
-          <p:cNvPr id="21" name="TextBox 20"/>
+          <p:cNvPr id="22" name="TextBox 21"/>
           <p:cNvSpPr txBox="1"/>
           <p:nvPr/>
         </p:nvSpPr>
@@ -4598,7 +4633,7 @@
       </p:sp>
       <p:sp>
         <p:nvSpPr>
-          <p:cNvPr id="22" name="TextBox 21"/>
+          <p:cNvPr id="23" name="TextBox 22"/>
           <p:cNvSpPr txBox="1"/>
           <p:nvPr/>
         </p:nvSpPr>
@@ -4633,7 +4668,7 @@
       </p:sp>
       <p:sp>
         <p:nvSpPr>
-          <p:cNvPr id="23" name="Rectangle 22"/>
+          <p:cNvPr id="24" name="Rectangle 23"/>
           <p:cNvSpPr/>
           <p:nvPr/>
         </p:nvSpPr>
@@ -4676,7 +4711,7 @@
       </p:sp>
       <p:sp>
         <p:nvSpPr>
-          <p:cNvPr id="24" name="TextBox 23"/>
+          <p:cNvPr id="25" name="TextBox 24"/>
           <p:cNvSpPr txBox="1"/>
           <p:nvPr/>
         </p:nvSpPr>
@@ -4711,7 +4746,7 @@
       </p:sp>
       <p:sp>
         <p:nvSpPr>
-          <p:cNvPr id="25" name="TextBox 24"/>
+          <p:cNvPr id="26" name="TextBox 25"/>
           <p:cNvSpPr txBox="1"/>
           <p:nvPr/>
         </p:nvSpPr>
@@ -4746,7 +4781,7 @@
       </p:sp>
       <p:sp>
         <p:nvSpPr>
-          <p:cNvPr id="26" name="Rectangle 25"/>
+          <p:cNvPr id="27" name="Rectangle 26"/>
           <p:cNvSpPr/>
           <p:nvPr/>
         </p:nvSpPr>
@@ -4791,7 +4826,7 @@
       </p:sp>
       <p:sp>
         <p:nvSpPr>
-          <p:cNvPr id="27" name="TextBox 26"/>
+          <p:cNvPr id="28" name="TextBox 27"/>
           <p:cNvSpPr txBox="1"/>
           <p:nvPr/>
         </p:nvSpPr>
@@ -4826,7 +4861,7 @@
       </p:sp>
       <p:sp>
         <p:nvSpPr>
-          <p:cNvPr id="28" name="Rectangle 27"/>
+          <p:cNvPr id="29" name="Rectangle 28"/>
           <p:cNvSpPr/>
           <p:nvPr/>
         </p:nvSpPr>
@@ -4869,7 +4904,7 @@
       </p:sp>
       <p:pic>
         <p:nvPicPr>
-          <p:cNvPr id="29" name="Picture 28" descr="home-raw.png"/>
+          <p:cNvPr id="30" name="Picture 29" descr="home-raw.png"/>
           <p:cNvPicPr>
             <a:picLocks noChangeAspect="1"/>
           </p:cNvPicPr>
@@ -4894,7 +4929,7 @@
       </p:pic>
       <p:sp>
         <p:nvSpPr>
-          <p:cNvPr id="30" name="Rectangle 29"/>
+          <p:cNvPr id="31" name="Rectangle 30"/>
           <p:cNvSpPr/>
           <p:nvPr/>
         </p:nvSpPr>
@@ -4937,7 +4972,7 @@
       </p:sp>
       <p:sp>
         <p:nvSpPr>
-          <p:cNvPr id="31" name="Rectangle 30"/>
+          <p:cNvPr id="32" name="Rectangle 31"/>
           <p:cNvSpPr/>
           <p:nvPr/>
         </p:nvSpPr>
@@ -4980,7 +5015,7 @@
       </p:sp>
       <p:sp>
         <p:nvSpPr>
-          <p:cNvPr id="32" name="TextBox 31"/>
+          <p:cNvPr id="33" name="TextBox 32"/>
           <p:cNvSpPr txBox="1"/>
           <p:nvPr/>
         </p:nvSpPr>
@@ -5015,7 +5050,7 @@
       </p:sp>
       <p:sp>
         <p:nvSpPr>
-          <p:cNvPr id="33" name="Rectangle 32"/>
+          <p:cNvPr id="34" name="Rectangle 33"/>
           <p:cNvSpPr/>
           <p:nvPr/>
         </p:nvSpPr>
@@ -5058,7 +5093,7 @@
       </p:sp>
       <p:sp>
         <p:nvSpPr>
-          <p:cNvPr id="34" name="TextBox 33"/>
+          <p:cNvPr id="35" name="TextBox 34"/>
           <p:cNvSpPr txBox="1"/>
           <p:nvPr/>
         </p:nvSpPr>
@@ -5093,7 +5128,7 @@
       </p:sp>
       <p:sp>
         <p:nvSpPr>
-          <p:cNvPr id="35" name="TextBox 34"/>
+          <p:cNvPr id="36" name="TextBox 35"/>
           <p:cNvSpPr txBox="1"/>
           <p:nvPr/>
         </p:nvSpPr>
@@ -5128,7 +5163,7 @@
       </p:sp>
       <p:sp>
         <p:nvSpPr>
-          <p:cNvPr id="36" name="Rectangle 35"/>
+          <p:cNvPr id="37" name="Rectangle 36"/>
           <p:cNvSpPr/>
           <p:nvPr/>
         </p:nvSpPr>
@@ -5171,7 +5206,7 @@
       </p:sp>
       <p:sp>
         <p:nvSpPr>
-          <p:cNvPr id="37" name="TextBox 36"/>
+          <p:cNvPr id="38" name="TextBox 37"/>
           <p:cNvSpPr txBox="1"/>
           <p:nvPr/>
         </p:nvSpPr>
@@ -5206,7 +5241,7 @@
       </p:sp>
       <p:sp>
         <p:nvSpPr>
-          <p:cNvPr id="38" name="TextBox 37"/>
+          <p:cNvPr id="39" name="TextBox 38"/>
           <p:cNvSpPr txBox="1"/>
           <p:nvPr/>
         </p:nvSpPr>
@@ -5241,7 +5276,7 @@
       </p:sp>
       <p:sp>
         <p:nvSpPr>
-          <p:cNvPr id="39" name="Rectangle 38"/>
+          <p:cNvPr id="40" name="Rectangle 39"/>
           <p:cNvSpPr/>
           <p:nvPr/>
         </p:nvSpPr>
@@ -5284,7 +5319,7 @@
       </p:sp>
       <p:sp>
         <p:nvSpPr>
-          <p:cNvPr id="40" name="TextBox 39"/>
+          <p:cNvPr id="41" name="TextBox 40"/>
           <p:cNvSpPr txBox="1"/>
           <p:nvPr/>
         </p:nvSpPr>
@@ -5319,7 +5354,7 @@
       </p:sp>
       <p:sp>
         <p:nvSpPr>
-          <p:cNvPr id="41" name="TextBox 40"/>
+          <p:cNvPr id="42" name="TextBox 41"/>
           <p:cNvSpPr txBox="1"/>
           <p:nvPr/>
         </p:nvSpPr>
@@ -5354,7 +5389,7 @@
       </p:sp>
       <p:sp>
         <p:nvSpPr>
-          <p:cNvPr id="42" name="Rectangle 41"/>
+          <p:cNvPr id="43" name="Rectangle 42"/>
           <p:cNvSpPr/>
           <p:nvPr/>
         </p:nvSpPr>
@@ -5397,7 +5432,7 @@
       </p:sp>
       <p:sp>
         <p:nvSpPr>
-          <p:cNvPr id="43" name="TextBox 42"/>
+          <p:cNvPr id="44" name="TextBox 43"/>
           <p:cNvSpPr txBox="1"/>
           <p:nvPr/>
         </p:nvSpPr>
@@ -5432,7 +5467,7 @@
       </p:sp>
       <p:sp>
         <p:nvSpPr>
-          <p:cNvPr id="44" name="TextBox 43"/>
+          <p:cNvPr id="45" name="TextBox 44"/>
           <p:cNvSpPr txBox="1"/>
           <p:nvPr/>
         </p:nvSpPr>
@@ -5467,7 +5502,7 @@
       </p:sp>
       <p:sp>
         <p:nvSpPr>
-          <p:cNvPr id="45" name="TextBox 44"/>
+          <p:cNvPr id="46" name="TextBox 45"/>
           <p:cNvSpPr txBox="1"/>
           <p:nvPr/>
         </p:nvSpPr>

</xml_diff>

<commit_message>
Restore visual flow of presentation by updating slide 9 theme
Update presentation slide 9 from an ivory background to dark navy, matching the rest of the deck, and adjust text colors for better contrast.

Replit-Commit-Author: Agent
Replit-Commit-Session-Id: 85f09f3c-352d-446d-b98e-3f307c26fc5a
Replit-Commit-Checkpoint-Type: full_checkpoint
Replit-Commit-Event-Id: 0eee8b59-599a-4207-9601-8694cfb97bf2
Replit-Commit-Screenshot-Url: https://storage.googleapis.com/screenshot-production-us-central1/3bd53afc-ff4f-401b-9e3d-b367791ef629/85f09f3c-352d-446d-b98e-3f307c26fc5a/yZH2El0
Replit-Helium-Checkpoint-Created: true
</commit_message>
<xml_diff>
--- a/attached_assets/VaughnMartin-Investor-Pitch-Deck-v10.pptx
+++ b/attached_assets/VaughnMartin-Investor-Pitch-Deck-v10.pptx
@@ -13272,7 +13272,7 @@
     <p:bg>
       <p:bgPr>
         <a:solidFill>
-          <a:srgbClr val="F2F0EB"/>
+          <a:srgbClr val="0A0F2E"/>
         </a:solidFill>
         <a:effectLst/>
       </p:bgPr>
@@ -13566,7 +13566,7 @@
             <a:r>
               <a:rPr sz="900" b="1" i="0">
                 <a:solidFill>
-                  <a:srgbClr val="444A68"/>
+                  <a:srgbClr val="C9A84C"/>
                 </a:solidFill>
                 <a:latin typeface="Barlow Condensed"/>
               </a:rPr>
@@ -13601,7 +13601,7 @@
             <a:r>
               <a:rPr sz="2600" b="1">
                 <a:solidFill>
-                  <a:srgbClr val="0A0F2E"/>
+                  <a:srgbClr val="FFFFFF"/>
                 </a:solidFill>
                 <a:latin typeface="Barlow Condensed"/>
               </a:rPr>
@@ -13625,7 +13625,7 @@
             <a:avLst/>
           </a:prstGeom>
           <a:solidFill>
-            <a:srgbClr val="887850"/>
+            <a:srgbClr val="C9A84C"/>
           </a:solidFill>
           <a:ln>
             <a:noFill/>
@@ -13714,7 +13714,7 @@
             <a:r>
               <a:rPr sz="1500" b="0" i="0">
                 <a:solidFill>
-                  <a:srgbClr val="0A0F2E"/>
+                  <a:srgbClr val="FFFFFF"/>
                 </a:solidFill>
                 <a:latin typeface="Barlow Condensed"/>
               </a:rPr>
@@ -13784,7 +13784,7 @@
             <a:r>
               <a:rPr sz="1500" b="0" i="0">
                 <a:solidFill>
-                  <a:srgbClr val="0A0F2E"/>
+                  <a:srgbClr val="FFFFFF"/>
                 </a:solidFill>
                 <a:latin typeface="Barlow Condensed"/>
               </a:rPr>
@@ -13854,7 +13854,7 @@
             <a:r>
               <a:rPr sz="1500" b="0" i="0">
                 <a:solidFill>
-                  <a:srgbClr val="0A0F2E"/>
+                  <a:srgbClr val="FFFFFF"/>
                 </a:solidFill>
                 <a:latin typeface="Barlow Condensed"/>
               </a:rPr>

</xml_diff>